<commit_message>
Update test sample data files
Replace binary test fixtures tests/sample_data/participants.xlsx and tests/sample_data/template.pptx with updated versions. Updates sample participant data and presentation template used by the test suite.
</commit_message>
<xml_diff>
--- a/tests/sample_data/template.pptx
+++ b/tests/sample_data/template.pptx
@@ -5,18 +5,19 @@
     <p:sldMasterId id="2147483648" r:id="rId1"/>
   </p:sldMasterIdLst>
   <p:sldIdLst>
-    <p:sldId id="256" r:id="rId7"/>
-    <p:sldId id="257" r:id="rId8"/>
-    <p:sldId id="258" r:id="rId9"/>
-    <p:sldId id="259" r:id="rId10"/>
-    <p:sldId id="260" r:id="rId11"/>
-    <p:sldId id="261" r:id="rId12"/>
-    <p:sldId id="262" r:id="rId13"/>
-    <p:sldId id="263" r:id="rId14"/>
-    <p:sldId id="264" r:id="rId15"/>
-    <p:sldId id="265" r:id="rId16"/>
-    <p:sldId id="266" r:id="rId17"/>
-    <p:sldId id="267" r:id="rId18"/>
+    <p:sldId id="256" r:id="rId2"/>
+    <p:sldId id="268" r:id="rId3"/>
+    <p:sldId id="257" r:id="rId4"/>
+    <p:sldId id="258" r:id="rId5"/>
+    <p:sldId id="259" r:id="rId6"/>
+    <p:sldId id="260" r:id="rId7"/>
+    <p:sldId id="261" r:id="rId8"/>
+    <p:sldId id="262" r:id="rId9"/>
+    <p:sldId id="263" r:id="rId10"/>
+    <p:sldId id="264" r:id="rId11"/>
+    <p:sldId id="265" r:id="rId12"/>
+    <p:sldId id="266" r:id="rId13"/>
+    <p:sldId id="267" r:id="rId14"/>
   </p:sldIdLst>
   <p:sldSz cx="9144000" cy="6858000" type="screen4x3"/>
   <p:notesSz cx="6858000" cy="9144000"/>
@@ -115,6 +116,22 @@
       </a:defRPr>
     </a:lvl9pPr>
   </p:defaultTextStyle>
+  <p:extLst>
+    <p:ext uri="{EFAFB233-063F-42B5-8137-9DF3F51BA10A}">
+      <p15:sldGuideLst xmlns:p15="http://schemas.microsoft.com/office/powerpoint/2012/main">
+        <p15:guide id="1" orient="horz" pos="2160">
+          <p15:clr>
+            <a:srgbClr val="A4A3A4"/>
+          </p15:clr>
+        </p15:guide>
+        <p15:guide id="2" pos="2880">
+          <p15:clr>
+            <a:srgbClr val="A4A3A4"/>
+          </p15:clr>
+        </p15:guide>
+      </p15:sldGuideLst>
+    </p:ext>
+  </p:extLst>
 </p:presentation>
 </file>
 
@@ -156,10 +173,9 @@
           <a:lstStyle/>
           <a:p>
             <a:r>
-              <a:rPr lang="en-US" smtClean="0"/>
+              <a:rPr lang="en-US"/>
               <a:t>Click to edit Master title style</a:t>
             </a:r>
-            <a:endParaRPr lang="en-US"/>
           </a:p>
         </p:txBody>
       </p:sp>
@@ -275,10 +291,9 @@
           </a:lstStyle>
           <a:p>
             <a:r>
-              <a:rPr lang="en-US" smtClean="0"/>
+              <a:rPr lang="en-US"/>
               <a:t>Click to edit Master subtitle style</a:t>
             </a:r>
-            <a:endParaRPr lang="en-US"/>
           </a:p>
         </p:txBody>
       </p:sp>
@@ -299,7 +314,7 @@
           <a:p>
             <a:fld id="{5BCAD085-E8A6-8845-BD4E-CB4CCA059FC4}" type="datetimeFigureOut">
               <a:rPr lang="en-US" smtClean="0"/>
-              <a:t>1/27/13</a:t>
+              <a:t>6/22/2026</a:t>
             </a:fld>
             <a:endParaRPr lang="en-US"/>
           </a:p>
@@ -393,10 +408,9 @@
           <a:lstStyle/>
           <a:p>
             <a:r>
-              <a:rPr lang="en-US" smtClean="0"/>
+              <a:rPr lang="en-US"/>
               <a:t>Click to edit Master title style</a:t>
             </a:r>
-            <a:endParaRPr lang="en-US"/>
           </a:p>
         </p:txBody>
       </p:sp>
@@ -417,38 +431,37 @@
           <a:p>
             <a:pPr lvl="0"/>
             <a:r>
-              <a:rPr lang="en-US" smtClean="0"/>
+              <a:rPr lang="en-US"/>
               <a:t>Click to edit Master text styles</a:t>
             </a:r>
           </a:p>
           <a:p>
             <a:pPr lvl="1"/>
             <a:r>
-              <a:rPr lang="en-US" smtClean="0"/>
+              <a:rPr lang="en-US"/>
               <a:t>Second level</a:t>
             </a:r>
           </a:p>
           <a:p>
             <a:pPr lvl="2"/>
             <a:r>
-              <a:rPr lang="en-US" smtClean="0"/>
+              <a:rPr lang="en-US"/>
               <a:t>Third level</a:t>
             </a:r>
           </a:p>
           <a:p>
             <a:pPr lvl="3"/>
             <a:r>
-              <a:rPr lang="en-US" smtClean="0"/>
+              <a:rPr lang="en-US"/>
               <a:t>Fourth level</a:t>
             </a:r>
           </a:p>
           <a:p>
             <a:pPr lvl="4"/>
             <a:r>
-              <a:rPr lang="en-US" smtClean="0"/>
+              <a:rPr lang="en-US"/>
               <a:t>Fifth level</a:t>
             </a:r>
-            <a:endParaRPr lang="en-US"/>
           </a:p>
         </p:txBody>
       </p:sp>
@@ -469,7 +482,7 @@
           <a:p>
             <a:fld id="{5BCAD085-E8A6-8845-BD4E-CB4CCA059FC4}" type="datetimeFigureOut">
               <a:rPr lang="en-US" smtClean="0"/>
-              <a:t>1/27/13</a:t>
+              <a:t>6/22/2026</a:t>
             </a:fld>
             <a:endParaRPr lang="en-US"/>
           </a:p>
@@ -568,10 +581,9 @@
           <a:lstStyle/>
           <a:p>
             <a:r>
-              <a:rPr lang="en-US" smtClean="0"/>
+              <a:rPr lang="en-US"/>
               <a:t>Click to edit Master title style</a:t>
             </a:r>
-            <a:endParaRPr lang="en-US"/>
           </a:p>
         </p:txBody>
       </p:sp>
@@ -597,38 +609,37 @@
           <a:p>
             <a:pPr lvl="0"/>
             <a:r>
-              <a:rPr lang="en-US" smtClean="0"/>
+              <a:rPr lang="en-US"/>
               <a:t>Click to edit Master text styles</a:t>
             </a:r>
           </a:p>
           <a:p>
             <a:pPr lvl="1"/>
             <a:r>
-              <a:rPr lang="en-US" smtClean="0"/>
+              <a:rPr lang="en-US"/>
               <a:t>Second level</a:t>
             </a:r>
           </a:p>
           <a:p>
             <a:pPr lvl="2"/>
             <a:r>
-              <a:rPr lang="en-US" smtClean="0"/>
+              <a:rPr lang="en-US"/>
               <a:t>Third level</a:t>
             </a:r>
           </a:p>
           <a:p>
             <a:pPr lvl="3"/>
             <a:r>
-              <a:rPr lang="en-US" smtClean="0"/>
+              <a:rPr lang="en-US"/>
               <a:t>Fourth level</a:t>
             </a:r>
           </a:p>
           <a:p>
             <a:pPr lvl="4"/>
             <a:r>
-              <a:rPr lang="en-US" smtClean="0"/>
+              <a:rPr lang="en-US"/>
               <a:t>Fifth level</a:t>
             </a:r>
-            <a:endParaRPr lang="en-US"/>
           </a:p>
         </p:txBody>
       </p:sp>
@@ -649,7 +660,7 @@
           <a:p>
             <a:fld id="{5BCAD085-E8A6-8845-BD4E-CB4CCA059FC4}" type="datetimeFigureOut">
               <a:rPr lang="en-US" smtClean="0"/>
-              <a:t>1/27/13</a:t>
+              <a:t>6/22/2026</a:t>
             </a:fld>
             <a:endParaRPr lang="en-US"/>
           </a:p>
@@ -743,10 +754,9 @@
           <a:lstStyle/>
           <a:p>
             <a:r>
-              <a:rPr lang="en-US" smtClean="0"/>
+              <a:rPr lang="en-US"/>
               <a:t>Click to edit Master title style</a:t>
             </a:r>
-            <a:endParaRPr lang="en-US"/>
           </a:p>
         </p:txBody>
       </p:sp>
@@ -767,38 +777,37 @@
           <a:p>
             <a:pPr lvl="0"/>
             <a:r>
-              <a:rPr lang="en-US" smtClean="0"/>
+              <a:rPr lang="en-US"/>
               <a:t>Click to edit Master text styles</a:t>
             </a:r>
           </a:p>
           <a:p>
             <a:pPr lvl="1"/>
             <a:r>
-              <a:rPr lang="en-US" smtClean="0"/>
+              <a:rPr lang="en-US"/>
               <a:t>Second level</a:t>
             </a:r>
           </a:p>
           <a:p>
             <a:pPr lvl="2"/>
             <a:r>
-              <a:rPr lang="en-US" smtClean="0"/>
+              <a:rPr lang="en-US"/>
               <a:t>Third level</a:t>
             </a:r>
           </a:p>
           <a:p>
             <a:pPr lvl="3"/>
             <a:r>
-              <a:rPr lang="en-US" smtClean="0"/>
+              <a:rPr lang="en-US"/>
               <a:t>Fourth level</a:t>
             </a:r>
           </a:p>
           <a:p>
             <a:pPr lvl="4"/>
             <a:r>
-              <a:rPr lang="en-US" smtClean="0"/>
+              <a:rPr lang="en-US"/>
               <a:t>Fifth level</a:t>
             </a:r>
-            <a:endParaRPr lang="en-US"/>
           </a:p>
         </p:txBody>
       </p:sp>
@@ -819,7 +828,7 @@
           <a:p>
             <a:fld id="{5BCAD085-E8A6-8845-BD4E-CB4CCA059FC4}" type="datetimeFigureOut">
               <a:rPr lang="en-US" smtClean="0"/>
-              <a:t>1/27/13</a:t>
+              <a:t>6/22/2026</a:t>
             </a:fld>
             <a:endParaRPr lang="en-US"/>
           </a:p>
@@ -922,10 +931,9 @@
           </a:lstStyle>
           <a:p>
             <a:r>
-              <a:rPr lang="en-US" smtClean="0"/>
+              <a:rPr lang="en-US"/>
               <a:t>Click to edit Master title style</a:t>
             </a:r>
-            <a:endParaRPr lang="en-US"/>
           </a:p>
         </p:txBody>
       </p:sp>
@@ -1042,7 +1050,7 @@
           <a:p>
             <a:pPr lvl="0"/>
             <a:r>
-              <a:rPr lang="en-US" smtClean="0"/>
+              <a:rPr lang="en-US"/>
               <a:t>Click to edit Master text styles</a:t>
             </a:r>
           </a:p>
@@ -1065,7 +1073,7 @@
           <a:p>
             <a:fld id="{5BCAD085-E8A6-8845-BD4E-CB4CCA059FC4}" type="datetimeFigureOut">
               <a:rPr lang="en-US" smtClean="0"/>
-              <a:t>1/27/13</a:t>
+              <a:t>6/22/2026</a:t>
             </a:fld>
             <a:endParaRPr lang="en-US"/>
           </a:p>
@@ -1159,10 +1167,9 @@
           <a:lstStyle/>
           <a:p>
             <a:r>
-              <a:rPr lang="en-US" smtClean="0"/>
+              <a:rPr lang="en-US"/>
               <a:t>Click to edit Master title style</a:t>
             </a:r>
-            <a:endParaRPr lang="en-US"/>
           </a:p>
         </p:txBody>
       </p:sp>
@@ -1216,38 +1223,37 @@
           <a:p>
             <a:pPr lvl="0"/>
             <a:r>
-              <a:rPr lang="en-US" smtClean="0"/>
+              <a:rPr lang="en-US"/>
               <a:t>Click to edit Master text styles</a:t>
             </a:r>
           </a:p>
           <a:p>
             <a:pPr lvl="1"/>
             <a:r>
-              <a:rPr lang="en-US" smtClean="0"/>
+              <a:rPr lang="en-US"/>
               <a:t>Second level</a:t>
             </a:r>
           </a:p>
           <a:p>
             <a:pPr lvl="2"/>
             <a:r>
-              <a:rPr lang="en-US" smtClean="0"/>
+              <a:rPr lang="en-US"/>
               <a:t>Third level</a:t>
             </a:r>
           </a:p>
           <a:p>
             <a:pPr lvl="3"/>
             <a:r>
-              <a:rPr lang="en-US" smtClean="0"/>
+              <a:rPr lang="en-US"/>
               <a:t>Fourth level</a:t>
             </a:r>
           </a:p>
           <a:p>
             <a:pPr lvl="4"/>
             <a:r>
-              <a:rPr lang="en-US" smtClean="0"/>
+              <a:rPr lang="en-US"/>
               <a:t>Fifth level</a:t>
             </a:r>
-            <a:endParaRPr lang="en-US"/>
           </a:p>
         </p:txBody>
       </p:sp>
@@ -1301,38 +1307,37 @@
           <a:p>
             <a:pPr lvl="0"/>
             <a:r>
-              <a:rPr lang="en-US" smtClean="0"/>
+              <a:rPr lang="en-US"/>
               <a:t>Click to edit Master text styles</a:t>
             </a:r>
           </a:p>
           <a:p>
             <a:pPr lvl="1"/>
             <a:r>
-              <a:rPr lang="en-US" smtClean="0"/>
+              <a:rPr lang="en-US"/>
               <a:t>Second level</a:t>
             </a:r>
           </a:p>
           <a:p>
             <a:pPr lvl="2"/>
             <a:r>
-              <a:rPr lang="en-US" smtClean="0"/>
+              <a:rPr lang="en-US"/>
               <a:t>Third level</a:t>
             </a:r>
           </a:p>
           <a:p>
             <a:pPr lvl="3"/>
             <a:r>
-              <a:rPr lang="en-US" smtClean="0"/>
+              <a:rPr lang="en-US"/>
               <a:t>Fourth level</a:t>
             </a:r>
           </a:p>
           <a:p>
             <a:pPr lvl="4"/>
             <a:r>
-              <a:rPr lang="en-US" smtClean="0"/>
+              <a:rPr lang="en-US"/>
               <a:t>Fifth level</a:t>
             </a:r>
-            <a:endParaRPr lang="en-US"/>
           </a:p>
         </p:txBody>
       </p:sp>
@@ -1353,7 +1358,7 @@
           <a:p>
             <a:fld id="{5BCAD085-E8A6-8845-BD4E-CB4CCA059FC4}" type="datetimeFigureOut">
               <a:rPr lang="en-US" smtClean="0"/>
-              <a:t>1/27/13</a:t>
+              <a:t>6/22/2026</a:t>
             </a:fld>
             <a:endParaRPr lang="en-US"/>
           </a:p>
@@ -1451,10 +1456,9 @@
           </a:lstStyle>
           <a:p>
             <a:r>
-              <a:rPr lang="en-US" smtClean="0"/>
+              <a:rPr lang="en-US"/>
               <a:t>Click to edit Master title style</a:t>
             </a:r>
-            <a:endParaRPr lang="en-US"/>
           </a:p>
         </p:txBody>
       </p:sp>
@@ -1517,7 +1521,7 @@
           <a:p>
             <a:pPr lvl="0"/>
             <a:r>
-              <a:rPr lang="en-US" smtClean="0"/>
+              <a:rPr lang="en-US"/>
               <a:t>Click to edit Master text styles</a:t>
             </a:r>
           </a:p>
@@ -1573,38 +1577,37 @@
           <a:p>
             <a:pPr lvl="0"/>
             <a:r>
-              <a:rPr lang="en-US" smtClean="0"/>
+              <a:rPr lang="en-US"/>
               <a:t>Click to edit Master text styles</a:t>
             </a:r>
           </a:p>
           <a:p>
             <a:pPr lvl="1"/>
             <a:r>
-              <a:rPr lang="en-US" smtClean="0"/>
+              <a:rPr lang="en-US"/>
               <a:t>Second level</a:t>
             </a:r>
           </a:p>
           <a:p>
             <a:pPr lvl="2"/>
             <a:r>
-              <a:rPr lang="en-US" smtClean="0"/>
+              <a:rPr lang="en-US"/>
               <a:t>Third level</a:t>
             </a:r>
           </a:p>
           <a:p>
             <a:pPr lvl="3"/>
             <a:r>
-              <a:rPr lang="en-US" smtClean="0"/>
+              <a:rPr lang="en-US"/>
               <a:t>Fourth level</a:t>
             </a:r>
           </a:p>
           <a:p>
             <a:pPr lvl="4"/>
             <a:r>
-              <a:rPr lang="en-US" smtClean="0"/>
+              <a:rPr lang="en-US"/>
               <a:t>Fifth level</a:t>
             </a:r>
-            <a:endParaRPr lang="en-US"/>
           </a:p>
         </p:txBody>
       </p:sp>
@@ -1667,7 +1670,7 @@
           <a:p>
             <a:pPr lvl="0"/>
             <a:r>
-              <a:rPr lang="en-US" smtClean="0"/>
+              <a:rPr lang="en-US"/>
               <a:t>Click to edit Master text styles</a:t>
             </a:r>
           </a:p>
@@ -1723,38 +1726,37 @@
           <a:p>
             <a:pPr lvl="0"/>
             <a:r>
-              <a:rPr lang="en-US" smtClean="0"/>
+              <a:rPr lang="en-US"/>
               <a:t>Click to edit Master text styles</a:t>
             </a:r>
           </a:p>
           <a:p>
             <a:pPr lvl="1"/>
             <a:r>
-              <a:rPr lang="en-US" smtClean="0"/>
+              <a:rPr lang="en-US"/>
               <a:t>Second level</a:t>
             </a:r>
           </a:p>
           <a:p>
             <a:pPr lvl="2"/>
             <a:r>
-              <a:rPr lang="en-US" smtClean="0"/>
+              <a:rPr lang="en-US"/>
               <a:t>Third level</a:t>
             </a:r>
           </a:p>
           <a:p>
             <a:pPr lvl="3"/>
             <a:r>
-              <a:rPr lang="en-US" smtClean="0"/>
+              <a:rPr lang="en-US"/>
               <a:t>Fourth level</a:t>
             </a:r>
           </a:p>
           <a:p>
             <a:pPr lvl="4"/>
             <a:r>
-              <a:rPr lang="en-US" smtClean="0"/>
+              <a:rPr lang="en-US"/>
               <a:t>Fifth level</a:t>
             </a:r>
-            <a:endParaRPr lang="en-US"/>
           </a:p>
         </p:txBody>
       </p:sp>
@@ -1775,7 +1777,7 @@
           <a:p>
             <a:fld id="{5BCAD085-E8A6-8845-BD4E-CB4CCA059FC4}" type="datetimeFigureOut">
               <a:rPr lang="en-US" smtClean="0"/>
-              <a:t>1/27/13</a:t>
+              <a:t>6/22/2026</a:t>
             </a:fld>
             <a:endParaRPr lang="en-US"/>
           </a:p>
@@ -1869,10 +1871,9 @@
           <a:lstStyle/>
           <a:p>
             <a:r>
-              <a:rPr lang="en-US" smtClean="0"/>
+              <a:rPr lang="en-US"/>
               <a:t>Click to edit Master title style</a:t>
             </a:r>
-            <a:endParaRPr lang="en-US"/>
           </a:p>
         </p:txBody>
       </p:sp>
@@ -1893,7 +1894,7 @@
           <a:p>
             <a:fld id="{5BCAD085-E8A6-8845-BD4E-CB4CCA059FC4}" type="datetimeFigureOut">
               <a:rPr lang="en-US" smtClean="0"/>
-              <a:t>1/27/13</a:t>
+              <a:t>6/22/2026</a:t>
             </a:fld>
             <a:endParaRPr lang="en-US"/>
           </a:p>
@@ -1988,7 +1989,7 @@
           <a:p>
             <a:fld id="{5BCAD085-E8A6-8845-BD4E-CB4CCA059FC4}" type="datetimeFigureOut">
               <a:rPr lang="en-US" smtClean="0"/>
-              <a:t>1/27/13</a:t>
+              <a:t>6/22/2026</a:t>
             </a:fld>
             <a:endParaRPr lang="en-US"/>
           </a:p>
@@ -2091,10 +2092,9 @@
           </a:lstStyle>
           <a:p>
             <a:r>
-              <a:rPr lang="en-US" smtClean="0"/>
+              <a:rPr lang="en-US"/>
               <a:t>Click to edit Master title style</a:t>
             </a:r>
-            <a:endParaRPr lang="en-US"/>
           </a:p>
         </p:txBody>
       </p:sp>
@@ -2148,38 +2148,37 @@
           <a:p>
             <a:pPr lvl="0"/>
             <a:r>
-              <a:rPr lang="en-US" smtClean="0"/>
+              <a:rPr lang="en-US"/>
               <a:t>Click to edit Master text styles</a:t>
             </a:r>
           </a:p>
           <a:p>
             <a:pPr lvl="1"/>
             <a:r>
-              <a:rPr lang="en-US" smtClean="0"/>
+              <a:rPr lang="en-US"/>
               <a:t>Second level</a:t>
             </a:r>
           </a:p>
           <a:p>
             <a:pPr lvl="2"/>
             <a:r>
-              <a:rPr lang="en-US" smtClean="0"/>
+              <a:rPr lang="en-US"/>
               <a:t>Third level</a:t>
             </a:r>
           </a:p>
           <a:p>
             <a:pPr lvl="3"/>
             <a:r>
-              <a:rPr lang="en-US" smtClean="0"/>
+              <a:rPr lang="en-US"/>
               <a:t>Fourth level</a:t>
             </a:r>
           </a:p>
           <a:p>
             <a:pPr lvl="4"/>
             <a:r>
-              <a:rPr lang="en-US" smtClean="0"/>
+              <a:rPr lang="en-US"/>
               <a:t>Fifth level</a:t>
             </a:r>
-            <a:endParaRPr lang="en-US"/>
           </a:p>
         </p:txBody>
       </p:sp>
@@ -2242,7 +2241,7 @@
           <a:p>
             <a:pPr lvl="0"/>
             <a:r>
-              <a:rPr lang="en-US" smtClean="0"/>
+              <a:rPr lang="en-US"/>
               <a:t>Click to edit Master text styles</a:t>
             </a:r>
           </a:p>
@@ -2265,7 +2264,7 @@
           <a:p>
             <a:fld id="{5BCAD085-E8A6-8845-BD4E-CB4CCA059FC4}" type="datetimeFigureOut">
               <a:rPr lang="en-US" smtClean="0"/>
-              <a:t>1/27/13</a:t>
+              <a:t>6/22/2026</a:t>
             </a:fld>
             <a:endParaRPr lang="en-US"/>
           </a:p>
@@ -2368,10 +2367,9 @@
           </a:lstStyle>
           <a:p>
             <a:r>
-              <a:rPr lang="en-US" smtClean="0"/>
+              <a:rPr lang="en-US"/>
               <a:t>Click to edit Master title style</a:t>
             </a:r>
-            <a:endParaRPr lang="en-US"/>
           </a:p>
         </p:txBody>
       </p:sp>
@@ -2495,7 +2493,7 @@
           <a:p>
             <a:pPr lvl="0"/>
             <a:r>
-              <a:rPr lang="en-US" smtClean="0"/>
+              <a:rPr lang="en-US"/>
               <a:t>Click to edit Master text styles</a:t>
             </a:r>
           </a:p>
@@ -2518,7 +2516,7 @@
           <a:p>
             <a:fld id="{5BCAD085-E8A6-8845-BD4E-CB4CCA059FC4}" type="datetimeFigureOut">
               <a:rPr lang="en-US" smtClean="0"/>
-              <a:t>1/27/13</a:t>
+              <a:t>6/22/2026</a:t>
             </a:fld>
             <a:endParaRPr lang="en-US"/>
           </a:p>
@@ -2627,10 +2625,9 @@
           <a:lstStyle/>
           <a:p>
             <a:r>
-              <a:rPr lang="en-US" smtClean="0"/>
+              <a:rPr lang="en-US"/>
               <a:t>Click to edit Master title style</a:t>
             </a:r>
-            <a:endParaRPr lang="en-US"/>
           </a:p>
         </p:txBody>
       </p:sp>
@@ -2661,38 +2658,37 @@
           <a:p>
             <a:pPr lvl="0"/>
             <a:r>
-              <a:rPr lang="en-US" smtClean="0"/>
+              <a:rPr lang="en-US"/>
               <a:t>Click to edit Master text styles</a:t>
             </a:r>
           </a:p>
           <a:p>
             <a:pPr lvl="1"/>
             <a:r>
-              <a:rPr lang="en-US" smtClean="0"/>
+              <a:rPr lang="en-US"/>
               <a:t>Second level</a:t>
             </a:r>
           </a:p>
           <a:p>
             <a:pPr lvl="2"/>
             <a:r>
-              <a:rPr lang="en-US" smtClean="0"/>
+              <a:rPr lang="en-US"/>
               <a:t>Third level</a:t>
             </a:r>
           </a:p>
           <a:p>
             <a:pPr lvl="3"/>
             <a:r>
-              <a:rPr lang="en-US" smtClean="0"/>
+              <a:rPr lang="en-US"/>
               <a:t>Fourth level</a:t>
             </a:r>
           </a:p>
           <a:p>
             <a:pPr lvl="4"/>
             <a:r>
-              <a:rPr lang="en-US" smtClean="0"/>
+              <a:rPr lang="en-US"/>
               <a:t>Fifth level</a:t>
             </a:r>
-            <a:endParaRPr lang="en-US"/>
           </a:p>
         </p:txBody>
       </p:sp>
@@ -2731,7 +2727,7 @@
           <a:p>
             <a:fld id="{5BCAD085-E8A6-8845-BD4E-CB4CCA059FC4}" type="datetimeFigureOut">
               <a:rPr lang="en-US" smtClean="0"/>
-              <a:t>1/27/13</a:t>
+              <a:t>6/22/2026</a:t>
             </a:fld>
             <a:endParaRPr lang="en-US"/>
           </a:p>
@@ -3090,7 +3086,7 @@
 </file>
 
 <file path=ppt/slides/slide1.xml><?xml version="1.0" encoding="utf-8"?>
-<p:sld xmlns:a="http://schemas.openxmlformats.org/drawingml/2006/main" xmlns:p="http://schemas.openxmlformats.org/presentationml/2006/main" xmlns:r="http://schemas.openxmlformats.org/officeDocument/2006/relationships">
+<p:sld xmlns:a="http://schemas.openxmlformats.org/drawingml/2006/main" xmlns:r="http://schemas.openxmlformats.org/officeDocument/2006/relationships" xmlns:p="http://schemas.openxmlformats.org/presentationml/2006/main">
   <p:cSld>
     <p:spTree>
       <p:nvGrpSpPr>
@@ -3098,7 +3094,14 @@
         <p:cNvGrpSpPr/>
         <p:nvPr/>
       </p:nvGrpSpPr>
-      <p:grpSpPr/>
+      <p:grpSpPr>
+        <a:xfrm>
+          <a:off x="0" y="0"/>
+          <a:ext cx="0" cy="0"/>
+          <a:chOff x="0" y="0"/>
+          <a:chExt cx="0" cy="0"/>
+        </a:xfrm>
+      </p:grpSpPr>
       <p:sp>
         <p:nvSpPr>
           <p:cNvPr id="2" name="TextBox 1"/>
@@ -3137,7 +3140,7 @@
 </file>
 
 <file path=ppt/slides/slide10.xml><?xml version="1.0" encoding="utf-8"?>
-<p:sld xmlns:a="http://schemas.openxmlformats.org/drawingml/2006/main" xmlns:p="http://schemas.openxmlformats.org/presentationml/2006/main" xmlns:r="http://schemas.openxmlformats.org/officeDocument/2006/relationships">
+<p:sld xmlns:a="http://schemas.openxmlformats.org/drawingml/2006/main" xmlns:r="http://schemas.openxmlformats.org/officeDocument/2006/relationships" xmlns:p="http://schemas.openxmlformats.org/presentationml/2006/main">
   <p:cSld>
     <p:spTree>
       <p:nvGrpSpPr>
@@ -3145,7 +3148,68 @@
         <p:cNvGrpSpPr/>
         <p:nvPr/>
       </p:nvGrpSpPr>
-      <p:grpSpPr/>
+      <p:grpSpPr>
+        <a:xfrm>
+          <a:off x="0" y="0"/>
+          <a:ext cx="0" cy="0"/>
+          <a:chOff x="0" y="0"/>
+          <a:chExt cx="0" cy="0"/>
+        </a:xfrm>
+      </p:grpSpPr>
+      <p:sp>
+        <p:nvSpPr>
+          <p:cNvPr id="2" name="TextBox 1"/>
+          <p:cNvSpPr txBox="1"/>
+          <p:nvPr/>
+        </p:nvSpPr>
+        <p:spPr>
+          <a:xfrm>
+            <a:off x="914400" y="2286000"/>
+            <a:ext cx="7315200" cy="1371600"/>
+          </a:xfrm>
+          <a:prstGeom prst="rect">
+            <a:avLst/>
+          </a:prstGeom>
+          <a:noFill/>
+        </p:spPr>
+        <p:txBody>
+          <a:bodyPr wrap="none">
+            <a:spAutoFit/>
+          </a:bodyPr>
+          <a:lstStyle/>
+          <a:p>
+            <a:r>
+              <a:rPr sz="4000"/>
+              <a:t>F grade attendees</a:t>
+            </a:r>
+          </a:p>
+        </p:txBody>
+      </p:sp>
+    </p:spTree>
+  </p:cSld>
+  <p:clrMapOvr>
+    <a:masterClrMapping/>
+  </p:clrMapOvr>
+</p:sld>
+</file>
+
+<file path=ppt/slides/slide11.xml><?xml version="1.0" encoding="utf-8"?>
+<p:sld xmlns:a="http://schemas.openxmlformats.org/drawingml/2006/main" xmlns:r="http://schemas.openxmlformats.org/officeDocument/2006/relationships" xmlns:p="http://schemas.openxmlformats.org/presentationml/2006/main">
+  <p:cSld>
+    <p:spTree>
+      <p:nvGrpSpPr>
+        <p:cNvPr id="1" name=""/>
+        <p:cNvGrpSpPr/>
+        <p:nvPr/>
+      </p:nvGrpSpPr>
+      <p:grpSpPr>
+        <a:xfrm>
+          <a:off x="0" y="0"/>
+          <a:ext cx="0" cy="0"/>
+          <a:chOff x="0" y="0"/>
+          <a:chExt cx="0" cy="0"/>
+        </a:xfrm>
+      </p:grpSpPr>
       <p:sp>
         <p:nvSpPr>
           <p:cNvPr id="2" name="NAME"/>
@@ -3212,8 +3276,8 @@
 </p:sld>
 </file>
 
-<file path=ppt/slides/slide11.xml><?xml version="1.0" encoding="utf-8"?>
-<p:sld xmlns:a="http://schemas.openxmlformats.org/drawingml/2006/main" xmlns:p="http://schemas.openxmlformats.org/presentationml/2006/main" xmlns:r="http://schemas.openxmlformats.org/officeDocument/2006/relationships">
+<file path=ppt/slides/slide12.xml><?xml version="1.0" encoding="utf-8"?>
+<p:sld xmlns:a="http://schemas.openxmlformats.org/drawingml/2006/main" xmlns:r="http://schemas.openxmlformats.org/officeDocument/2006/relationships" xmlns:p="http://schemas.openxmlformats.org/presentationml/2006/main">
   <p:cSld>
     <p:spTree>
       <p:nvGrpSpPr>
@@ -3221,7 +3285,14 @@
         <p:cNvGrpSpPr/>
         <p:nvPr/>
       </p:nvGrpSpPr>
-      <p:grpSpPr/>
+      <p:grpSpPr>
+        <a:xfrm>
+          <a:off x="0" y="0"/>
+          <a:ext cx="0" cy="0"/>
+          <a:chOff x="0" y="0"/>
+          <a:chExt cx="0" cy="0"/>
+        </a:xfrm>
+      </p:grpSpPr>
       <p:sp>
         <p:nvSpPr>
           <p:cNvPr id="2" name="TextBox 1"/>
@@ -3259,8 +3330,8 @@
 </p:sld>
 </file>
 
-<file path=ppt/slides/slide12.xml><?xml version="1.0" encoding="utf-8"?>
-<p:sld xmlns:a="http://schemas.openxmlformats.org/drawingml/2006/main" xmlns:p="http://schemas.openxmlformats.org/presentationml/2006/main" xmlns:r="http://schemas.openxmlformats.org/officeDocument/2006/relationships">
+<file path=ppt/slides/slide13.xml><?xml version="1.0" encoding="utf-8"?>
+<p:sld xmlns:a="http://schemas.openxmlformats.org/drawingml/2006/main" xmlns:r="http://schemas.openxmlformats.org/officeDocument/2006/relationships" xmlns:p="http://schemas.openxmlformats.org/presentationml/2006/main">
   <p:cSld>
     <p:spTree>
       <p:nvGrpSpPr>
@@ -3268,7 +3339,14 @@
         <p:cNvGrpSpPr/>
         <p:nvPr/>
       </p:nvGrpSpPr>
-      <p:grpSpPr/>
+      <p:grpSpPr>
+        <a:xfrm>
+          <a:off x="0" y="0"/>
+          <a:ext cx="0" cy="0"/>
+          <a:chOff x="0" y="0"/>
+          <a:chExt cx="0" cy="0"/>
+        </a:xfrm>
+      </p:grpSpPr>
       <p:sp>
         <p:nvSpPr>
           <p:cNvPr id="2" name="NAME"/>
@@ -3336,7 +3414,7 @@
 </file>
 
 <file path=ppt/slides/slide2.xml><?xml version="1.0" encoding="utf-8"?>
-<p:sld xmlns:a="http://schemas.openxmlformats.org/drawingml/2006/main" xmlns:p="http://schemas.openxmlformats.org/presentationml/2006/main" xmlns:r="http://schemas.openxmlformats.org/officeDocument/2006/relationships">
+<p:sld xmlns:a="http://schemas.openxmlformats.org/drawingml/2006/main" xmlns:r="http://schemas.openxmlformats.org/officeDocument/2006/relationships" xmlns:p="http://schemas.openxmlformats.org/presentationml/2006/main">
   <p:cSld>
     <p:spTree>
       <p:nvGrpSpPr>
@@ -3344,7 +3422,98 @@
         <p:cNvGrpSpPr/>
         <p:nvPr/>
       </p:nvGrpSpPr>
-      <p:grpSpPr/>
+      <p:grpSpPr>
+        <a:xfrm>
+          <a:off x="0" y="0"/>
+          <a:ext cx="0" cy="0"/>
+          <a:chOff x="0" y="0"/>
+          <a:chExt cx="0" cy="0"/>
+        </a:xfrm>
+      </p:grpSpPr>
+      <p:sp>
+        <p:nvSpPr>
+          <p:cNvPr id="2" name="Title 1">
+            <a:extLst>
+              <a:ext uri="{FF2B5EF4-FFF2-40B4-BE49-F238E27FC236}">
+                <a16:creationId xmlns:a16="http://schemas.microsoft.com/office/drawing/2014/main" id="{DC90E417-AC9D-3356-FA2A-318F3CA3E1B4}"/>
+              </a:ext>
+            </a:extLst>
+          </p:cNvPr>
+          <p:cNvSpPr>
+            <a:spLocks noGrp="1"/>
+          </p:cNvSpPr>
+          <p:nvPr>
+            <p:ph type="ctrTitle"/>
+          </p:nvPr>
+        </p:nvSpPr>
+        <p:spPr/>
+        <p:txBody>
+          <a:bodyPr/>
+          <a:lstStyle/>
+          <a:p>
+            <a:r>
+              <a:rPr lang="en-US" dirty="0" err="1"/>
+              <a:t>O,o,o,o</a:t>
+            </a:r>
+            <a:endParaRPr lang="en-SG" dirty="0"/>
+          </a:p>
+        </p:txBody>
+      </p:sp>
+      <p:sp>
+        <p:nvSpPr>
+          <p:cNvPr id="3" name="Subtitle 2">
+            <a:extLst>
+              <a:ext uri="{FF2B5EF4-FFF2-40B4-BE49-F238E27FC236}">
+                <a16:creationId xmlns:a16="http://schemas.microsoft.com/office/drawing/2014/main" id="{FACCCAF6-5383-E923-B9A6-B085D2618815}"/>
+              </a:ext>
+            </a:extLst>
+          </p:cNvPr>
+          <p:cNvSpPr>
+            <a:spLocks noGrp="1"/>
+          </p:cNvSpPr>
+          <p:nvPr>
+            <p:ph type="subTitle" idx="1"/>
+          </p:nvPr>
+        </p:nvSpPr>
+        <p:spPr/>
+        <p:txBody>
+          <a:bodyPr/>
+          <a:lstStyle/>
+          <a:p>
+            <a:endParaRPr lang="en-SG"/>
+          </a:p>
+        </p:txBody>
+      </p:sp>
+    </p:spTree>
+    <p:extLst>
+      <p:ext uri="{BB962C8B-B14F-4D97-AF65-F5344CB8AC3E}">
+        <p14:creationId xmlns:p14="http://schemas.microsoft.com/office/powerpoint/2010/main" val="3955295978"/>
+      </p:ext>
+    </p:extLst>
+  </p:cSld>
+  <p:clrMapOvr>
+    <a:masterClrMapping/>
+  </p:clrMapOvr>
+</p:sld>
+</file>
+
+<file path=ppt/slides/slide3.xml><?xml version="1.0" encoding="utf-8"?>
+<p:sld xmlns:a="http://schemas.openxmlformats.org/drawingml/2006/main" xmlns:r="http://schemas.openxmlformats.org/officeDocument/2006/relationships" xmlns:p="http://schemas.openxmlformats.org/presentationml/2006/main">
+  <p:cSld>
+    <p:spTree>
+      <p:nvGrpSpPr>
+        <p:cNvPr id="1" name=""/>
+        <p:cNvGrpSpPr/>
+        <p:nvPr/>
+      </p:nvGrpSpPr>
+      <p:grpSpPr>
+        <a:xfrm>
+          <a:off x="0" y="0"/>
+          <a:ext cx="0" cy="0"/>
+          <a:chOff x="0" y="0"/>
+          <a:chExt cx="0" cy="0"/>
+        </a:xfrm>
+      </p:grpSpPr>
       <p:sp>
         <p:nvSpPr>
           <p:cNvPr id="2" name="NAME"/>
@@ -3411,8 +3580,8 @@
 </p:sld>
 </file>
 
-<file path=ppt/slides/slide3.xml><?xml version="1.0" encoding="utf-8"?>
-<p:sld xmlns:a="http://schemas.openxmlformats.org/drawingml/2006/main" xmlns:p="http://schemas.openxmlformats.org/presentationml/2006/main" xmlns:r="http://schemas.openxmlformats.org/officeDocument/2006/relationships">
+<file path=ppt/slides/slide4.xml><?xml version="1.0" encoding="utf-8"?>
+<p:sld xmlns:a="http://schemas.openxmlformats.org/drawingml/2006/main" xmlns:r="http://schemas.openxmlformats.org/officeDocument/2006/relationships" xmlns:p="http://schemas.openxmlformats.org/presentationml/2006/main">
   <p:cSld>
     <p:spTree>
       <p:nvGrpSpPr>
@@ -3420,7 +3589,14 @@
         <p:cNvGrpSpPr/>
         <p:nvPr/>
       </p:nvGrpSpPr>
-      <p:grpSpPr/>
+      <p:grpSpPr>
+        <a:xfrm>
+          <a:off x="0" y="0"/>
+          <a:ext cx="0" cy="0"/>
+          <a:chOff x="0" y="0"/>
+          <a:chExt cx="0" cy="0"/>
+        </a:xfrm>
+      </p:grpSpPr>
       <p:sp>
         <p:nvSpPr>
           <p:cNvPr id="2" name="TextBox 1"/>
@@ -3458,8 +3634,8 @@
 </p:sld>
 </file>
 
-<file path=ppt/slides/slide4.xml><?xml version="1.0" encoding="utf-8"?>
-<p:sld xmlns:a="http://schemas.openxmlformats.org/drawingml/2006/main" xmlns:p="http://schemas.openxmlformats.org/presentationml/2006/main" xmlns:r="http://schemas.openxmlformats.org/officeDocument/2006/relationships">
+<file path=ppt/slides/slide5.xml><?xml version="1.0" encoding="utf-8"?>
+<p:sld xmlns:a="http://schemas.openxmlformats.org/drawingml/2006/main" xmlns:r="http://schemas.openxmlformats.org/officeDocument/2006/relationships" xmlns:p="http://schemas.openxmlformats.org/presentationml/2006/main">
   <p:cSld>
     <p:spTree>
       <p:nvGrpSpPr>
@@ -3467,7 +3643,14 @@
         <p:cNvGrpSpPr/>
         <p:nvPr/>
       </p:nvGrpSpPr>
-      <p:grpSpPr/>
+      <p:grpSpPr>
+        <a:xfrm>
+          <a:off x="0" y="0"/>
+          <a:ext cx="0" cy="0"/>
+          <a:chOff x="0" y="0"/>
+          <a:chExt cx="0" cy="0"/>
+        </a:xfrm>
+      </p:grpSpPr>
       <p:sp>
         <p:nvSpPr>
           <p:cNvPr id="2" name="NAME"/>
@@ -3534,8 +3717,8 @@
 </p:sld>
 </file>
 
-<file path=ppt/slides/slide5.xml><?xml version="1.0" encoding="utf-8"?>
-<p:sld xmlns:a="http://schemas.openxmlformats.org/drawingml/2006/main" xmlns:p="http://schemas.openxmlformats.org/presentationml/2006/main" xmlns:r="http://schemas.openxmlformats.org/officeDocument/2006/relationships">
+<file path=ppt/slides/slide6.xml><?xml version="1.0" encoding="utf-8"?>
+<p:sld xmlns:a="http://schemas.openxmlformats.org/drawingml/2006/main" xmlns:r="http://schemas.openxmlformats.org/officeDocument/2006/relationships" xmlns:p="http://schemas.openxmlformats.org/presentationml/2006/main">
   <p:cSld>
     <p:spTree>
       <p:nvGrpSpPr>
@@ -3543,7 +3726,14 @@
         <p:cNvGrpSpPr/>
         <p:nvPr/>
       </p:nvGrpSpPr>
-      <p:grpSpPr/>
+      <p:grpSpPr>
+        <a:xfrm>
+          <a:off x="0" y="0"/>
+          <a:ext cx="0" cy="0"/>
+          <a:chOff x="0" y="0"/>
+          <a:chExt cx="0" cy="0"/>
+        </a:xfrm>
+      </p:grpSpPr>
       <p:sp>
         <p:nvSpPr>
           <p:cNvPr id="2" name="TextBox 1"/>
@@ -3581,8 +3771,8 @@
 </p:sld>
 </file>
 
-<file path=ppt/slides/slide6.xml><?xml version="1.0" encoding="utf-8"?>
-<p:sld xmlns:a="http://schemas.openxmlformats.org/drawingml/2006/main" xmlns:p="http://schemas.openxmlformats.org/presentationml/2006/main" xmlns:r="http://schemas.openxmlformats.org/officeDocument/2006/relationships">
+<file path=ppt/slides/slide7.xml><?xml version="1.0" encoding="utf-8"?>
+<p:sld xmlns:a="http://schemas.openxmlformats.org/drawingml/2006/main" xmlns:r="http://schemas.openxmlformats.org/officeDocument/2006/relationships" xmlns:p="http://schemas.openxmlformats.org/presentationml/2006/main">
   <p:cSld>
     <p:spTree>
       <p:nvGrpSpPr>
@@ -3590,7 +3780,14 @@
         <p:cNvGrpSpPr/>
         <p:nvPr/>
       </p:nvGrpSpPr>
-      <p:grpSpPr/>
+      <p:grpSpPr>
+        <a:xfrm>
+          <a:off x="0" y="0"/>
+          <a:ext cx="0" cy="0"/>
+          <a:chOff x="0" y="0"/>
+          <a:chExt cx="0" cy="0"/>
+        </a:xfrm>
+      </p:grpSpPr>
       <p:sp>
         <p:nvSpPr>
           <p:cNvPr id="2" name="NAME"/>
@@ -3657,8 +3854,8 @@
 </p:sld>
 </file>
 
-<file path=ppt/slides/slide7.xml><?xml version="1.0" encoding="utf-8"?>
-<p:sld xmlns:a="http://schemas.openxmlformats.org/drawingml/2006/main" xmlns:p="http://schemas.openxmlformats.org/presentationml/2006/main" xmlns:r="http://schemas.openxmlformats.org/officeDocument/2006/relationships">
+<file path=ppt/slides/slide8.xml><?xml version="1.0" encoding="utf-8"?>
+<p:sld xmlns:a="http://schemas.openxmlformats.org/drawingml/2006/main" xmlns:r="http://schemas.openxmlformats.org/officeDocument/2006/relationships" xmlns:p="http://schemas.openxmlformats.org/presentationml/2006/main">
   <p:cSld>
     <p:spTree>
       <p:nvGrpSpPr>
@@ -3666,7 +3863,14 @@
         <p:cNvGrpSpPr/>
         <p:nvPr/>
       </p:nvGrpSpPr>
-      <p:grpSpPr/>
+      <p:grpSpPr>
+        <a:xfrm>
+          <a:off x="0" y="0"/>
+          <a:ext cx="0" cy="0"/>
+          <a:chOff x="0" y="0"/>
+          <a:chExt cx="0" cy="0"/>
+        </a:xfrm>
+      </p:grpSpPr>
       <p:sp>
         <p:nvSpPr>
           <p:cNvPr id="2" name="TextBox 1"/>
@@ -3704,8 +3908,8 @@
 </p:sld>
 </file>
 
-<file path=ppt/slides/slide8.xml><?xml version="1.0" encoding="utf-8"?>
-<p:sld xmlns:a="http://schemas.openxmlformats.org/drawingml/2006/main" xmlns:p="http://schemas.openxmlformats.org/presentationml/2006/main" xmlns:r="http://schemas.openxmlformats.org/officeDocument/2006/relationships">
+<file path=ppt/slides/slide9.xml><?xml version="1.0" encoding="utf-8"?>
+<p:sld xmlns:a="http://schemas.openxmlformats.org/drawingml/2006/main" xmlns:r="http://schemas.openxmlformats.org/officeDocument/2006/relationships" xmlns:p="http://schemas.openxmlformats.org/presentationml/2006/main">
   <p:cSld>
     <p:spTree>
       <p:nvGrpSpPr>
@@ -3713,7 +3917,14 @@
         <p:cNvGrpSpPr/>
         <p:nvPr/>
       </p:nvGrpSpPr>
-      <p:grpSpPr/>
+      <p:grpSpPr>
+        <a:xfrm>
+          <a:off x="0" y="0"/>
+          <a:ext cx="0" cy="0"/>
+          <a:chOff x="0" y="0"/>
+          <a:chExt cx="0" cy="0"/>
+        </a:xfrm>
+      </p:grpSpPr>
       <p:sp>
         <p:nvSpPr>
           <p:cNvPr id="2" name="NAME"/>
@@ -3768,53 +3979,6 @@
             <a:r>
               <a:rPr sz="2400"/>
               <a:t>{{title}}</a:t>
-            </a:r>
-          </a:p>
-        </p:txBody>
-      </p:sp>
-    </p:spTree>
-  </p:cSld>
-  <p:clrMapOvr>
-    <a:masterClrMapping/>
-  </p:clrMapOvr>
-</p:sld>
-</file>
-
-<file path=ppt/slides/slide9.xml><?xml version="1.0" encoding="utf-8"?>
-<p:sld xmlns:a="http://schemas.openxmlformats.org/drawingml/2006/main" xmlns:p="http://schemas.openxmlformats.org/presentationml/2006/main" xmlns:r="http://schemas.openxmlformats.org/officeDocument/2006/relationships">
-  <p:cSld>
-    <p:spTree>
-      <p:nvGrpSpPr>
-        <p:cNvPr id="1" name=""/>
-        <p:cNvGrpSpPr/>
-        <p:nvPr/>
-      </p:nvGrpSpPr>
-      <p:grpSpPr/>
-      <p:sp>
-        <p:nvSpPr>
-          <p:cNvPr id="2" name="TextBox 1"/>
-          <p:cNvSpPr txBox="1"/>
-          <p:nvPr/>
-        </p:nvSpPr>
-        <p:spPr>
-          <a:xfrm>
-            <a:off x="914400" y="2286000"/>
-            <a:ext cx="7315200" cy="1371600"/>
-          </a:xfrm>
-          <a:prstGeom prst="rect">
-            <a:avLst/>
-          </a:prstGeom>
-          <a:noFill/>
-        </p:spPr>
-        <p:txBody>
-          <a:bodyPr wrap="none">
-            <a:spAutoFit/>
-          </a:bodyPr>
-          <a:lstStyle/>
-          <a:p>
-            <a:r>
-              <a:rPr sz="4000"/>
-              <a:t>F grade attendees</a:t>
             </a:r>
           </a:p>
         </p:txBody>

</xml_diff>

<commit_message>
Inline shape dropdowns in mapping dialog
Replace the separate ShapePicker dialog with inline Name/Title QComboBox controls in ui/mapping_dialog.py. Shape lists are cached per-slide and repopulated automatically when a template slide selection changes; saved mappings are restored into the inline combos. Remove ui/shape_picker.py and update tests and docs accordingly (README and tests/test_gui_smoke.py updated, sample PPTX/XLSX test fixtures refreshed). This simplifies the UI flow by keeping shape selection next to the template slide pickers.
</commit_message>
<xml_diff>
--- a/tests/sample_data/template.pptx
+++ b/tests/sample_data/template.pptx
@@ -5,19 +5,18 @@
     <p:sldMasterId id="2147483648" r:id="rId1"/>
   </p:sldMasterIdLst>
   <p:sldIdLst>
-    <p:sldId id="256" r:id="rId2"/>
-    <p:sldId id="268" r:id="rId3"/>
-    <p:sldId id="257" r:id="rId4"/>
-    <p:sldId id="258" r:id="rId5"/>
-    <p:sldId id="259" r:id="rId6"/>
-    <p:sldId id="260" r:id="rId7"/>
-    <p:sldId id="261" r:id="rId8"/>
-    <p:sldId id="262" r:id="rId9"/>
-    <p:sldId id="263" r:id="rId10"/>
-    <p:sldId id="264" r:id="rId11"/>
-    <p:sldId id="265" r:id="rId12"/>
-    <p:sldId id="266" r:id="rId13"/>
-    <p:sldId id="267" r:id="rId14"/>
+    <p:sldId id="256" r:id="rId7"/>
+    <p:sldId id="257" r:id="rId8"/>
+    <p:sldId id="258" r:id="rId9"/>
+    <p:sldId id="259" r:id="rId10"/>
+    <p:sldId id="260" r:id="rId11"/>
+    <p:sldId id="261" r:id="rId12"/>
+    <p:sldId id="262" r:id="rId13"/>
+    <p:sldId id="263" r:id="rId14"/>
+    <p:sldId id="264" r:id="rId15"/>
+    <p:sldId id="265" r:id="rId16"/>
+    <p:sldId id="266" r:id="rId17"/>
+    <p:sldId id="267" r:id="rId18"/>
   </p:sldIdLst>
   <p:sldSz cx="9144000" cy="6858000" type="screen4x3"/>
   <p:notesSz cx="6858000" cy="9144000"/>
@@ -116,22 +115,6 @@
       </a:defRPr>
     </a:lvl9pPr>
   </p:defaultTextStyle>
-  <p:extLst>
-    <p:ext uri="{EFAFB233-063F-42B5-8137-9DF3F51BA10A}">
-      <p15:sldGuideLst xmlns:p15="http://schemas.microsoft.com/office/powerpoint/2012/main">
-        <p15:guide id="1" orient="horz" pos="2160">
-          <p15:clr>
-            <a:srgbClr val="A4A3A4"/>
-          </p15:clr>
-        </p15:guide>
-        <p15:guide id="2" pos="2880">
-          <p15:clr>
-            <a:srgbClr val="A4A3A4"/>
-          </p15:clr>
-        </p15:guide>
-      </p15:sldGuideLst>
-    </p:ext>
-  </p:extLst>
 </p:presentation>
 </file>
 
@@ -173,9 +156,10 @@
           <a:lstStyle/>
           <a:p>
             <a:r>
-              <a:rPr lang="en-US"/>
+              <a:rPr lang="en-US" smtClean="0"/>
               <a:t>Click to edit Master title style</a:t>
             </a:r>
+            <a:endParaRPr lang="en-US"/>
           </a:p>
         </p:txBody>
       </p:sp>
@@ -291,9 +275,10 @@
           </a:lstStyle>
           <a:p>
             <a:r>
-              <a:rPr lang="en-US"/>
+              <a:rPr lang="en-US" smtClean="0"/>
               <a:t>Click to edit Master subtitle style</a:t>
             </a:r>
+            <a:endParaRPr lang="en-US"/>
           </a:p>
         </p:txBody>
       </p:sp>
@@ -314,7 +299,7 @@
           <a:p>
             <a:fld id="{5BCAD085-E8A6-8845-BD4E-CB4CCA059FC4}" type="datetimeFigureOut">
               <a:rPr lang="en-US" smtClean="0"/>
-              <a:t>6/22/2026</a:t>
+              <a:t>1/27/13</a:t>
             </a:fld>
             <a:endParaRPr lang="en-US"/>
           </a:p>
@@ -408,9 +393,10 @@
           <a:lstStyle/>
           <a:p>
             <a:r>
-              <a:rPr lang="en-US"/>
+              <a:rPr lang="en-US" smtClean="0"/>
               <a:t>Click to edit Master title style</a:t>
             </a:r>
+            <a:endParaRPr lang="en-US"/>
           </a:p>
         </p:txBody>
       </p:sp>
@@ -431,37 +417,38 @@
           <a:p>
             <a:pPr lvl="0"/>
             <a:r>
-              <a:rPr lang="en-US"/>
+              <a:rPr lang="en-US" smtClean="0"/>
               <a:t>Click to edit Master text styles</a:t>
             </a:r>
           </a:p>
           <a:p>
             <a:pPr lvl="1"/>
             <a:r>
-              <a:rPr lang="en-US"/>
+              <a:rPr lang="en-US" smtClean="0"/>
               <a:t>Second level</a:t>
             </a:r>
           </a:p>
           <a:p>
             <a:pPr lvl="2"/>
             <a:r>
-              <a:rPr lang="en-US"/>
+              <a:rPr lang="en-US" smtClean="0"/>
               <a:t>Third level</a:t>
             </a:r>
           </a:p>
           <a:p>
             <a:pPr lvl="3"/>
             <a:r>
-              <a:rPr lang="en-US"/>
+              <a:rPr lang="en-US" smtClean="0"/>
               <a:t>Fourth level</a:t>
             </a:r>
           </a:p>
           <a:p>
             <a:pPr lvl="4"/>
             <a:r>
-              <a:rPr lang="en-US"/>
+              <a:rPr lang="en-US" smtClean="0"/>
               <a:t>Fifth level</a:t>
             </a:r>
+            <a:endParaRPr lang="en-US"/>
           </a:p>
         </p:txBody>
       </p:sp>
@@ -482,7 +469,7 @@
           <a:p>
             <a:fld id="{5BCAD085-E8A6-8845-BD4E-CB4CCA059FC4}" type="datetimeFigureOut">
               <a:rPr lang="en-US" smtClean="0"/>
-              <a:t>6/22/2026</a:t>
+              <a:t>1/27/13</a:t>
             </a:fld>
             <a:endParaRPr lang="en-US"/>
           </a:p>
@@ -581,9 +568,10 @@
           <a:lstStyle/>
           <a:p>
             <a:r>
-              <a:rPr lang="en-US"/>
+              <a:rPr lang="en-US" smtClean="0"/>
               <a:t>Click to edit Master title style</a:t>
             </a:r>
+            <a:endParaRPr lang="en-US"/>
           </a:p>
         </p:txBody>
       </p:sp>
@@ -609,37 +597,38 @@
           <a:p>
             <a:pPr lvl="0"/>
             <a:r>
-              <a:rPr lang="en-US"/>
+              <a:rPr lang="en-US" smtClean="0"/>
               <a:t>Click to edit Master text styles</a:t>
             </a:r>
           </a:p>
           <a:p>
             <a:pPr lvl="1"/>
             <a:r>
-              <a:rPr lang="en-US"/>
+              <a:rPr lang="en-US" smtClean="0"/>
               <a:t>Second level</a:t>
             </a:r>
           </a:p>
           <a:p>
             <a:pPr lvl="2"/>
             <a:r>
-              <a:rPr lang="en-US"/>
+              <a:rPr lang="en-US" smtClean="0"/>
               <a:t>Third level</a:t>
             </a:r>
           </a:p>
           <a:p>
             <a:pPr lvl="3"/>
             <a:r>
-              <a:rPr lang="en-US"/>
+              <a:rPr lang="en-US" smtClean="0"/>
               <a:t>Fourth level</a:t>
             </a:r>
           </a:p>
           <a:p>
             <a:pPr lvl="4"/>
             <a:r>
-              <a:rPr lang="en-US"/>
+              <a:rPr lang="en-US" smtClean="0"/>
               <a:t>Fifth level</a:t>
             </a:r>
+            <a:endParaRPr lang="en-US"/>
           </a:p>
         </p:txBody>
       </p:sp>
@@ -660,7 +649,7 @@
           <a:p>
             <a:fld id="{5BCAD085-E8A6-8845-BD4E-CB4CCA059FC4}" type="datetimeFigureOut">
               <a:rPr lang="en-US" smtClean="0"/>
-              <a:t>6/22/2026</a:t>
+              <a:t>1/27/13</a:t>
             </a:fld>
             <a:endParaRPr lang="en-US"/>
           </a:p>
@@ -754,9 +743,10 @@
           <a:lstStyle/>
           <a:p>
             <a:r>
-              <a:rPr lang="en-US"/>
+              <a:rPr lang="en-US" smtClean="0"/>
               <a:t>Click to edit Master title style</a:t>
             </a:r>
+            <a:endParaRPr lang="en-US"/>
           </a:p>
         </p:txBody>
       </p:sp>
@@ -777,37 +767,38 @@
           <a:p>
             <a:pPr lvl="0"/>
             <a:r>
-              <a:rPr lang="en-US"/>
+              <a:rPr lang="en-US" smtClean="0"/>
               <a:t>Click to edit Master text styles</a:t>
             </a:r>
           </a:p>
           <a:p>
             <a:pPr lvl="1"/>
             <a:r>
-              <a:rPr lang="en-US"/>
+              <a:rPr lang="en-US" smtClean="0"/>
               <a:t>Second level</a:t>
             </a:r>
           </a:p>
           <a:p>
             <a:pPr lvl="2"/>
             <a:r>
-              <a:rPr lang="en-US"/>
+              <a:rPr lang="en-US" smtClean="0"/>
               <a:t>Third level</a:t>
             </a:r>
           </a:p>
           <a:p>
             <a:pPr lvl="3"/>
             <a:r>
-              <a:rPr lang="en-US"/>
+              <a:rPr lang="en-US" smtClean="0"/>
               <a:t>Fourth level</a:t>
             </a:r>
           </a:p>
           <a:p>
             <a:pPr lvl="4"/>
             <a:r>
-              <a:rPr lang="en-US"/>
+              <a:rPr lang="en-US" smtClean="0"/>
               <a:t>Fifth level</a:t>
             </a:r>
+            <a:endParaRPr lang="en-US"/>
           </a:p>
         </p:txBody>
       </p:sp>
@@ -828,7 +819,7 @@
           <a:p>
             <a:fld id="{5BCAD085-E8A6-8845-BD4E-CB4CCA059FC4}" type="datetimeFigureOut">
               <a:rPr lang="en-US" smtClean="0"/>
-              <a:t>6/22/2026</a:t>
+              <a:t>1/27/13</a:t>
             </a:fld>
             <a:endParaRPr lang="en-US"/>
           </a:p>
@@ -931,9 +922,10 @@
           </a:lstStyle>
           <a:p>
             <a:r>
-              <a:rPr lang="en-US"/>
+              <a:rPr lang="en-US" smtClean="0"/>
               <a:t>Click to edit Master title style</a:t>
             </a:r>
+            <a:endParaRPr lang="en-US"/>
           </a:p>
         </p:txBody>
       </p:sp>
@@ -1050,7 +1042,7 @@
           <a:p>
             <a:pPr lvl="0"/>
             <a:r>
-              <a:rPr lang="en-US"/>
+              <a:rPr lang="en-US" smtClean="0"/>
               <a:t>Click to edit Master text styles</a:t>
             </a:r>
           </a:p>
@@ -1073,7 +1065,7 @@
           <a:p>
             <a:fld id="{5BCAD085-E8A6-8845-BD4E-CB4CCA059FC4}" type="datetimeFigureOut">
               <a:rPr lang="en-US" smtClean="0"/>
-              <a:t>6/22/2026</a:t>
+              <a:t>1/27/13</a:t>
             </a:fld>
             <a:endParaRPr lang="en-US"/>
           </a:p>
@@ -1167,9 +1159,10 @@
           <a:lstStyle/>
           <a:p>
             <a:r>
-              <a:rPr lang="en-US"/>
+              <a:rPr lang="en-US" smtClean="0"/>
               <a:t>Click to edit Master title style</a:t>
             </a:r>
+            <a:endParaRPr lang="en-US"/>
           </a:p>
         </p:txBody>
       </p:sp>
@@ -1223,37 +1216,38 @@
           <a:p>
             <a:pPr lvl="0"/>
             <a:r>
-              <a:rPr lang="en-US"/>
+              <a:rPr lang="en-US" smtClean="0"/>
               <a:t>Click to edit Master text styles</a:t>
             </a:r>
           </a:p>
           <a:p>
             <a:pPr lvl="1"/>
             <a:r>
-              <a:rPr lang="en-US"/>
+              <a:rPr lang="en-US" smtClean="0"/>
               <a:t>Second level</a:t>
             </a:r>
           </a:p>
           <a:p>
             <a:pPr lvl="2"/>
             <a:r>
-              <a:rPr lang="en-US"/>
+              <a:rPr lang="en-US" smtClean="0"/>
               <a:t>Third level</a:t>
             </a:r>
           </a:p>
           <a:p>
             <a:pPr lvl="3"/>
             <a:r>
-              <a:rPr lang="en-US"/>
+              <a:rPr lang="en-US" smtClean="0"/>
               <a:t>Fourth level</a:t>
             </a:r>
           </a:p>
           <a:p>
             <a:pPr lvl="4"/>
             <a:r>
-              <a:rPr lang="en-US"/>
+              <a:rPr lang="en-US" smtClean="0"/>
               <a:t>Fifth level</a:t>
             </a:r>
+            <a:endParaRPr lang="en-US"/>
           </a:p>
         </p:txBody>
       </p:sp>
@@ -1307,37 +1301,38 @@
           <a:p>
             <a:pPr lvl="0"/>
             <a:r>
-              <a:rPr lang="en-US"/>
+              <a:rPr lang="en-US" smtClean="0"/>
               <a:t>Click to edit Master text styles</a:t>
             </a:r>
           </a:p>
           <a:p>
             <a:pPr lvl="1"/>
             <a:r>
-              <a:rPr lang="en-US"/>
+              <a:rPr lang="en-US" smtClean="0"/>
               <a:t>Second level</a:t>
             </a:r>
           </a:p>
           <a:p>
             <a:pPr lvl="2"/>
             <a:r>
-              <a:rPr lang="en-US"/>
+              <a:rPr lang="en-US" smtClean="0"/>
               <a:t>Third level</a:t>
             </a:r>
           </a:p>
           <a:p>
             <a:pPr lvl="3"/>
             <a:r>
-              <a:rPr lang="en-US"/>
+              <a:rPr lang="en-US" smtClean="0"/>
               <a:t>Fourth level</a:t>
             </a:r>
           </a:p>
           <a:p>
             <a:pPr lvl="4"/>
             <a:r>
-              <a:rPr lang="en-US"/>
+              <a:rPr lang="en-US" smtClean="0"/>
               <a:t>Fifth level</a:t>
             </a:r>
+            <a:endParaRPr lang="en-US"/>
           </a:p>
         </p:txBody>
       </p:sp>
@@ -1358,7 +1353,7 @@
           <a:p>
             <a:fld id="{5BCAD085-E8A6-8845-BD4E-CB4CCA059FC4}" type="datetimeFigureOut">
               <a:rPr lang="en-US" smtClean="0"/>
-              <a:t>6/22/2026</a:t>
+              <a:t>1/27/13</a:t>
             </a:fld>
             <a:endParaRPr lang="en-US"/>
           </a:p>
@@ -1456,9 +1451,10 @@
           </a:lstStyle>
           <a:p>
             <a:r>
-              <a:rPr lang="en-US"/>
+              <a:rPr lang="en-US" smtClean="0"/>
               <a:t>Click to edit Master title style</a:t>
             </a:r>
+            <a:endParaRPr lang="en-US"/>
           </a:p>
         </p:txBody>
       </p:sp>
@@ -1521,7 +1517,7 @@
           <a:p>
             <a:pPr lvl="0"/>
             <a:r>
-              <a:rPr lang="en-US"/>
+              <a:rPr lang="en-US" smtClean="0"/>
               <a:t>Click to edit Master text styles</a:t>
             </a:r>
           </a:p>
@@ -1577,37 +1573,38 @@
           <a:p>
             <a:pPr lvl="0"/>
             <a:r>
-              <a:rPr lang="en-US"/>
+              <a:rPr lang="en-US" smtClean="0"/>
               <a:t>Click to edit Master text styles</a:t>
             </a:r>
           </a:p>
           <a:p>
             <a:pPr lvl="1"/>
             <a:r>
-              <a:rPr lang="en-US"/>
+              <a:rPr lang="en-US" smtClean="0"/>
               <a:t>Second level</a:t>
             </a:r>
           </a:p>
           <a:p>
             <a:pPr lvl="2"/>
             <a:r>
-              <a:rPr lang="en-US"/>
+              <a:rPr lang="en-US" smtClean="0"/>
               <a:t>Third level</a:t>
             </a:r>
           </a:p>
           <a:p>
             <a:pPr lvl="3"/>
             <a:r>
-              <a:rPr lang="en-US"/>
+              <a:rPr lang="en-US" smtClean="0"/>
               <a:t>Fourth level</a:t>
             </a:r>
           </a:p>
           <a:p>
             <a:pPr lvl="4"/>
             <a:r>
-              <a:rPr lang="en-US"/>
+              <a:rPr lang="en-US" smtClean="0"/>
               <a:t>Fifth level</a:t>
             </a:r>
+            <a:endParaRPr lang="en-US"/>
           </a:p>
         </p:txBody>
       </p:sp>
@@ -1670,7 +1667,7 @@
           <a:p>
             <a:pPr lvl="0"/>
             <a:r>
-              <a:rPr lang="en-US"/>
+              <a:rPr lang="en-US" smtClean="0"/>
               <a:t>Click to edit Master text styles</a:t>
             </a:r>
           </a:p>
@@ -1726,37 +1723,38 @@
           <a:p>
             <a:pPr lvl="0"/>
             <a:r>
-              <a:rPr lang="en-US"/>
+              <a:rPr lang="en-US" smtClean="0"/>
               <a:t>Click to edit Master text styles</a:t>
             </a:r>
           </a:p>
           <a:p>
             <a:pPr lvl="1"/>
             <a:r>
-              <a:rPr lang="en-US"/>
+              <a:rPr lang="en-US" smtClean="0"/>
               <a:t>Second level</a:t>
             </a:r>
           </a:p>
           <a:p>
             <a:pPr lvl="2"/>
             <a:r>
-              <a:rPr lang="en-US"/>
+              <a:rPr lang="en-US" smtClean="0"/>
               <a:t>Third level</a:t>
             </a:r>
           </a:p>
           <a:p>
             <a:pPr lvl="3"/>
             <a:r>
-              <a:rPr lang="en-US"/>
+              <a:rPr lang="en-US" smtClean="0"/>
               <a:t>Fourth level</a:t>
             </a:r>
           </a:p>
           <a:p>
             <a:pPr lvl="4"/>
             <a:r>
-              <a:rPr lang="en-US"/>
+              <a:rPr lang="en-US" smtClean="0"/>
               <a:t>Fifth level</a:t>
             </a:r>
+            <a:endParaRPr lang="en-US"/>
           </a:p>
         </p:txBody>
       </p:sp>
@@ -1777,7 +1775,7 @@
           <a:p>
             <a:fld id="{5BCAD085-E8A6-8845-BD4E-CB4CCA059FC4}" type="datetimeFigureOut">
               <a:rPr lang="en-US" smtClean="0"/>
-              <a:t>6/22/2026</a:t>
+              <a:t>1/27/13</a:t>
             </a:fld>
             <a:endParaRPr lang="en-US"/>
           </a:p>
@@ -1871,9 +1869,10 @@
           <a:lstStyle/>
           <a:p>
             <a:r>
-              <a:rPr lang="en-US"/>
+              <a:rPr lang="en-US" smtClean="0"/>
               <a:t>Click to edit Master title style</a:t>
             </a:r>
+            <a:endParaRPr lang="en-US"/>
           </a:p>
         </p:txBody>
       </p:sp>
@@ -1894,7 +1893,7 @@
           <a:p>
             <a:fld id="{5BCAD085-E8A6-8845-BD4E-CB4CCA059FC4}" type="datetimeFigureOut">
               <a:rPr lang="en-US" smtClean="0"/>
-              <a:t>6/22/2026</a:t>
+              <a:t>1/27/13</a:t>
             </a:fld>
             <a:endParaRPr lang="en-US"/>
           </a:p>
@@ -1989,7 +1988,7 @@
           <a:p>
             <a:fld id="{5BCAD085-E8A6-8845-BD4E-CB4CCA059FC4}" type="datetimeFigureOut">
               <a:rPr lang="en-US" smtClean="0"/>
-              <a:t>6/22/2026</a:t>
+              <a:t>1/27/13</a:t>
             </a:fld>
             <a:endParaRPr lang="en-US"/>
           </a:p>
@@ -2092,9 +2091,10 @@
           </a:lstStyle>
           <a:p>
             <a:r>
-              <a:rPr lang="en-US"/>
+              <a:rPr lang="en-US" smtClean="0"/>
               <a:t>Click to edit Master title style</a:t>
             </a:r>
+            <a:endParaRPr lang="en-US"/>
           </a:p>
         </p:txBody>
       </p:sp>
@@ -2148,37 +2148,38 @@
           <a:p>
             <a:pPr lvl="0"/>
             <a:r>
-              <a:rPr lang="en-US"/>
+              <a:rPr lang="en-US" smtClean="0"/>
               <a:t>Click to edit Master text styles</a:t>
             </a:r>
           </a:p>
           <a:p>
             <a:pPr lvl="1"/>
             <a:r>
-              <a:rPr lang="en-US"/>
+              <a:rPr lang="en-US" smtClean="0"/>
               <a:t>Second level</a:t>
             </a:r>
           </a:p>
           <a:p>
             <a:pPr lvl="2"/>
             <a:r>
-              <a:rPr lang="en-US"/>
+              <a:rPr lang="en-US" smtClean="0"/>
               <a:t>Third level</a:t>
             </a:r>
           </a:p>
           <a:p>
             <a:pPr lvl="3"/>
             <a:r>
-              <a:rPr lang="en-US"/>
+              <a:rPr lang="en-US" smtClean="0"/>
               <a:t>Fourth level</a:t>
             </a:r>
           </a:p>
           <a:p>
             <a:pPr lvl="4"/>
             <a:r>
-              <a:rPr lang="en-US"/>
+              <a:rPr lang="en-US" smtClean="0"/>
               <a:t>Fifth level</a:t>
             </a:r>
+            <a:endParaRPr lang="en-US"/>
           </a:p>
         </p:txBody>
       </p:sp>
@@ -2241,7 +2242,7 @@
           <a:p>
             <a:pPr lvl="0"/>
             <a:r>
-              <a:rPr lang="en-US"/>
+              <a:rPr lang="en-US" smtClean="0"/>
               <a:t>Click to edit Master text styles</a:t>
             </a:r>
           </a:p>
@@ -2264,7 +2265,7 @@
           <a:p>
             <a:fld id="{5BCAD085-E8A6-8845-BD4E-CB4CCA059FC4}" type="datetimeFigureOut">
               <a:rPr lang="en-US" smtClean="0"/>
-              <a:t>6/22/2026</a:t>
+              <a:t>1/27/13</a:t>
             </a:fld>
             <a:endParaRPr lang="en-US"/>
           </a:p>
@@ -2367,9 +2368,10 @@
           </a:lstStyle>
           <a:p>
             <a:r>
-              <a:rPr lang="en-US"/>
+              <a:rPr lang="en-US" smtClean="0"/>
               <a:t>Click to edit Master title style</a:t>
             </a:r>
+            <a:endParaRPr lang="en-US"/>
           </a:p>
         </p:txBody>
       </p:sp>
@@ -2493,7 +2495,7 @@
           <a:p>
             <a:pPr lvl="0"/>
             <a:r>
-              <a:rPr lang="en-US"/>
+              <a:rPr lang="en-US" smtClean="0"/>
               <a:t>Click to edit Master text styles</a:t>
             </a:r>
           </a:p>
@@ -2516,7 +2518,7 @@
           <a:p>
             <a:fld id="{5BCAD085-E8A6-8845-BD4E-CB4CCA059FC4}" type="datetimeFigureOut">
               <a:rPr lang="en-US" smtClean="0"/>
-              <a:t>6/22/2026</a:t>
+              <a:t>1/27/13</a:t>
             </a:fld>
             <a:endParaRPr lang="en-US"/>
           </a:p>
@@ -2625,9 +2627,10 @@
           <a:lstStyle/>
           <a:p>
             <a:r>
-              <a:rPr lang="en-US"/>
+              <a:rPr lang="en-US" smtClean="0"/>
               <a:t>Click to edit Master title style</a:t>
             </a:r>
+            <a:endParaRPr lang="en-US"/>
           </a:p>
         </p:txBody>
       </p:sp>
@@ -2658,37 +2661,38 @@
           <a:p>
             <a:pPr lvl="0"/>
             <a:r>
-              <a:rPr lang="en-US"/>
+              <a:rPr lang="en-US" smtClean="0"/>
               <a:t>Click to edit Master text styles</a:t>
             </a:r>
           </a:p>
           <a:p>
             <a:pPr lvl="1"/>
             <a:r>
-              <a:rPr lang="en-US"/>
+              <a:rPr lang="en-US" smtClean="0"/>
               <a:t>Second level</a:t>
             </a:r>
           </a:p>
           <a:p>
             <a:pPr lvl="2"/>
             <a:r>
-              <a:rPr lang="en-US"/>
+              <a:rPr lang="en-US" smtClean="0"/>
               <a:t>Third level</a:t>
             </a:r>
           </a:p>
           <a:p>
             <a:pPr lvl="3"/>
             <a:r>
-              <a:rPr lang="en-US"/>
+              <a:rPr lang="en-US" smtClean="0"/>
               <a:t>Fourth level</a:t>
             </a:r>
           </a:p>
           <a:p>
             <a:pPr lvl="4"/>
             <a:r>
-              <a:rPr lang="en-US"/>
+              <a:rPr lang="en-US" smtClean="0"/>
               <a:t>Fifth level</a:t>
             </a:r>
+            <a:endParaRPr lang="en-US"/>
           </a:p>
         </p:txBody>
       </p:sp>
@@ -2727,7 +2731,7 @@
           <a:p>
             <a:fld id="{5BCAD085-E8A6-8845-BD4E-CB4CCA059FC4}" type="datetimeFigureOut">
               <a:rPr lang="en-US" smtClean="0"/>
-              <a:t>6/22/2026</a:t>
+              <a:t>1/27/13</a:t>
             </a:fld>
             <a:endParaRPr lang="en-US"/>
           </a:p>
@@ -3086,7 +3090,7 @@
 </file>
 
 <file path=ppt/slides/slide1.xml><?xml version="1.0" encoding="utf-8"?>
-<p:sld xmlns:a="http://schemas.openxmlformats.org/drawingml/2006/main" xmlns:r="http://schemas.openxmlformats.org/officeDocument/2006/relationships" xmlns:p="http://schemas.openxmlformats.org/presentationml/2006/main">
+<p:sld xmlns:a="http://schemas.openxmlformats.org/drawingml/2006/main" xmlns:p="http://schemas.openxmlformats.org/presentationml/2006/main" xmlns:r="http://schemas.openxmlformats.org/officeDocument/2006/relationships">
   <p:cSld>
     <p:spTree>
       <p:nvGrpSpPr>
@@ -3094,14 +3098,7 @@
         <p:cNvGrpSpPr/>
         <p:nvPr/>
       </p:nvGrpSpPr>
-      <p:grpSpPr>
-        <a:xfrm>
-          <a:off x="0" y="0"/>
-          <a:ext cx="0" cy="0"/>
-          <a:chOff x="0" y="0"/>
-          <a:chExt cx="0" cy="0"/>
-        </a:xfrm>
-      </p:grpSpPr>
+      <p:grpSpPr/>
       <p:sp>
         <p:nvSpPr>
           <p:cNvPr id="2" name="TextBox 1"/>
@@ -3140,7 +3137,7 @@
 </file>
 
 <file path=ppt/slides/slide10.xml><?xml version="1.0" encoding="utf-8"?>
-<p:sld xmlns:a="http://schemas.openxmlformats.org/drawingml/2006/main" xmlns:r="http://schemas.openxmlformats.org/officeDocument/2006/relationships" xmlns:p="http://schemas.openxmlformats.org/presentationml/2006/main">
+<p:sld xmlns:a="http://schemas.openxmlformats.org/drawingml/2006/main" xmlns:p="http://schemas.openxmlformats.org/presentationml/2006/main" xmlns:r="http://schemas.openxmlformats.org/officeDocument/2006/relationships">
   <p:cSld>
     <p:spTree>
       <p:nvGrpSpPr>
@@ -3148,14 +3145,83 @@
         <p:cNvGrpSpPr/>
         <p:nvPr/>
       </p:nvGrpSpPr>
-      <p:grpSpPr>
-        <a:xfrm>
-          <a:off x="0" y="0"/>
-          <a:ext cx="0" cy="0"/>
-          <a:chOff x="0" y="0"/>
-          <a:chExt cx="0" cy="0"/>
-        </a:xfrm>
-      </p:grpSpPr>
+      <p:grpSpPr/>
+      <p:sp>
+        <p:nvSpPr>
+          <p:cNvPr id="2" name="NAME"/>
+          <p:cNvSpPr txBox="1"/>
+          <p:nvPr/>
+        </p:nvSpPr>
+        <p:spPr>
+          <a:xfrm>
+            <a:off x="914400" y="1828800"/>
+            <a:ext cx="7315200" cy="914400"/>
+          </a:xfrm>
+          <a:prstGeom prst="rect">
+            <a:avLst/>
+          </a:prstGeom>
+          <a:noFill/>
+        </p:spPr>
+        <p:txBody>
+          <a:bodyPr wrap="none">
+            <a:spAutoFit/>
+          </a:bodyPr>
+          <a:lstStyle/>
+          <a:p>
+            <a:r>
+              <a:rPr sz="3200"/>
+              <a:t>{{name}}</a:t>
+            </a:r>
+          </a:p>
+        </p:txBody>
+      </p:sp>
+      <p:sp>
+        <p:nvSpPr>
+          <p:cNvPr id="3" name="TITLE"/>
+          <p:cNvSpPr txBox="1"/>
+          <p:nvPr/>
+        </p:nvSpPr>
+        <p:spPr>
+          <a:xfrm>
+            <a:off x="914400" y="2926080"/>
+            <a:ext cx="7315200" cy="914400"/>
+          </a:xfrm>
+          <a:prstGeom prst="rect">
+            <a:avLst/>
+          </a:prstGeom>
+          <a:noFill/>
+        </p:spPr>
+        <p:txBody>
+          <a:bodyPr wrap="none">
+            <a:spAutoFit/>
+          </a:bodyPr>
+          <a:lstStyle/>
+          <a:p>
+            <a:r>
+              <a:rPr sz="2400"/>
+              <a:t>{{title}}</a:t>
+            </a:r>
+          </a:p>
+        </p:txBody>
+      </p:sp>
+    </p:spTree>
+  </p:cSld>
+  <p:clrMapOvr>
+    <a:masterClrMapping/>
+  </p:clrMapOvr>
+</p:sld>
+</file>
+
+<file path=ppt/slides/slide11.xml><?xml version="1.0" encoding="utf-8"?>
+<p:sld xmlns:a="http://schemas.openxmlformats.org/drawingml/2006/main" xmlns:p="http://schemas.openxmlformats.org/presentationml/2006/main" xmlns:r="http://schemas.openxmlformats.org/officeDocument/2006/relationships">
+  <p:cSld>
+    <p:spTree>
+      <p:nvGrpSpPr>
+        <p:cNvPr id="1" name=""/>
+        <p:cNvGrpSpPr/>
+        <p:nvPr/>
+      </p:nvGrpSpPr>
+      <p:grpSpPr/>
       <p:sp>
         <p:nvSpPr>
           <p:cNvPr id="2" name="TextBox 1"/>
@@ -3180,7 +3246,7 @@
           <a:p>
             <a:r>
               <a:rPr sz="4000"/>
-              <a:t>F grade attendees</a:t>
+              <a:t>F grade absentees</a:t>
             </a:r>
           </a:p>
         </p:txBody>
@@ -3193,8 +3259,8 @@
 </p:sld>
 </file>
 
-<file path=ppt/slides/slide11.xml><?xml version="1.0" encoding="utf-8"?>
-<p:sld xmlns:a="http://schemas.openxmlformats.org/drawingml/2006/main" xmlns:r="http://schemas.openxmlformats.org/officeDocument/2006/relationships" xmlns:p="http://schemas.openxmlformats.org/presentationml/2006/main">
+<file path=ppt/slides/slide12.xml><?xml version="1.0" encoding="utf-8"?>
+<p:sld xmlns:a="http://schemas.openxmlformats.org/drawingml/2006/main" xmlns:p="http://schemas.openxmlformats.org/presentationml/2006/main" xmlns:r="http://schemas.openxmlformats.org/officeDocument/2006/relationships">
   <p:cSld>
     <p:spTree>
       <p:nvGrpSpPr>
@@ -3202,14 +3268,7 @@
         <p:cNvGrpSpPr/>
         <p:nvPr/>
       </p:nvGrpSpPr>
-      <p:grpSpPr>
-        <a:xfrm>
-          <a:off x="0" y="0"/>
-          <a:ext cx="0" cy="0"/>
-          <a:chOff x="0" y="0"/>
-          <a:chExt cx="0" cy="0"/>
-        </a:xfrm>
-      </p:grpSpPr>
+      <p:grpSpPr/>
       <p:sp>
         <p:nvSpPr>
           <p:cNvPr id="2" name="NAME"/>
@@ -3276,8 +3335,8 @@
 </p:sld>
 </file>
 
-<file path=ppt/slides/slide12.xml><?xml version="1.0" encoding="utf-8"?>
-<p:sld xmlns:a="http://schemas.openxmlformats.org/drawingml/2006/main" xmlns:r="http://schemas.openxmlformats.org/officeDocument/2006/relationships" xmlns:p="http://schemas.openxmlformats.org/presentationml/2006/main">
+<file path=ppt/slides/slide2.xml><?xml version="1.0" encoding="utf-8"?>
+<p:sld xmlns:a="http://schemas.openxmlformats.org/drawingml/2006/main" xmlns:p="http://schemas.openxmlformats.org/presentationml/2006/main" xmlns:r="http://schemas.openxmlformats.org/officeDocument/2006/relationships">
   <p:cSld>
     <p:spTree>
       <p:nvGrpSpPr>
@@ -3285,14 +3344,83 @@
         <p:cNvGrpSpPr/>
         <p:nvPr/>
       </p:nvGrpSpPr>
-      <p:grpSpPr>
-        <a:xfrm>
-          <a:off x="0" y="0"/>
-          <a:ext cx="0" cy="0"/>
-          <a:chOff x="0" y="0"/>
-          <a:chExt cx="0" cy="0"/>
-        </a:xfrm>
-      </p:grpSpPr>
+      <p:grpSpPr/>
+      <p:sp>
+        <p:nvSpPr>
+          <p:cNvPr id="2" name="NAME"/>
+          <p:cNvSpPr txBox="1"/>
+          <p:nvPr/>
+        </p:nvSpPr>
+        <p:spPr>
+          <a:xfrm>
+            <a:off x="914400" y="1828800"/>
+            <a:ext cx="7315200" cy="914400"/>
+          </a:xfrm>
+          <a:prstGeom prst="rect">
+            <a:avLst/>
+          </a:prstGeom>
+          <a:noFill/>
+        </p:spPr>
+        <p:txBody>
+          <a:bodyPr wrap="none">
+            <a:spAutoFit/>
+          </a:bodyPr>
+          <a:lstStyle/>
+          <a:p>
+            <a:r>
+              <a:rPr sz="3200"/>
+              <a:t>{{name}}</a:t>
+            </a:r>
+          </a:p>
+        </p:txBody>
+      </p:sp>
+      <p:sp>
+        <p:nvSpPr>
+          <p:cNvPr id="3" name="TITLE"/>
+          <p:cNvSpPr txBox="1"/>
+          <p:nvPr/>
+        </p:nvSpPr>
+        <p:spPr>
+          <a:xfrm>
+            <a:off x="914400" y="2926080"/>
+            <a:ext cx="7315200" cy="914400"/>
+          </a:xfrm>
+          <a:prstGeom prst="rect">
+            <a:avLst/>
+          </a:prstGeom>
+          <a:noFill/>
+        </p:spPr>
+        <p:txBody>
+          <a:bodyPr wrap="none">
+            <a:spAutoFit/>
+          </a:bodyPr>
+          <a:lstStyle/>
+          <a:p>
+            <a:r>
+              <a:rPr sz="2400"/>
+              <a:t>{{title}}</a:t>
+            </a:r>
+          </a:p>
+        </p:txBody>
+      </p:sp>
+    </p:spTree>
+  </p:cSld>
+  <p:clrMapOvr>
+    <a:masterClrMapping/>
+  </p:clrMapOvr>
+</p:sld>
+</file>
+
+<file path=ppt/slides/slide3.xml><?xml version="1.0" encoding="utf-8"?>
+<p:sld xmlns:a="http://schemas.openxmlformats.org/drawingml/2006/main" xmlns:p="http://schemas.openxmlformats.org/presentationml/2006/main" xmlns:r="http://schemas.openxmlformats.org/officeDocument/2006/relationships">
+  <p:cSld>
+    <p:spTree>
+      <p:nvGrpSpPr>
+        <p:cNvPr id="1" name=""/>
+        <p:cNvGrpSpPr/>
+        <p:nvPr/>
+      </p:nvGrpSpPr>
+      <p:grpSpPr/>
       <p:sp>
         <p:nvSpPr>
           <p:cNvPr id="2" name="TextBox 1"/>
@@ -3317,7 +3445,7 @@
           <a:p>
             <a:r>
               <a:rPr sz="4000"/>
-              <a:t>F grade absentees</a:t>
+              <a:t>E grade absentees</a:t>
             </a:r>
           </a:p>
         </p:txBody>
@@ -3330,8 +3458,8 @@
 </p:sld>
 </file>
 
-<file path=ppt/slides/slide13.xml><?xml version="1.0" encoding="utf-8"?>
-<p:sld xmlns:a="http://schemas.openxmlformats.org/drawingml/2006/main" xmlns:r="http://schemas.openxmlformats.org/officeDocument/2006/relationships" xmlns:p="http://schemas.openxmlformats.org/presentationml/2006/main">
+<file path=ppt/slides/slide4.xml><?xml version="1.0" encoding="utf-8"?>
+<p:sld xmlns:a="http://schemas.openxmlformats.org/drawingml/2006/main" xmlns:p="http://schemas.openxmlformats.org/presentationml/2006/main" xmlns:r="http://schemas.openxmlformats.org/officeDocument/2006/relationships">
   <p:cSld>
     <p:spTree>
       <p:nvGrpSpPr>
@@ -3339,14 +3467,7 @@
         <p:cNvGrpSpPr/>
         <p:nvPr/>
       </p:nvGrpSpPr>
-      <p:grpSpPr>
-        <a:xfrm>
-          <a:off x="0" y="0"/>
-          <a:ext cx="0" cy="0"/>
-          <a:chOff x="0" y="0"/>
-          <a:chExt cx="0" cy="0"/>
-        </a:xfrm>
-      </p:grpSpPr>
+      <p:grpSpPr/>
       <p:sp>
         <p:nvSpPr>
           <p:cNvPr id="2" name="NAME"/>
@@ -3413,8 +3534,8 @@
 </p:sld>
 </file>
 
-<file path=ppt/slides/slide2.xml><?xml version="1.0" encoding="utf-8"?>
-<p:sld xmlns:a="http://schemas.openxmlformats.org/drawingml/2006/main" xmlns:r="http://schemas.openxmlformats.org/officeDocument/2006/relationships" xmlns:p="http://schemas.openxmlformats.org/presentationml/2006/main">
+<file path=ppt/slides/slide5.xml><?xml version="1.0" encoding="utf-8"?>
+<p:sld xmlns:a="http://schemas.openxmlformats.org/drawingml/2006/main" xmlns:p="http://schemas.openxmlformats.org/presentationml/2006/main" xmlns:r="http://schemas.openxmlformats.org/officeDocument/2006/relationships">
   <p:cSld>
     <p:spTree>
       <p:nvGrpSpPr>
@@ -3422,74 +3543,37 @@
         <p:cNvGrpSpPr/>
         <p:nvPr/>
       </p:nvGrpSpPr>
-      <p:grpSpPr>
-        <a:xfrm>
-          <a:off x="0" y="0"/>
-          <a:ext cx="0" cy="0"/>
-          <a:chOff x="0" y="0"/>
-          <a:chExt cx="0" cy="0"/>
-        </a:xfrm>
-      </p:grpSpPr>
-      <p:sp>
-        <p:nvSpPr>
-          <p:cNvPr id="2" name="Title 1">
-            <a:extLst>
-              <a:ext uri="{FF2B5EF4-FFF2-40B4-BE49-F238E27FC236}">
-                <a16:creationId xmlns:a16="http://schemas.microsoft.com/office/drawing/2014/main" id="{DC90E417-AC9D-3356-FA2A-318F3CA3E1B4}"/>
-              </a:ext>
-            </a:extLst>
-          </p:cNvPr>
-          <p:cNvSpPr>
-            <a:spLocks noGrp="1"/>
-          </p:cNvSpPr>
-          <p:nvPr>
-            <p:ph type="ctrTitle"/>
-          </p:nvPr>
-        </p:nvSpPr>
-        <p:spPr/>
-        <p:txBody>
-          <a:bodyPr/>
-          <a:lstStyle/>
-          <a:p>
-            <a:r>
-              <a:rPr lang="en-US" dirty="0" err="1"/>
-              <a:t>O,o,o,o</a:t>
-            </a:r>
-            <a:endParaRPr lang="en-SG" dirty="0"/>
-          </a:p>
-        </p:txBody>
-      </p:sp>
-      <p:sp>
-        <p:nvSpPr>
-          <p:cNvPr id="3" name="Subtitle 2">
-            <a:extLst>
-              <a:ext uri="{FF2B5EF4-FFF2-40B4-BE49-F238E27FC236}">
-                <a16:creationId xmlns:a16="http://schemas.microsoft.com/office/drawing/2014/main" id="{FACCCAF6-5383-E923-B9A6-B085D2618815}"/>
-              </a:ext>
-            </a:extLst>
-          </p:cNvPr>
-          <p:cNvSpPr>
-            <a:spLocks noGrp="1"/>
-          </p:cNvSpPr>
-          <p:nvPr>
-            <p:ph type="subTitle" idx="1"/>
-          </p:nvPr>
-        </p:nvSpPr>
-        <p:spPr/>
-        <p:txBody>
-          <a:bodyPr/>
-          <a:lstStyle/>
-          <a:p>
-            <a:endParaRPr lang="en-SG"/>
+      <p:grpSpPr/>
+      <p:sp>
+        <p:nvSpPr>
+          <p:cNvPr id="2" name="TextBox 1"/>
+          <p:cNvSpPr txBox="1"/>
+          <p:nvPr/>
+        </p:nvSpPr>
+        <p:spPr>
+          <a:xfrm>
+            <a:off x="914400" y="2286000"/>
+            <a:ext cx="7315200" cy="1371600"/>
+          </a:xfrm>
+          <a:prstGeom prst="rect">
+            <a:avLst/>
+          </a:prstGeom>
+          <a:noFill/>
+        </p:spPr>
+        <p:txBody>
+          <a:bodyPr wrap="none">
+            <a:spAutoFit/>
+          </a:bodyPr>
+          <a:lstStyle/>
+          <a:p>
+            <a:r>
+              <a:rPr sz="4000"/>
+              <a:t>M grade attendees</a:t>
+            </a:r>
           </a:p>
         </p:txBody>
       </p:sp>
     </p:spTree>
-    <p:extLst>
-      <p:ext uri="{BB962C8B-B14F-4D97-AF65-F5344CB8AC3E}">
-        <p14:creationId xmlns:p14="http://schemas.microsoft.com/office/powerpoint/2010/main" val="3955295978"/>
-      </p:ext>
-    </p:extLst>
   </p:cSld>
   <p:clrMapOvr>
     <a:masterClrMapping/>
@@ -3497,8 +3581,8 @@
 </p:sld>
 </file>
 
-<file path=ppt/slides/slide3.xml><?xml version="1.0" encoding="utf-8"?>
-<p:sld xmlns:a="http://schemas.openxmlformats.org/drawingml/2006/main" xmlns:r="http://schemas.openxmlformats.org/officeDocument/2006/relationships" xmlns:p="http://schemas.openxmlformats.org/presentationml/2006/main">
+<file path=ppt/slides/slide6.xml><?xml version="1.0" encoding="utf-8"?>
+<p:sld xmlns:a="http://schemas.openxmlformats.org/drawingml/2006/main" xmlns:p="http://schemas.openxmlformats.org/presentationml/2006/main" xmlns:r="http://schemas.openxmlformats.org/officeDocument/2006/relationships">
   <p:cSld>
     <p:spTree>
       <p:nvGrpSpPr>
@@ -3506,14 +3590,7 @@
         <p:cNvGrpSpPr/>
         <p:nvPr/>
       </p:nvGrpSpPr>
-      <p:grpSpPr>
-        <a:xfrm>
-          <a:off x="0" y="0"/>
-          <a:ext cx="0" cy="0"/>
-          <a:chOff x="0" y="0"/>
-          <a:chExt cx="0" cy="0"/>
-        </a:xfrm>
-      </p:grpSpPr>
+      <p:grpSpPr/>
       <p:sp>
         <p:nvSpPr>
           <p:cNvPr id="2" name="NAME"/>
@@ -3580,8 +3657,8 @@
 </p:sld>
 </file>
 
-<file path=ppt/slides/slide4.xml><?xml version="1.0" encoding="utf-8"?>
-<p:sld xmlns:a="http://schemas.openxmlformats.org/drawingml/2006/main" xmlns:r="http://schemas.openxmlformats.org/officeDocument/2006/relationships" xmlns:p="http://schemas.openxmlformats.org/presentationml/2006/main">
+<file path=ppt/slides/slide7.xml><?xml version="1.0" encoding="utf-8"?>
+<p:sld xmlns:a="http://schemas.openxmlformats.org/drawingml/2006/main" xmlns:p="http://schemas.openxmlformats.org/presentationml/2006/main" xmlns:r="http://schemas.openxmlformats.org/officeDocument/2006/relationships">
   <p:cSld>
     <p:spTree>
       <p:nvGrpSpPr>
@@ -3589,14 +3666,7 @@
         <p:cNvGrpSpPr/>
         <p:nvPr/>
       </p:nvGrpSpPr>
-      <p:grpSpPr>
-        <a:xfrm>
-          <a:off x="0" y="0"/>
-          <a:ext cx="0" cy="0"/>
-          <a:chOff x="0" y="0"/>
-          <a:chExt cx="0" cy="0"/>
-        </a:xfrm>
-      </p:grpSpPr>
+      <p:grpSpPr/>
       <p:sp>
         <p:nvSpPr>
           <p:cNvPr id="2" name="TextBox 1"/>
@@ -3621,7 +3691,7 @@
           <a:p>
             <a:r>
               <a:rPr sz="4000"/>
-              <a:t>E grade absentees</a:t>
+              <a:t>M grade absentees</a:t>
             </a:r>
           </a:p>
         </p:txBody>
@@ -3634,8 +3704,8 @@
 </p:sld>
 </file>
 
-<file path=ppt/slides/slide5.xml><?xml version="1.0" encoding="utf-8"?>
-<p:sld xmlns:a="http://schemas.openxmlformats.org/drawingml/2006/main" xmlns:r="http://schemas.openxmlformats.org/officeDocument/2006/relationships" xmlns:p="http://schemas.openxmlformats.org/presentationml/2006/main">
+<file path=ppt/slides/slide8.xml><?xml version="1.0" encoding="utf-8"?>
+<p:sld xmlns:a="http://schemas.openxmlformats.org/drawingml/2006/main" xmlns:p="http://schemas.openxmlformats.org/presentationml/2006/main" xmlns:r="http://schemas.openxmlformats.org/officeDocument/2006/relationships">
   <p:cSld>
     <p:spTree>
       <p:nvGrpSpPr>
@@ -3643,14 +3713,7 @@
         <p:cNvGrpSpPr/>
         <p:nvPr/>
       </p:nvGrpSpPr>
-      <p:grpSpPr>
-        <a:xfrm>
-          <a:off x="0" y="0"/>
-          <a:ext cx="0" cy="0"/>
-          <a:chOff x="0" y="0"/>
-          <a:chExt cx="0" cy="0"/>
-        </a:xfrm>
-      </p:grpSpPr>
+      <p:grpSpPr/>
       <p:sp>
         <p:nvSpPr>
           <p:cNvPr id="2" name="NAME"/>
@@ -3717,8 +3780,8 @@
 </p:sld>
 </file>
 
-<file path=ppt/slides/slide6.xml><?xml version="1.0" encoding="utf-8"?>
-<p:sld xmlns:a="http://schemas.openxmlformats.org/drawingml/2006/main" xmlns:r="http://schemas.openxmlformats.org/officeDocument/2006/relationships" xmlns:p="http://schemas.openxmlformats.org/presentationml/2006/main">
+<file path=ppt/slides/slide9.xml><?xml version="1.0" encoding="utf-8"?>
+<p:sld xmlns:a="http://schemas.openxmlformats.org/drawingml/2006/main" xmlns:p="http://schemas.openxmlformats.org/presentationml/2006/main" xmlns:r="http://schemas.openxmlformats.org/officeDocument/2006/relationships">
   <p:cSld>
     <p:spTree>
       <p:nvGrpSpPr>
@@ -3726,14 +3789,7 @@
         <p:cNvGrpSpPr/>
         <p:nvPr/>
       </p:nvGrpSpPr>
-      <p:grpSpPr>
-        <a:xfrm>
-          <a:off x="0" y="0"/>
-          <a:ext cx="0" cy="0"/>
-          <a:chOff x="0" y="0"/>
-          <a:chExt cx="0" cy="0"/>
-        </a:xfrm>
-      </p:grpSpPr>
+      <p:grpSpPr/>
       <p:sp>
         <p:nvSpPr>
           <p:cNvPr id="2" name="TextBox 1"/>
@@ -3758,227 +3814,7 @@
           <a:p>
             <a:r>
               <a:rPr sz="4000"/>
-              <a:t>M grade attendees</a:t>
-            </a:r>
-          </a:p>
-        </p:txBody>
-      </p:sp>
-    </p:spTree>
-  </p:cSld>
-  <p:clrMapOvr>
-    <a:masterClrMapping/>
-  </p:clrMapOvr>
-</p:sld>
-</file>
-
-<file path=ppt/slides/slide7.xml><?xml version="1.0" encoding="utf-8"?>
-<p:sld xmlns:a="http://schemas.openxmlformats.org/drawingml/2006/main" xmlns:r="http://schemas.openxmlformats.org/officeDocument/2006/relationships" xmlns:p="http://schemas.openxmlformats.org/presentationml/2006/main">
-  <p:cSld>
-    <p:spTree>
-      <p:nvGrpSpPr>
-        <p:cNvPr id="1" name=""/>
-        <p:cNvGrpSpPr/>
-        <p:nvPr/>
-      </p:nvGrpSpPr>
-      <p:grpSpPr>
-        <a:xfrm>
-          <a:off x="0" y="0"/>
-          <a:ext cx="0" cy="0"/>
-          <a:chOff x="0" y="0"/>
-          <a:chExt cx="0" cy="0"/>
-        </a:xfrm>
-      </p:grpSpPr>
-      <p:sp>
-        <p:nvSpPr>
-          <p:cNvPr id="2" name="NAME"/>
-          <p:cNvSpPr txBox="1"/>
-          <p:nvPr/>
-        </p:nvSpPr>
-        <p:spPr>
-          <a:xfrm>
-            <a:off x="914400" y="1828800"/>
-            <a:ext cx="7315200" cy="914400"/>
-          </a:xfrm>
-          <a:prstGeom prst="rect">
-            <a:avLst/>
-          </a:prstGeom>
-          <a:noFill/>
-        </p:spPr>
-        <p:txBody>
-          <a:bodyPr wrap="none">
-            <a:spAutoFit/>
-          </a:bodyPr>
-          <a:lstStyle/>
-          <a:p>
-            <a:r>
-              <a:rPr sz="3200"/>
-              <a:t>{{name}}</a:t>
-            </a:r>
-          </a:p>
-        </p:txBody>
-      </p:sp>
-      <p:sp>
-        <p:nvSpPr>
-          <p:cNvPr id="3" name="TITLE"/>
-          <p:cNvSpPr txBox="1"/>
-          <p:nvPr/>
-        </p:nvSpPr>
-        <p:spPr>
-          <a:xfrm>
-            <a:off x="914400" y="2926080"/>
-            <a:ext cx="7315200" cy="914400"/>
-          </a:xfrm>
-          <a:prstGeom prst="rect">
-            <a:avLst/>
-          </a:prstGeom>
-          <a:noFill/>
-        </p:spPr>
-        <p:txBody>
-          <a:bodyPr wrap="none">
-            <a:spAutoFit/>
-          </a:bodyPr>
-          <a:lstStyle/>
-          <a:p>
-            <a:r>
-              <a:rPr sz="2400"/>
-              <a:t>{{title}}</a:t>
-            </a:r>
-          </a:p>
-        </p:txBody>
-      </p:sp>
-    </p:spTree>
-  </p:cSld>
-  <p:clrMapOvr>
-    <a:masterClrMapping/>
-  </p:clrMapOvr>
-</p:sld>
-</file>
-
-<file path=ppt/slides/slide8.xml><?xml version="1.0" encoding="utf-8"?>
-<p:sld xmlns:a="http://schemas.openxmlformats.org/drawingml/2006/main" xmlns:r="http://schemas.openxmlformats.org/officeDocument/2006/relationships" xmlns:p="http://schemas.openxmlformats.org/presentationml/2006/main">
-  <p:cSld>
-    <p:spTree>
-      <p:nvGrpSpPr>
-        <p:cNvPr id="1" name=""/>
-        <p:cNvGrpSpPr/>
-        <p:nvPr/>
-      </p:nvGrpSpPr>
-      <p:grpSpPr>
-        <a:xfrm>
-          <a:off x="0" y="0"/>
-          <a:ext cx="0" cy="0"/>
-          <a:chOff x="0" y="0"/>
-          <a:chExt cx="0" cy="0"/>
-        </a:xfrm>
-      </p:grpSpPr>
-      <p:sp>
-        <p:nvSpPr>
-          <p:cNvPr id="2" name="TextBox 1"/>
-          <p:cNvSpPr txBox="1"/>
-          <p:nvPr/>
-        </p:nvSpPr>
-        <p:spPr>
-          <a:xfrm>
-            <a:off x="914400" y="2286000"/>
-            <a:ext cx="7315200" cy="1371600"/>
-          </a:xfrm>
-          <a:prstGeom prst="rect">
-            <a:avLst/>
-          </a:prstGeom>
-          <a:noFill/>
-        </p:spPr>
-        <p:txBody>
-          <a:bodyPr wrap="none">
-            <a:spAutoFit/>
-          </a:bodyPr>
-          <a:lstStyle/>
-          <a:p>
-            <a:r>
-              <a:rPr sz="4000"/>
-              <a:t>M grade absentees</a:t>
-            </a:r>
-          </a:p>
-        </p:txBody>
-      </p:sp>
-    </p:spTree>
-  </p:cSld>
-  <p:clrMapOvr>
-    <a:masterClrMapping/>
-  </p:clrMapOvr>
-</p:sld>
-</file>
-
-<file path=ppt/slides/slide9.xml><?xml version="1.0" encoding="utf-8"?>
-<p:sld xmlns:a="http://schemas.openxmlformats.org/drawingml/2006/main" xmlns:r="http://schemas.openxmlformats.org/officeDocument/2006/relationships" xmlns:p="http://schemas.openxmlformats.org/presentationml/2006/main">
-  <p:cSld>
-    <p:spTree>
-      <p:nvGrpSpPr>
-        <p:cNvPr id="1" name=""/>
-        <p:cNvGrpSpPr/>
-        <p:nvPr/>
-      </p:nvGrpSpPr>
-      <p:grpSpPr>
-        <a:xfrm>
-          <a:off x="0" y="0"/>
-          <a:ext cx="0" cy="0"/>
-          <a:chOff x="0" y="0"/>
-          <a:chExt cx="0" cy="0"/>
-        </a:xfrm>
-      </p:grpSpPr>
-      <p:sp>
-        <p:nvSpPr>
-          <p:cNvPr id="2" name="NAME"/>
-          <p:cNvSpPr txBox="1"/>
-          <p:nvPr/>
-        </p:nvSpPr>
-        <p:spPr>
-          <a:xfrm>
-            <a:off x="914400" y="1828800"/>
-            <a:ext cx="7315200" cy="914400"/>
-          </a:xfrm>
-          <a:prstGeom prst="rect">
-            <a:avLst/>
-          </a:prstGeom>
-          <a:noFill/>
-        </p:spPr>
-        <p:txBody>
-          <a:bodyPr wrap="none">
-            <a:spAutoFit/>
-          </a:bodyPr>
-          <a:lstStyle/>
-          <a:p>
-            <a:r>
-              <a:rPr sz="3200"/>
-              <a:t>{{name}}</a:t>
-            </a:r>
-          </a:p>
-        </p:txBody>
-      </p:sp>
-      <p:sp>
-        <p:nvSpPr>
-          <p:cNvPr id="3" name="TITLE"/>
-          <p:cNvSpPr txBox="1"/>
-          <p:nvPr/>
-        </p:nvSpPr>
-        <p:spPr>
-          <a:xfrm>
-            <a:off x="914400" y="2926080"/>
-            <a:ext cx="7315200" cy="914400"/>
-          </a:xfrm>
-          <a:prstGeom prst="rect">
-            <a:avLst/>
-          </a:prstGeom>
-          <a:noFill/>
-        </p:spPr>
-        <p:txBody>
-          <a:bodyPr wrap="none">
-            <a:spAutoFit/>
-          </a:bodyPr>
-          <a:lstStyle/>
-          <a:p>
-            <a:r>
-              <a:rPr sz="2400"/>
-              <a:t>{{title}}</a:t>
+              <a:t>F grade attendees</a:t>
             </a:r>
           </a:p>
         </p:txBody>

</xml_diff>

<commit_message>
Add sample data and PySide6 ICU fix
Apply an ICU compatibility workaround in setup.bat that copies the system icuuc.dll next to PySide6 (avoids WinError 127 when conda-forge ships an older ICU). Also add/update test sample data files under tests/sample_data: add "2025-07-10 CDCS-Masterlist.xlsx" and "STE CDCS Promotion Ceremony Deck 2025 v1.pptx", and update participants.xlsx and template.pptx.
</commit_message>
<xml_diff>
--- a/tests/sample_data/template.pptx
+++ b/tests/sample_data/template.pptx
@@ -5,18 +5,19 @@
     <p:sldMasterId id="2147483648" r:id="rId1"/>
   </p:sldMasterIdLst>
   <p:sldIdLst>
-    <p:sldId id="256" r:id="rId7"/>
-    <p:sldId id="257" r:id="rId8"/>
-    <p:sldId id="258" r:id="rId9"/>
-    <p:sldId id="259" r:id="rId10"/>
-    <p:sldId id="260" r:id="rId11"/>
-    <p:sldId id="261" r:id="rId12"/>
-    <p:sldId id="262" r:id="rId13"/>
-    <p:sldId id="263" r:id="rId14"/>
-    <p:sldId id="264" r:id="rId15"/>
-    <p:sldId id="265" r:id="rId16"/>
-    <p:sldId id="266" r:id="rId17"/>
-    <p:sldId id="267" r:id="rId18"/>
+    <p:sldId id="256" r:id="rId2"/>
+    <p:sldId id="268" r:id="rId3"/>
+    <p:sldId id="257" r:id="rId4"/>
+    <p:sldId id="258" r:id="rId5"/>
+    <p:sldId id="259" r:id="rId6"/>
+    <p:sldId id="260" r:id="rId7"/>
+    <p:sldId id="261" r:id="rId8"/>
+    <p:sldId id="262" r:id="rId9"/>
+    <p:sldId id="263" r:id="rId10"/>
+    <p:sldId id="264" r:id="rId11"/>
+    <p:sldId id="265" r:id="rId12"/>
+    <p:sldId id="266" r:id="rId13"/>
+    <p:sldId id="267" r:id="rId14"/>
   </p:sldIdLst>
   <p:sldSz cx="9144000" cy="6858000" type="screen4x3"/>
   <p:notesSz cx="6858000" cy="9144000"/>
@@ -115,6 +116,22 @@
       </a:defRPr>
     </a:lvl9pPr>
   </p:defaultTextStyle>
+  <p:extLst>
+    <p:ext uri="{EFAFB233-063F-42B5-8137-9DF3F51BA10A}">
+      <p15:sldGuideLst xmlns:p15="http://schemas.microsoft.com/office/powerpoint/2012/main">
+        <p15:guide id="1" orient="horz" pos="2160">
+          <p15:clr>
+            <a:srgbClr val="A4A3A4"/>
+          </p15:clr>
+        </p15:guide>
+        <p15:guide id="2" pos="2880">
+          <p15:clr>
+            <a:srgbClr val="A4A3A4"/>
+          </p15:clr>
+        </p15:guide>
+      </p15:sldGuideLst>
+    </p:ext>
+  </p:extLst>
 </p:presentation>
 </file>
 
@@ -156,10 +173,9 @@
           <a:lstStyle/>
           <a:p>
             <a:r>
-              <a:rPr lang="en-US" smtClean="0"/>
+              <a:rPr lang="en-US"/>
               <a:t>Click to edit Master title style</a:t>
             </a:r>
-            <a:endParaRPr lang="en-US"/>
           </a:p>
         </p:txBody>
       </p:sp>
@@ -275,10 +291,9 @@
           </a:lstStyle>
           <a:p>
             <a:r>
-              <a:rPr lang="en-US" smtClean="0"/>
+              <a:rPr lang="en-US"/>
               <a:t>Click to edit Master subtitle style</a:t>
             </a:r>
-            <a:endParaRPr lang="en-US"/>
           </a:p>
         </p:txBody>
       </p:sp>
@@ -299,7 +314,7 @@
           <a:p>
             <a:fld id="{5BCAD085-E8A6-8845-BD4E-CB4CCA059FC4}" type="datetimeFigureOut">
               <a:rPr lang="en-US" smtClean="0"/>
-              <a:t>1/27/13</a:t>
+              <a:t>6/29/2026</a:t>
             </a:fld>
             <a:endParaRPr lang="en-US"/>
           </a:p>
@@ -393,10 +408,9 @@
           <a:lstStyle/>
           <a:p>
             <a:r>
-              <a:rPr lang="en-US" smtClean="0"/>
+              <a:rPr lang="en-US"/>
               <a:t>Click to edit Master title style</a:t>
             </a:r>
-            <a:endParaRPr lang="en-US"/>
           </a:p>
         </p:txBody>
       </p:sp>
@@ -417,38 +431,37 @@
           <a:p>
             <a:pPr lvl="0"/>
             <a:r>
-              <a:rPr lang="en-US" smtClean="0"/>
+              <a:rPr lang="en-US"/>
               <a:t>Click to edit Master text styles</a:t>
             </a:r>
           </a:p>
           <a:p>
             <a:pPr lvl="1"/>
             <a:r>
-              <a:rPr lang="en-US" smtClean="0"/>
+              <a:rPr lang="en-US"/>
               <a:t>Second level</a:t>
             </a:r>
           </a:p>
           <a:p>
             <a:pPr lvl="2"/>
             <a:r>
-              <a:rPr lang="en-US" smtClean="0"/>
+              <a:rPr lang="en-US"/>
               <a:t>Third level</a:t>
             </a:r>
           </a:p>
           <a:p>
             <a:pPr lvl="3"/>
             <a:r>
-              <a:rPr lang="en-US" smtClean="0"/>
+              <a:rPr lang="en-US"/>
               <a:t>Fourth level</a:t>
             </a:r>
           </a:p>
           <a:p>
             <a:pPr lvl="4"/>
             <a:r>
-              <a:rPr lang="en-US" smtClean="0"/>
+              <a:rPr lang="en-US"/>
               <a:t>Fifth level</a:t>
             </a:r>
-            <a:endParaRPr lang="en-US"/>
           </a:p>
         </p:txBody>
       </p:sp>
@@ -469,7 +482,7 @@
           <a:p>
             <a:fld id="{5BCAD085-E8A6-8845-BD4E-CB4CCA059FC4}" type="datetimeFigureOut">
               <a:rPr lang="en-US" smtClean="0"/>
-              <a:t>1/27/13</a:t>
+              <a:t>6/29/2026</a:t>
             </a:fld>
             <a:endParaRPr lang="en-US"/>
           </a:p>
@@ -568,10 +581,9 @@
           <a:lstStyle/>
           <a:p>
             <a:r>
-              <a:rPr lang="en-US" smtClean="0"/>
+              <a:rPr lang="en-US"/>
               <a:t>Click to edit Master title style</a:t>
             </a:r>
-            <a:endParaRPr lang="en-US"/>
           </a:p>
         </p:txBody>
       </p:sp>
@@ -597,38 +609,37 @@
           <a:p>
             <a:pPr lvl="0"/>
             <a:r>
-              <a:rPr lang="en-US" smtClean="0"/>
+              <a:rPr lang="en-US"/>
               <a:t>Click to edit Master text styles</a:t>
             </a:r>
           </a:p>
           <a:p>
             <a:pPr lvl="1"/>
             <a:r>
-              <a:rPr lang="en-US" smtClean="0"/>
+              <a:rPr lang="en-US"/>
               <a:t>Second level</a:t>
             </a:r>
           </a:p>
           <a:p>
             <a:pPr lvl="2"/>
             <a:r>
-              <a:rPr lang="en-US" smtClean="0"/>
+              <a:rPr lang="en-US"/>
               <a:t>Third level</a:t>
             </a:r>
           </a:p>
           <a:p>
             <a:pPr lvl="3"/>
             <a:r>
-              <a:rPr lang="en-US" smtClean="0"/>
+              <a:rPr lang="en-US"/>
               <a:t>Fourth level</a:t>
             </a:r>
           </a:p>
           <a:p>
             <a:pPr lvl="4"/>
             <a:r>
-              <a:rPr lang="en-US" smtClean="0"/>
+              <a:rPr lang="en-US"/>
               <a:t>Fifth level</a:t>
             </a:r>
-            <a:endParaRPr lang="en-US"/>
           </a:p>
         </p:txBody>
       </p:sp>
@@ -649,7 +660,7 @@
           <a:p>
             <a:fld id="{5BCAD085-E8A6-8845-BD4E-CB4CCA059FC4}" type="datetimeFigureOut">
               <a:rPr lang="en-US" smtClean="0"/>
-              <a:t>1/27/13</a:t>
+              <a:t>6/29/2026</a:t>
             </a:fld>
             <a:endParaRPr lang="en-US"/>
           </a:p>
@@ -743,10 +754,9 @@
           <a:lstStyle/>
           <a:p>
             <a:r>
-              <a:rPr lang="en-US" smtClean="0"/>
+              <a:rPr lang="en-US"/>
               <a:t>Click to edit Master title style</a:t>
             </a:r>
-            <a:endParaRPr lang="en-US"/>
           </a:p>
         </p:txBody>
       </p:sp>
@@ -767,38 +777,37 @@
           <a:p>
             <a:pPr lvl="0"/>
             <a:r>
-              <a:rPr lang="en-US" smtClean="0"/>
+              <a:rPr lang="en-US"/>
               <a:t>Click to edit Master text styles</a:t>
             </a:r>
           </a:p>
           <a:p>
             <a:pPr lvl="1"/>
             <a:r>
-              <a:rPr lang="en-US" smtClean="0"/>
+              <a:rPr lang="en-US"/>
               <a:t>Second level</a:t>
             </a:r>
           </a:p>
           <a:p>
             <a:pPr lvl="2"/>
             <a:r>
-              <a:rPr lang="en-US" smtClean="0"/>
+              <a:rPr lang="en-US"/>
               <a:t>Third level</a:t>
             </a:r>
           </a:p>
           <a:p>
             <a:pPr lvl="3"/>
             <a:r>
-              <a:rPr lang="en-US" smtClean="0"/>
+              <a:rPr lang="en-US"/>
               <a:t>Fourth level</a:t>
             </a:r>
           </a:p>
           <a:p>
             <a:pPr lvl="4"/>
             <a:r>
-              <a:rPr lang="en-US" smtClean="0"/>
+              <a:rPr lang="en-US"/>
               <a:t>Fifth level</a:t>
             </a:r>
-            <a:endParaRPr lang="en-US"/>
           </a:p>
         </p:txBody>
       </p:sp>
@@ -819,7 +828,7 @@
           <a:p>
             <a:fld id="{5BCAD085-E8A6-8845-BD4E-CB4CCA059FC4}" type="datetimeFigureOut">
               <a:rPr lang="en-US" smtClean="0"/>
-              <a:t>1/27/13</a:t>
+              <a:t>6/29/2026</a:t>
             </a:fld>
             <a:endParaRPr lang="en-US"/>
           </a:p>
@@ -922,10 +931,9 @@
           </a:lstStyle>
           <a:p>
             <a:r>
-              <a:rPr lang="en-US" smtClean="0"/>
+              <a:rPr lang="en-US"/>
               <a:t>Click to edit Master title style</a:t>
             </a:r>
-            <a:endParaRPr lang="en-US"/>
           </a:p>
         </p:txBody>
       </p:sp>
@@ -1042,7 +1050,7 @@
           <a:p>
             <a:pPr lvl="0"/>
             <a:r>
-              <a:rPr lang="en-US" smtClean="0"/>
+              <a:rPr lang="en-US"/>
               <a:t>Click to edit Master text styles</a:t>
             </a:r>
           </a:p>
@@ -1065,7 +1073,7 @@
           <a:p>
             <a:fld id="{5BCAD085-E8A6-8845-BD4E-CB4CCA059FC4}" type="datetimeFigureOut">
               <a:rPr lang="en-US" smtClean="0"/>
-              <a:t>1/27/13</a:t>
+              <a:t>6/29/2026</a:t>
             </a:fld>
             <a:endParaRPr lang="en-US"/>
           </a:p>
@@ -1159,10 +1167,9 @@
           <a:lstStyle/>
           <a:p>
             <a:r>
-              <a:rPr lang="en-US" smtClean="0"/>
+              <a:rPr lang="en-US"/>
               <a:t>Click to edit Master title style</a:t>
             </a:r>
-            <a:endParaRPr lang="en-US"/>
           </a:p>
         </p:txBody>
       </p:sp>
@@ -1216,38 +1223,37 @@
           <a:p>
             <a:pPr lvl="0"/>
             <a:r>
-              <a:rPr lang="en-US" smtClean="0"/>
+              <a:rPr lang="en-US"/>
               <a:t>Click to edit Master text styles</a:t>
             </a:r>
           </a:p>
           <a:p>
             <a:pPr lvl="1"/>
             <a:r>
-              <a:rPr lang="en-US" smtClean="0"/>
+              <a:rPr lang="en-US"/>
               <a:t>Second level</a:t>
             </a:r>
           </a:p>
           <a:p>
             <a:pPr lvl="2"/>
             <a:r>
-              <a:rPr lang="en-US" smtClean="0"/>
+              <a:rPr lang="en-US"/>
               <a:t>Third level</a:t>
             </a:r>
           </a:p>
           <a:p>
             <a:pPr lvl="3"/>
             <a:r>
-              <a:rPr lang="en-US" smtClean="0"/>
+              <a:rPr lang="en-US"/>
               <a:t>Fourth level</a:t>
             </a:r>
           </a:p>
           <a:p>
             <a:pPr lvl="4"/>
             <a:r>
-              <a:rPr lang="en-US" smtClean="0"/>
+              <a:rPr lang="en-US"/>
               <a:t>Fifth level</a:t>
             </a:r>
-            <a:endParaRPr lang="en-US"/>
           </a:p>
         </p:txBody>
       </p:sp>
@@ -1301,38 +1307,37 @@
           <a:p>
             <a:pPr lvl="0"/>
             <a:r>
-              <a:rPr lang="en-US" smtClean="0"/>
+              <a:rPr lang="en-US"/>
               <a:t>Click to edit Master text styles</a:t>
             </a:r>
           </a:p>
           <a:p>
             <a:pPr lvl="1"/>
             <a:r>
-              <a:rPr lang="en-US" smtClean="0"/>
+              <a:rPr lang="en-US"/>
               <a:t>Second level</a:t>
             </a:r>
           </a:p>
           <a:p>
             <a:pPr lvl="2"/>
             <a:r>
-              <a:rPr lang="en-US" smtClean="0"/>
+              <a:rPr lang="en-US"/>
               <a:t>Third level</a:t>
             </a:r>
           </a:p>
           <a:p>
             <a:pPr lvl="3"/>
             <a:r>
-              <a:rPr lang="en-US" smtClean="0"/>
+              <a:rPr lang="en-US"/>
               <a:t>Fourth level</a:t>
             </a:r>
           </a:p>
           <a:p>
             <a:pPr lvl="4"/>
             <a:r>
-              <a:rPr lang="en-US" smtClean="0"/>
+              <a:rPr lang="en-US"/>
               <a:t>Fifth level</a:t>
             </a:r>
-            <a:endParaRPr lang="en-US"/>
           </a:p>
         </p:txBody>
       </p:sp>
@@ -1353,7 +1358,7 @@
           <a:p>
             <a:fld id="{5BCAD085-E8A6-8845-BD4E-CB4CCA059FC4}" type="datetimeFigureOut">
               <a:rPr lang="en-US" smtClean="0"/>
-              <a:t>1/27/13</a:t>
+              <a:t>6/29/2026</a:t>
             </a:fld>
             <a:endParaRPr lang="en-US"/>
           </a:p>
@@ -1451,10 +1456,9 @@
           </a:lstStyle>
           <a:p>
             <a:r>
-              <a:rPr lang="en-US" smtClean="0"/>
+              <a:rPr lang="en-US"/>
               <a:t>Click to edit Master title style</a:t>
             </a:r>
-            <a:endParaRPr lang="en-US"/>
           </a:p>
         </p:txBody>
       </p:sp>
@@ -1517,7 +1521,7 @@
           <a:p>
             <a:pPr lvl="0"/>
             <a:r>
-              <a:rPr lang="en-US" smtClean="0"/>
+              <a:rPr lang="en-US"/>
               <a:t>Click to edit Master text styles</a:t>
             </a:r>
           </a:p>
@@ -1573,38 +1577,37 @@
           <a:p>
             <a:pPr lvl="0"/>
             <a:r>
-              <a:rPr lang="en-US" smtClean="0"/>
+              <a:rPr lang="en-US"/>
               <a:t>Click to edit Master text styles</a:t>
             </a:r>
           </a:p>
           <a:p>
             <a:pPr lvl="1"/>
             <a:r>
-              <a:rPr lang="en-US" smtClean="0"/>
+              <a:rPr lang="en-US"/>
               <a:t>Second level</a:t>
             </a:r>
           </a:p>
           <a:p>
             <a:pPr lvl="2"/>
             <a:r>
-              <a:rPr lang="en-US" smtClean="0"/>
+              <a:rPr lang="en-US"/>
               <a:t>Third level</a:t>
             </a:r>
           </a:p>
           <a:p>
             <a:pPr lvl="3"/>
             <a:r>
-              <a:rPr lang="en-US" smtClean="0"/>
+              <a:rPr lang="en-US"/>
               <a:t>Fourth level</a:t>
             </a:r>
           </a:p>
           <a:p>
             <a:pPr lvl="4"/>
             <a:r>
-              <a:rPr lang="en-US" smtClean="0"/>
+              <a:rPr lang="en-US"/>
               <a:t>Fifth level</a:t>
             </a:r>
-            <a:endParaRPr lang="en-US"/>
           </a:p>
         </p:txBody>
       </p:sp>
@@ -1667,7 +1670,7 @@
           <a:p>
             <a:pPr lvl="0"/>
             <a:r>
-              <a:rPr lang="en-US" smtClean="0"/>
+              <a:rPr lang="en-US"/>
               <a:t>Click to edit Master text styles</a:t>
             </a:r>
           </a:p>
@@ -1723,38 +1726,37 @@
           <a:p>
             <a:pPr lvl="0"/>
             <a:r>
-              <a:rPr lang="en-US" smtClean="0"/>
+              <a:rPr lang="en-US"/>
               <a:t>Click to edit Master text styles</a:t>
             </a:r>
           </a:p>
           <a:p>
             <a:pPr lvl="1"/>
             <a:r>
-              <a:rPr lang="en-US" smtClean="0"/>
+              <a:rPr lang="en-US"/>
               <a:t>Second level</a:t>
             </a:r>
           </a:p>
           <a:p>
             <a:pPr lvl="2"/>
             <a:r>
-              <a:rPr lang="en-US" smtClean="0"/>
+              <a:rPr lang="en-US"/>
               <a:t>Third level</a:t>
             </a:r>
           </a:p>
           <a:p>
             <a:pPr lvl="3"/>
             <a:r>
-              <a:rPr lang="en-US" smtClean="0"/>
+              <a:rPr lang="en-US"/>
               <a:t>Fourth level</a:t>
             </a:r>
           </a:p>
           <a:p>
             <a:pPr lvl="4"/>
             <a:r>
-              <a:rPr lang="en-US" smtClean="0"/>
+              <a:rPr lang="en-US"/>
               <a:t>Fifth level</a:t>
             </a:r>
-            <a:endParaRPr lang="en-US"/>
           </a:p>
         </p:txBody>
       </p:sp>
@@ -1775,7 +1777,7 @@
           <a:p>
             <a:fld id="{5BCAD085-E8A6-8845-BD4E-CB4CCA059FC4}" type="datetimeFigureOut">
               <a:rPr lang="en-US" smtClean="0"/>
-              <a:t>1/27/13</a:t>
+              <a:t>6/29/2026</a:t>
             </a:fld>
             <a:endParaRPr lang="en-US"/>
           </a:p>
@@ -1869,10 +1871,9 @@
           <a:lstStyle/>
           <a:p>
             <a:r>
-              <a:rPr lang="en-US" smtClean="0"/>
+              <a:rPr lang="en-US"/>
               <a:t>Click to edit Master title style</a:t>
             </a:r>
-            <a:endParaRPr lang="en-US"/>
           </a:p>
         </p:txBody>
       </p:sp>
@@ -1893,7 +1894,7 @@
           <a:p>
             <a:fld id="{5BCAD085-E8A6-8845-BD4E-CB4CCA059FC4}" type="datetimeFigureOut">
               <a:rPr lang="en-US" smtClean="0"/>
-              <a:t>1/27/13</a:t>
+              <a:t>6/29/2026</a:t>
             </a:fld>
             <a:endParaRPr lang="en-US"/>
           </a:p>
@@ -1988,7 +1989,7 @@
           <a:p>
             <a:fld id="{5BCAD085-E8A6-8845-BD4E-CB4CCA059FC4}" type="datetimeFigureOut">
               <a:rPr lang="en-US" smtClean="0"/>
-              <a:t>1/27/13</a:t>
+              <a:t>6/29/2026</a:t>
             </a:fld>
             <a:endParaRPr lang="en-US"/>
           </a:p>
@@ -2091,10 +2092,9 @@
           </a:lstStyle>
           <a:p>
             <a:r>
-              <a:rPr lang="en-US" smtClean="0"/>
+              <a:rPr lang="en-US"/>
               <a:t>Click to edit Master title style</a:t>
             </a:r>
-            <a:endParaRPr lang="en-US"/>
           </a:p>
         </p:txBody>
       </p:sp>
@@ -2148,38 +2148,37 @@
           <a:p>
             <a:pPr lvl="0"/>
             <a:r>
-              <a:rPr lang="en-US" smtClean="0"/>
+              <a:rPr lang="en-US"/>
               <a:t>Click to edit Master text styles</a:t>
             </a:r>
           </a:p>
           <a:p>
             <a:pPr lvl="1"/>
             <a:r>
-              <a:rPr lang="en-US" smtClean="0"/>
+              <a:rPr lang="en-US"/>
               <a:t>Second level</a:t>
             </a:r>
           </a:p>
           <a:p>
             <a:pPr lvl="2"/>
             <a:r>
-              <a:rPr lang="en-US" smtClean="0"/>
+              <a:rPr lang="en-US"/>
               <a:t>Third level</a:t>
             </a:r>
           </a:p>
           <a:p>
             <a:pPr lvl="3"/>
             <a:r>
-              <a:rPr lang="en-US" smtClean="0"/>
+              <a:rPr lang="en-US"/>
               <a:t>Fourth level</a:t>
             </a:r>
           </a:p>
           <a:p>
             <a:pPr lvl="4"/>
             <a:r>
-              <a:rPr lang="en-US" smtClean="0"/>
+              <a:rPr lang="en-US"/>
               <a:t>Fifth level</a:t>
             </a:r>
-            <a:endParaRPr lang="en-US"/>
           </a:p>
         </p:txBody>
       </p:sp>
@@ -2242,7 +2241,7 @@
           <a:p>
             <a:pPr lvl="0"/>
             <a:r>
-              <a:rPr lang="en-US" smtClean="0"/>
+              <a:rPr lang="en-US"/>
               <a:t>Click to edit Master text styles</a:t>
             </a:r>
           </a:p>
@@ -2265,7 +2264,7 @@
           <a:p>
             <a:fld id="{5BCAD085-E8A6-8845-BD4E-CB4CCA059FC4}" type="datetimeFigureOut">
               <a:rPr lang="en-US" smtClean="0"/>
-              <a:t>1/27/13</a:t>
+              <a:t>6/29/2026</a:t>
             </a:fld>
             <a:endParaRPr lang="en-US"/>
           </a:p>
@@ -2368,10 +2367,9 @@
           </a:lstStyle>
           <a:p>
             <a:r>
-              <a:rPr lang="en-US" smtClean="0"/>
+              <a:rPr lang="en-US"/>
               <a:t>Click to edit Master title style</a:t>
             </a:r>
-            <a:endParaRPr lang="en-US"/>
           </a:p>
         </p:txBody>
       </p:sp>
@@ -2495,7 +2493,7 @@
           <a:p>
             <a:pPr lvl="0"/>
             <a:r>
-              <a:rPr lang="en-US" smtClean="0"/>
+              <a:rPr lang="en-US"/>
               <a:t>Click to edit Master text styles</a:t>
             </a:r>
           </a:p>
@@ -2518,7 +2516,7 @@
           <a:p>
             <a:fld id="{5BCAD085-E8A6-8845-BD4E-CB4CCA059FC4}" type="datetimeFigureOut">
               <a:rPr lang="en-US" smtClean="0"/>
-              <a:t>1/27/13</a:t>
+              <a:t>6/29/2026</a:t>
             </a:fld>
             <a:endParaRPr lang="en-US"/>
           </a:p>
@@ -2627,10 +2625,9 @@
           <a:lstStyle/>
           <a:p>
             <a:r>
-              <a:rPr lang="en-US" smtClean="0"/>
+              <a:rPr lang="en-US"/>
               <a:t>Click to edit Master title style</a:t>
             </a:r>
-            <a:endParaRPr lang="en-US"/>
           </a:p>
         </p:txBody>
       </p:sp>
@@ -2661,38 +2658,37 @@
           <a:p>
             <a:pPr lvl="0"/>
             <a:r>
-              <a:rPr lang="en-US" smtClean="0"/>
+              <a:rPr lang="en-US"/>
               <a:t>Click to edit Master text styles</a:t>
             </a:r>
           </a:p>
           <a:p>
             <a:pPr lvl="1"/>
             <a:r>
-              <a:rPr lang="en-US" smtClean="0"/>
+              <a:rPr lang="en-US"/>
               <a:t>Second level</a:t>
             </a:r>
           </a:p>
           <a:p>
             <a:pPr lvl="2"/>
             <a:r>
-              <a:rPr lang="en-US" smtClean="0"/>
+              <a:rPr lang="en-US"/>
               <a:t>Third level</a:t>
             </a:r>
           </a:p>
           <a:p>
             <a:pPr lvl="3"/>
             <a:r>
-              <a:rPr lang="en-US" smtClean="0"/>
+              <a:rPr lang="en-US"/>
               <a:t>Fourth level</a:t>
             </a:r>
           </a:p>
           <a:p>
             <a:pPr lvl="4"/>
             <a:r>
-              <a:rPr lang="en-US" smtClean="0"/>
+              <a:rPr lang="en-US"/>
               <a:t>Fifth level</a:t>
             </a:r>
-            <a:endParaRPr lang="en-US"/>
           </a:p>
         </p:txBody>
       </p:sp>
@@ -2731,7 +2727,7 @@
           <a:p>
             <a:fld id="{5BCAD085-E8A6-8845-BD4E-CB4CCA059FC4}" type="datetimeFigureOut">
               <a:rPr lang="en-US" smtClean="0"/>
-              <a:t>1/27/13</a:t>
+              <a:t>6/29/2026</a:t>
             </a:fld>
             <a:endParaRPr lang="en-US"/>
           </a:p>
@@ -3090,7 +3086,7 @@
 </file>
 
 <file path=ppt/slides/slide1.xml><?xml version="1.0" encoding="utf-8"?>
-<p:sld xmlns:a="http://schemas.openxmlformats.org/drawingml/2006/main" xmlns:p="http://schemas.openxmlformats.org/presentationml/2006/main" xmlns:r="http://schemas.openxmlformats.org/officeDocument/2006/relationships">
+<p:sld xmlns:a="http://schemas.openxmlformats.org/drawingml/2006/main" xmlns:r="http://schemas.openxmlformats.org/officeDocument/2006/relationships" xmlns:p="http://schemas.openxmlformats.org/presentationml/2006/main">
   <p:cSld>
     <p:spTree>
       <p:nvGrpSpPr>
@@ -3098,7 +3094,14 @@
         <p:cNvGrpSpPr/>
         <p:nvPr/>
       </p:nvGrpSpPr>
-      <p:grpSpPr/>
+      <p:grpSpPr>
+        <a:xfrm>
+          <a:off x="0" y="0"/>
+          <a:ext cx="0" cy="0"/>
+          <a:chOff x="0" y="0"/>
+          <a:chExt cx="0" cy="0"/>
+        </a:xfrm>
+      </p:grpSpPr>
       <p:sp>
         <p:nvSpPr>
           <p:cNvPr id="2" name="TextBox 1"/>
@@ -3137,7 +3140,7 @@
 </file>
 
 <file path=ppt/slides/slide10.xml><?xml version="1.0" encoding="utf-8"?>
-<p:sld xmlns:a="http://schemas.openxmlformats.org/drawingml/2006/main" xmlns:p="http://schemas.openxmlformats.org/presentationml/2006/main" xmlns:r="http://schemas.openxmlformats.org/officeDocument/2006/relationships">
+<p:sld xmlns:a="http://schemas.openxmlformats.org/drawingml/2006/main" xmlns:r="http://schemas.openxmlformats.org/officeDocument/2006/relationships" xmlns:p="http://schemas.openxmlformats.org/presentationml/2006/main">
   <p:cSld>
     <p:spTree>
       <p:nvGrpSpPr>
@@ -3145,7 +3148,68 @@
         <p:cNvGrpSpPr/>
         <p:nvPr/>
       </p:nvGrpSpPr>
-      <p:grpSpPr/>
+      <p:grpSpPr>
+        <a:xfrm>
+          <a:off x="0" y="0"/>
+          <a:ext cx="0" cy="0"/>
+          <a:chOff x="0" y="0"/>
+          <a:chExt cx="0" cy="0"/>
+        </a:xfrm>
+      </p:grpSpPr>
+      <p:sp>
+        <p:nvSpPr>
+          <p:cNvPr id="2" name="TextBox 1"/>
+          <p:cNvSpPr txBox="1"/>
+          <p:nvPr/>
+        </p:nvSpPr>
+        <p:spPr>
+          <a:xfrm>
+            <a:off x="914400" y="2286000"/>
+            <a:ext cx="7315200" cy="1371600"/>
+          </a:xfrm>
+          <a:prstGeom prst="rect">
+            <a:avLst/>
+          </a:prstGeom>
+          <a:noFill/>
+        </p:spPr>
+        <p:txBody>
+          <a:bodyPr wrap="none">
+            <a:spAutoFit/>
+          </a:bodyPr>
+          <a:lstStyle/>
+          <a:p>
+            <a:r>
+              <a:rPr sz="4000"/>
+              <a:t>F grade attendees</a:t>
+            </a:r>
+          </a:p>
+        </p:txBody>
+      </p:sp>
+    </p:spTree>
+  </p:cSld>
+  <p:clrMapOvr>
+    <a:masterClrMapping/>
+  </p:clrMapOvr>
+</p:sld>
+</file>
+
+<file path=ppt/slides/slide11.xml><?xml version="1.0" encoding="utf-8"?>
+<p:sld xmlns:a="http://schemas.openxmlformats.org/drawingml/2006/main" xmlns:r="http://schemas.openxmlformats.org/officeDocument/2006/relationships" xmlns:p="http://schemas.openxmlformats.org/presentationml/2006/main">
+  <p:cSld>
+    <p:spTree>
+      <p:nvGrpSpPr>
+        <p:cNvPr id="1" name=""/>
+        <p:cNvGrpSpPr/>
+        <p:nvPr/>
+      </p:nvGrpSpPr>
+      <p:grpSpPr>
+        <a:xfrm>
+          <a:off x="0" y="0"/>
+          <a:ext cx="0" cy="0"/>
+          <a:chOff x="0" y="0"/>
+          <a:chExt cx="0" cy="0"/>
+        </a:xfrm>
+      </p:grpSpPr>
       <p:sp>
         <p:nvSpPr>
           <p:cNvPr id="2" name="NAME"/>
@@ -3212,8 +3276,8 @@
 </p:sld>
 </file>
 
-<file path=ppt/slides/slide11.xml><?xml version="1.0" encoding="utf-8"?>
-<p:sld xmlns:a="http://schemas.openxmlformats.org/drawingml/2006/main" xmlns:p="http://schemas.openxmlformats.org/presentationml/2006/main" xmlns:r="http://schemas.openxmlformats.org/officeDocument/2006/relationships">
+<file path=ppt/slides/slide12.xml><?xml version="1.0" encoding="utf-8"?>
+<p:sld xmlns:a="http://schemas.openxmlformats.org/drawingml/2006/main" xmlns:r="http://schemas.openxmlformats.org/officeDocument/2006/relationships" xmlns:p="http://schemas.openxmlformats.org/presentationml/2006/main">
   <p:cSld>
     <p:spTree>
       <p:nvGrpSpPr>
@@ -3221,7 +3285,14 @@
         <p:cNvGrpSpPr/>
         <p:nvPr/>
       </p:nvGrpSpPr>
-      <p:grpSpPr/>
+      <p:grpSpPr>
+        <a:xfrm>
+          <a:off x="0" y="0"/>
+          <a:ext cx="0" cy="0"/>
+          <a:chOff x="0" y="0"/>
+          <a:chExt cx="0" cy="0"/>
+        </a:xfrm>
+      </p:grpSpPr>
       <p:sp>
         <p:nvSpPr>
           <p:cNvPr id="2" name="TextBox 1"/>
@@ -3259,8 +3330,8 @@
 </p:sld>
 </file>
 
-<file path=ppt/slides/slide12.xml><?xml version="1.0" encoding="utf-8"?>
-<p:sld xmlns:a="http://schemas.openxmlformats.org/drawingml/2006/main" xmlns:p="http://schemas.openxmlformats.org/presentationml/2006/main" xmlns:r="http://schemas.openxmlformats.org/officeDocument/2006/relationships">
+<file path=ppt/slides/slide13.xml><?xml version="1.0" encoding="utf-8"?>
+<p:sld xmlns:a="http://schemas.openxmlformats.org/drawingml/2006/main" xmlns:r="http://schemas.openxmlformats.org/officeDocument/2006/relationships" xmlns:p="http://schemas.openxmlformats.org/presentationml/2006/main">
   <p:cSld>
     <p:spTree>
       <p:nvGrpSpPr>
@@ -3268,7 +3339,14 @@
         <p:cNvGrpSpPr/>
         <p:nvPr/>
       </p:nvGrpSpPr>
-      <p:grpSpPr/>
+      <p:grpSpPr>
+        <a:xfrm>
+          <a:off x="0" y="0"/>
+          <a:ext cx="0" cy="0"/>
+          <a:chOff x="0" y="0"/>
+          <a:chExt cx="0" cy="0"/>
+        </a:xfrm>
+      </p:grpSpPr>
       <p:sp>
         <p:nvSpPr>
           <p:cNvPr id="2" name="NAME"/>
@@ -3336,7 +3414,7 @@
 </file>
 
 <file path=ppt/slides/slide2.xml><?xml version="1.0" encoding="utf-8"?>
-<p:sld xmlns:a="http://schemas.openxmlformats.org/drawingml/2006/main" xmlns:p="http://schemas.openxmlformats.org/presentationml/2006/main" xmlns:r="http://schemas.openxmlformats.org/officeDocument/2006/relationships">
+<p:sld xmlns:a="http://schemas.openxmlformats.org/drawingml/2006/main" xmlns:r="http://schemas.openxmlformats.org/officeDocument/2006/relationships" xmlns:p="http://schemas.openxmlformats.org/presentationml/2006/main">
   <p:cSld>
     <p:spTree>
       <p:nvGrpSpPr>
@@ -3344,7 +3422,185 @@
         <p:cNvGrpSpPr/>
         <p:nvPr/>
       </p:nvGrpSpPr>
-      <p:grpSpPr/>
+      <p:grpSpPr>
+        <a:xfrm>
+          <a:off x="0" y="0"/>
+          <a:ext cx="0" cy="0"/>
+          <a:chOff x="0" y="0"/>
+          <a:chExt cx="0" cy="0"/>
+        </a:xfrm>
+      </p:grpSpPr>
+      <p:sp>
+        <p:nvSpPr>
+          <p:cNvPr id="2" name="Rectangle 1">
+            <a:extLst>
+              <a:ext uri="{FF2B5EF4-FFF2-40B4-BE49-F238E27FC236}">
+                <a16:creationId xmlns:a16="http://schemas.microsoft.com/office/drawing/2014/main" id="{0F57B1E0-5715-ED26-9457-362E8AD0634D}"/>
+              </a:ext>
+            </a:extLst>
+          </p:cNvPr>
+          <p:cNvSpPr/>
+          <p:nvPr/>
+        </p:nvSpPr>
+        <p:spPr>
+          <a:xfrm>
+            <a:off x="1081548" y="648929"/>
+            <a:ext cx="3982065" cy="1258529"/>
+          </a:xfrm>
+          <a:prstGeom prst="rect">
+            <a:avLst/>
+          </a:prstGeom>
+        </p:spPr>
+        <p:style>
+          <a:lnRef idx="1">
+            <a:schemeClr val="accent1"/>
+          </a:lnRef>
+          <a:fillRef idx="3">
+            <a:schemeClr val="accent1"/>
+          </a:fillRef>
+          <a:effectRef idx="2">
+            <a:schemeClr val="accent1"/>
+          </a:effectRef>
+          <a:fontRef idx="minor">
+            <a:schemeClr val="lt1"/>
+          </a:fontRef>
+        </p:style>
+        <p:txBody>
+          <a:bodyPr rtlCol="0" anchor="ctr"/>
+          <a:lstStyle/>
+          <a:p>
+            <a:pPr algn="ctr"/>
+            <a:r>
+              <a:rPr lang="en-SG" dirty="0"/>
+              <a:t>name</a:t>
+            </a:r>
+          </a:p>
+        </p:txBody>
+      </p:sp>
+      <p:sp>
+        <p:nvSpPr>
+          <p:cNvPr id="3" name="Rectangle 2">
+            <a:extLst>
+              <a:ext uri="{FF2B5EF4-FFF2-40B4-BE49-F238E27FC236}">
+                <a16:creationId xmlns:a16="http://schemas.microsoft.com/office/drawing/2014/main" id="{3E9FC97A-DECC-C6B1-6317-4CEF2879EB96}"/>
+              </a:ext>
+            </a:extLst>
+          </p:cNvPr>
+          <p:cNvSpPr/>
+          <p:nvPr/>
+        </p:nvSpPr>
+        <p:spPr>
+          <a:xfrm>
+            <a:off x="1160206" y="2546555"/>
+            <a:ext cx="3982065" cy="1258529"/>
+          </a:xfrm>
+          <a:prstGeom prst="rect">
+            <a:avLst/>
+          </a:prstGeom>
+        </p:spPr>
+        <p:style>
+          <a:lnRef idx="1">
+            <a:schemeClr val="accent1"/>
+          </a:lnRef>
+          <a:fillRef idx="3">
+            <a:schemeClr val="accent1"/>
+          </a:fillRef>
+          <a:effectRef idx="2">
+            <a:schemeClr val="accent1"/>
+          </a:effectRef>
+          <a:fontRef idx="minor">
+            <a:schemeClr val="lt1"/>
+          </a:fontRef>
+        </p:style>
+        <p:txBody>
+          <a:bodyPr rtlCol="0" anchor="ctr"/>
+          <a:lstStyle/>
+          <a:p>
+            <a:pPr algn="ctr"/>
+            <a:r>
+              <a:rPr lang="en-SG" dirty="0"/>
+              <a:t>title</a:t>
+            </a:r>
+          </a:p>
+        </p:txBody>
+      </p:sp>
+      <p:sp>
+        <p:nvSpPr>
+          <p:cNvPr id="4" name="Rectangle 3">
+            <a:extLst>
+              <a:ext uri="{FF2B5EF4-FFF2-40B4-BE49-F238E27FC236}">
+                <a16:creationId xmlns:a16="http://schemas.microsoft.com/office/drawing/2014/main" id="{D60E88F6-7BF8-B5F7-F5D3-C647337C49C4}"/>
+              </a:ext>
+            </a:extLst>
+          </p:cNvPr>
+          <p:cNvSpPr/>
+          <p:nvPr/>
+        </p:nvSpPr>
+        <p:spPr>
+          <a:xfrm>
+            <a:off x="1268360" y="4562168"/>
+            <a:ext cx="3982065" cy="1258529"/>
+          </a:xfrm>
+          <a:prstGeom prst="rect">
+            <a:avLst/>
+          </a:prstGeom>
+        </p:spPr>
+        <p:style>
+          <a:lnRef idx="1">
+            <a:schemeClr val="accent1"/>
+          </a:lnRef>
+          <a:fillRef idx="3">
+            <a:schemeClr val="accent1"/>
+          </a:fillRef>
+          <a:effectRef idx="2">
+            <a:schemeClr val="accent1"/>
+          </a:effectRef>
+          <a:fontRef idx="minor">
+            <a:schemeClr val="lt1"/>
+          </a:fontRef>
+        </p:style>
+        <p:txBody>
+          <a:bodyPr rtlCol="0" anchor="ctr"/>
+          <a:lstStyle/>
+          <a:p>
+            <a:pPr algn="ctr"/>
+            <a:r>
+              <a:rPr lang="en-SG"/>
+              <a:t>BU</a:t>
+            </a:r>
+          </a:p>
+        </p:txBody>
+      </p:sp>
+    </p:spTree>
+    <p:extLst>
+      <p:ext uri="{BB962C8B-B14F-4D97-AF65-F5344CB8AC3E}">
+        <p14:creationId xmlns:p14="http://schemas.microsoft.com/office/powerpoint/2010/main" val="2163112749"/>
+      </p:ext>
+    </p:extLst>
+  </p:cSld>
+  <p:clrMapOvr>
+    <a:masterClrMapping/>
+  </p:clrMapOvr>
+</p:sld>
+</file>
+
+<file path=ppt/slides/slide3.xml><?xml version="1.0" encoding="utf-8"?>
+<p:sld xmlns:a="http://schemas.openxmlformats.org/drawingml/2006/main" xmlns:r="http://schemas.openxmlformats.org/officeDocument/2006/relationships" xmlns:p="http://schemas.openxmlformats.org/presentationml/2006/main">
+  <p:cSld>
+    <p:spTree>
+      <p:nvGrpSpPr>
+        <p:cNvPr id="1" name=""/>
+        <p:cNvGrpSpPr/>
+        <p:nvPr/>
+      </p:nvGrpSpPr>
+      <p:grpSpPr>
+        <a:xfrm>
+          <a:off x="0" y="0"/>
+          <a:ext cx="0" cy="0"/>
+          <a:chOff x="0" y="0"/>
+          <a:chExt cx="0" cy="0"/>
+        </a:xfrm>
+      </p:grpSpPr>
       <p:sp>
         <p:nvSpPr>
           <p:cNvPr id="2" name="NAME"/>
@@ -3411,8 +3667,8 @@
 </p:sld>
 </file>
 
-<file path=ppt/slides/slide3.xml><?xml version="1.0" encoding="utf-8"?>
-<p:sld xmlns:a="http://schemas.openxmlformats.org/drawingml/2006/main" xmlns:p="http://schemas.openxmlformats.org/presentationml/2006/main" xmlns:r="http://schemas.openxmlformats.org/officeDocument/2006/relationships">
+<file path=ppt/slides/slide4.xml><?xml version="1.0" encoding="utf-8"?>
+<p:sld xmlns:a="http://schemas.openxmlformats.org/drawingml/2006/main" xmlns:r="http://schemas.openxmlformats.org/officeDocument/2006/relationships" xmlns:p="http://schemas.openxmlformats.org/presentationml/2006/main">
   <p:cSld>
     <p:spTree>
       <p:nvGrpSpPr>
@@ -3420,7 +3676,14 @@
         <p:cNvGrpSpPr/>
         <p:nvPr/>
       </p:nvGrpSpPr>
-      <p:grpSpPr/>
+      <p:grpSpPr>
+        <a:xfrm>
+          <a:off x="0" y="0"/>
+          <a:ext cx="0" cy="0"/>
+          <a:chOff x="0" y="0"/>
+          <a:chExt cx="0" cy="0"/>
+        </a:xfrm>
+      </p:grpSpPr>
       <p:sp>
         <p:nvSpPr>
           <p:cNvPr id="2" name="TextBox 1"/>
@@ -3458,8 +3721,8 @@
 </p:sld>
 </file>
 
-<file path=ppt/slides/slide4.xml><?xml version="1.0" encoding="utf-8"?>
-<p:sld xmlns:a="http://schemas.openxmlformats.org/drawingml/2006/main" xmlns:p="http://schemas.openxmlformats.org/presentationml/2006/main" xmlns:r="http://schemas.openxmlformats.org/officeDocument/2006/relationships">
+<file path=ppt/slides/slide5.xml><?xml version="1.0" encoding="utf-8"?>
+<p:sld xmlns:a="http://schemas.openxmlformats.org/drawingml/2006/main" xmlns:r="http://schemas.openxmlformats.org/officeDocument/2006/relationships" xmlns:p="http://schemas.openxmlformats.org/presentationml/2006/main">
   <p:cSld>
     <p:spTree>
       <p:nvGrpSpPr>
@@ -3467,7 +3730,14 @@
         <p:cNvGrpSpPr/>
         <p:nvPr/>
       </p:nvGrpSpPr>
-      <p:grpSpPr/>
+      <p:grpSpPr>
+        <a:xfrm>
+          <a:off x="0" y="0"/>
+          <a:ext cx="0" cy="0"/>
+          <a:chOff x="0" y="0"/>
+          <a:chExt cx="0" cy="0"/>
+        </a:xfrm>
+      </p:grpSpPr>
       <p:sp>
         <p:nvSpPr>
           <p:cNvPr id="2" name="NAME"/>
@@ -3534,8 +3804,8 @@
 </p:sld>
 </file>
 
-<file path=ppt/slides/slide5.xml><?xml version="1.0" encoding="utf-8"?>
-<p:sld xmlns:a="http://schemas.openxmlformats.org/drawingml/2006/main" xmlns:p="http://schemas.openxmlformats.org/presentationml/2006/main" xmlns:r="http://schemas.openxmlformats.org/officeDocument/2006/relationships">
+<file path=ppt/slides/slide6.xml><?xml version="1.0" encoding="utf-8"?>
+<p:sld xmlns:a="http://schemas.openxmlformats.org/drawingml/2006/main" xmlns:r="http://schemas.openxmlformats.org/officeDocument/2006/relationships" xmlns:p="http://schemas.openxmlformats.org/presentationml/2006/main">
   <p:cSld>
     <p:spTree>
       <p:nvGrpSpPr>
@@ -3543,7 +3813,14 @@
         <p:cNvGrpSpPr/>
         <p:nvPr/>
       </p:nvGrpSpPr>
-      <p:grpSpPr/>
+      <p:grpSpPr>
+        <a:xfrm>
+          <a:off x="0" y="0"/>
+          <a:ext cx="0" cy="0"/>
+          <a:chOff x="0" y="0"/>
+          <a:chExt cx="0" cy="0"/>
+        </a:xfrm>
+      </p:grpSpPr>
       <p:sp>
         <p:nvSpPr>
           <p:cNvPr id="2" name="TextBox 1"/>
@@ -3581,8 +3858,8 @@
 </p:sld>
 </file>
 
-<file path=ppt/slides/slide6.xml><?xml version="1.0" encoding="utf-8"?>
-<p:sld xmlns:a="http://schemas.openxmlformats.org/drawingml/2006/main" xmlns:p="http://schemas.openxmlformats.org/presentationml/2006/main" xmlns:r="http://schemas.openxmlformats.org/officeDocument/2006/relationships">
+<file path=ppt/slides/slide7.xml><?xml version="1.0" encoding="utf-8"?>
+<p:sld xmlns:a="http://schemas.openxmlformats.org/drawingml/2006/main" xmlns:r="http://schemas.openxmlformats.org/officeDocument/2006/relationships" xmlns:p="http://schemas.openxmlformats.org/presentationml/2006/main">
   <p:cSld>
     <p:spTree>
       <p:nvGrpSpPr>
@@ -3590,7 +3867,14 @@
         <p:cNvGrpSpPr/>
         <p:nvPr/>
       </p:nvGrpSpPr>
-      <p:grpSpPr/>
+      <p:grpSpPr>
+        <a:xfrm>
+          <a:off x="0" y="0"/>
+          <a:ext cx="0" cy="0"/>
+          <a:chOff x="0" y="0"/>
+          <a:chExt cx="0" cy="0"/>
+        </a:xfrm>
+      </p:grpSpPr>
       <p:sp>
         <p:nvSpPr>
           <p:cNvPr id="2" name="NAME"/>
@@ -3657,8 +3941,8 @@
 </p:sld>
 </file>
 
-<file path=ppt/slides/slide7.xml><?xml version="1.0" encoding="utf-8"?>
-<p:sld xmlns:a="http://schemas.openxmlformats.org/drawingml/2006/main" xmlns:p="http://schemas.openxmlformats.org/presentationml/2006/main" xmlns:r="http://schemas.openxmlformats.org/officeDocument/2006/relationships">
+<file path=ppt/slides/slide8.xml><?xml version="1.0" encoding="utf-8"?>
+<p:sld xmlns:a="http://schemas.openxmlformats.org/drawingml/2006/main" xmlns:r="http://schemas.openxmlformats.org/officeDocument/2006/relationships" xmlns:p="http://schemas.openxmlformats.org/presentationml/2006/main">
   <p:cSld>
     <p:spTree>
       <p:nvGrpSpPr>
@@ -3666,7 +3950,14 @@
         <p:cNvGrpSpPr/>
         <p:nvPr/>
       </p:nvGrpSpPr>
-      <p:grpSpPr/>
+      <p:grpSpPr>
+        <a:xfrm>
+          <a:off x="0" y="0"/>
+          <a:ext cx="0" cy="0"/>
+          <a:chOff x="0" y="0"/>
+          <a:chExt cx="0" cy="0"/>
+        </a:xfrm>
+      </p:grpSpPr>
       <p:sp>
         <p:nvSpPr>
           <p:cNvPr id="2" name="TextBox 1"/>
@@ -3704,8 +3995,8 @@
 </p:sld>
 </file>
 
-<file path=ppt/slides/slide8.xml><?xml version="1.0" encoding="utf-8"?>
-<p:sld xmlns:a="http://schemas.openxmlformats.org/drawingml/2006/main" xmlns:p="http://schemas.openxmlformats.org/presentationml/2006/main" xmlns:r="http://schemas.openxmlformats.org/officeDocument/2006/relationships">
+<file path=ppt/slides/slide9.xml><?xml version="1.0" encoding="utf-8"?>
+<p:sld xmlns:a="http://schemas.openxmlformats.org/drawingml/2006/main" xmlns:r="http://schemas.openxmlformats.org/officeDocument/2006/relationships" xmlns:p="http://schemas.openxmlformats.org/presentationml/2006/main">
   <p:cSld>
     <p:spTree>
       <p:nvGrpSpPr>
@@ -3713,7 +4004,14 @@
         <p:cNvGrpSpPr/>
         <p:nvPr/>
       </p:nvGrpSpPr>
-      <p:grpSpPr/>
+      <p:grpSpPr>
+        <a:xfrm>
+          <a:off x="0" y="0"/>
+          <a:ext cx="0" cy="0"/>
+          <a:chOff x="0" y="0"/>
+          <a:chExt cx="0" cy="0"/>
+        </a:xfrm>
+      </p:grpSpPr>
       <p:sp>
         <p:nvSpPr>
           <p:cNvPr id="2" name="NAME"/>
@@ -3768,53 +4066,6 @@
             <a:r>
               <a:rPr sz="2400"/>
               <a:t>{{title}}</a:t>
-            </a:r>
-          </a:p>
-        </p:txBody>
-      </p:sp>
-    </p:spTree>
-  </p:cSld>
-  <p:clrMapOvr>
-    <a:masterClrMapping/>
-  </p:clrMapOvr>
-</p:sld>
-</file>
-
-<file path=ppt/slides/slide9.xml><?xml version="1.0" encoding="utf-8"?>
-<p:sld xmlns:a="http://schemas.openxmlformats.org/drawingml/2006/main" xmlns:p="http://schemas.openxmlformats.org/presentationml/2006/main" xmlns:r="http://schemas.openxmlformats.org/officeDocument/2006/relationships">
-  <p:cSld>
-    <p:spTree>
-      <p:nvGrpSpPr>
-        <p:cNvPr id="1" name=""/>
-        <p:cNvGrpSpPr/>
-        <p:nvPr/>
-      </p:nvGrpSpPr>
-      <p:grpSpPr/>
-      <p:sp>
-        <p:nvSpPr>
-          <p:cNvPr id="2" name="TextBox 1"/>
-          <p:cNvSpPr txBox="1"/>
-          <p:nvPr/>
-        </p:nvSpPr>
-        <p:spPr>
-          <a:xfrm>
-            <a:off x="914400" y="2286000"/>
-            <a:ext cx="7315200" cy="1371600"/>
-          </a:xfrm>
-          <a:prstGeom prst="rect">
-            <a:avLst/>
-          </a:prstGeom>
-          <a:noFill/>
-        </p:spPr>
-        <p:txBody>
-          <a:bodyPr wrap="none">
-            <a:spAutoFit/>
-          </a:bodyPr>
-          <a:lstStyle/>
-          <a:p>
-            <a:r>
-              <a:rPr sz="4000"/>
-              <a:t>F grade attendees</a:t>
             </a:r>
           </a:p>
         </p:txBody>

</xml_diff>

<commit_message>
Add QR generation and seat/BU support
Adds per-participant QR PNG generation and end-to-end support for seat_no and BU fields.
</commit_message>
<xml_diff>
--- a/tests/sample_data/template.pptx
+++ b/tests/sample_data/template.pptx
@@ -5,19 +5,18 @@
     <p:sldMasterId id="2147483648" r:id="rId1"/>
   </p:sldMasterIdLst>
   <p:sldIdLst>
-    <p:sldId id="256" r:id="rId2"/>
-    <p:sldId id="268" r:id="rId3"/>
-    <p:sldId id="257" r:id="rId4"/>
-    <p:sldId id="258" r:id="rId5"/>
-    <p:sldId id="259" r:id="rId6"/>
-    <p:sldId id="260" r:id="rId7"/>
-    <p:sldId id="261" r:id="rId8"/>
-    <p:sldId id="262" r:id="rId9"/>
-    <p:sldId id="263" r:id="rId10"/>
-    <p:sldId id="264" r:id="rId11"/>
-    <p:sldId id="265" r:id="rId12"/>
-    <p:sldId id="266" r:id="rId13"/>
-    <p:sldId id="267" r:id="rId14"/>
+    <p:sldId id="256" r:id="rId7"/>
+    <p:sldId id="257" r:id="rId8"/>
+    <p:sldId id="258" r:id="rId9"/>
+    <p:sldId id="259" r:id="rId10"/>
+    <p:sldId id="260" r:id="rId11"/>
+    <p:sldId id="261" r:id="rId12"/>
+    <p:sldId id="262" r:id="rId13"/>
+    <p:sldId id="263" r:id="rId14"/>
+    <p:sldId id="264" r:id="rId15"/>
+    <p:sldId id="265" r:id="rId16"/>
+    <p:sldId id="266" r:id="rId17"/>
+    <p:sldId id="267" r:id="rId18"/>
   </p:sldIdLst>
   <p:sldSz cx="9144000" cy="6858000" type="screen4x3"/>
   <p:notesSz cx="6858000" cy="9144000"/>
@@ -116,22 +115,6 @@
       </a:defRPr>
     </a:lvl9pPr>
   </p:defaultTextStyle>
-  <p:extLst>
-    <p:ext uri="{EFAFB233-063F-42B5-8137-9DF3F51BA10A}">
-      <p15:sldGuideLst xmlns:p15="http://schemas.microsoft.com/office/powerpoint/2012/main">
-        <p15:guide id="1" orient="horz" pos="2160">
-          <p15:clr>
-            <a:srgbClr val="A4A3A4"/>
-          </p15:clr>
-        </p15:guide>
-        <p15:guide id="2" pos="2880">
-          <p15:clr>
-            <a:srgbClr val="A4A3A4"/>
-          </p15:clr>
-        </p15:guide>
-      </p15:sldGuideLst>
-    </p:ext>
-  </p:extLst>
 </p:presentation>
 </file>
 
@@ -173,9 +156,10 @@
           <a:lstStyle/>
           <a:p>
             <a:r>
-              <a:rPr lang="en-US"/>
+              <a:rPr lang="en-US" smtClean="0"/>
               <a:t>Click to edit Master title style</a:t>
             </a:r>
+            <a:endParaRPr lang="en-US"/>
           </a:p>
         </p:txBody>
       </p:sp>
@@ -291,9 +275,10 @@
           </a:lstStyle>
           <a:p>
             <a:r>
-              <a:rPr lang="en-US"/>
+              <a:rPr lang="en-US" smtClean="0"/>
               <a:t>Click to edit Master subtitle style</a:t>
             </a:r>
+            <a:endParaRPr lang="en-US"/>
           </a:p>
         </p:txBody>
       </p:sp>
@@ -314,7 +299,7 @@
           <a:p>
             <a:fld id="{5BCAD085-E8A6-8845-BD4E-CB4CCA059FC4}" type="datetimeFigureOut">
               <a:rPr lang="en-US" smtClean="0"/>
-              <a:t>6/29/2026</a:t>
+              <a:t>1/27/13</a:t>
             </a:fld>
             <a:endParaRPr lang="en-US"/>
           </a:p>
@@ -408,9 +393,10 @@
           <a:lstStyle/>
           <a:p>
             <a:r>
-              <a:rPr lang="en-US"/>
+              <a:rPr lang="en-US" smtClean="0"/>
               <a:t>Click to edit Master title style</a:t>
             </a:r>
+            <a:endParaRPr lang="en-US"/>
           </a:p>
         </p:txBody>
       </p:sp>
@@ -431,37 +417,38 @@
           <a:p>
             <a:pPr lvl="0"/>
             <a:r>
-              <a:rPr lang="en-US"/>
+              <a:rPr lang="en-US" smtClean="0"/>
               <a:t>Click to edit Master text styles</a:t>
             </a:r>
           </a:p>
           <a:p>
             <a:pPr lvl="1"/>
             <a:r>
-              <a:rPr lang="en-US"/>
+              <a:rPr lang="en-US" smtClean="0"/>
               <a:t>Second level</a:t>
             </a:r>
           </a:p>
           <a:p>
             <a:pPr lvl="2"/>
             <a:r>
-              <a:rPr lang="en-US"/>
+              <a:rPr lang="en-US" smtClean="0"/>
               <a:t>Third level</a:t>
             </a:r>
           </a:p>
           <a:p>
             <a:pPr lvl="3"/>
             <a:r>
-              <a:rPr lang="en-US"/>
+              <a:rPr lang="en-US" smtClean="0"/>
               <a:t>Fourth level</a:t>
             </a:r>
           </a:p>
           <a:p>
             <a:pPr lvl="4"/>
             <a:r>
-              <a:rPr lang="en-US"/>
+              <a:rPr lang="en-US" smtClean="0"/>
               <a:t>Fifth level</a:t>
             </a:r>
+            <a:endParaRPr lang="en-US"/>
           </a:p>
         </p:txBody>
       </p:sp>
@@ -482,7 +469,7 @@
           <a:p>
             <a:fld id="{5BCAD085-E8A6-8845-BD4E-CB4CCA059FC4}" type="datetimeFigureOut">
               <a:rPr lang="en-US" smtClean="0"/>
-              <a:t>6/29/2026</a:t>
+              <a:t>1/27/13</a:t>
             </a:fld>
             <a:endParaRPr lang="en-US"/>
           </a:p>
@@ -581,9 +568,10 @@
           <a:lstStyle/>
           <a:p>
             <a:r>
-              <a:rPr lang="en-US"/>
+              <a:rPr lang="en-US" smtClean="0"/>
               <a:t>Click to edit Master title style</a:t>
             </a:r>
+            <a:endParaRPr lang="en-US"/>
           </a:p>
         </p:txBody>
       </p:sp>
@@ -609,37 +597,38 @@
           <a:p>
             <a:pPr lvl="0"/>
             <a:r>
-              <a:rPr lang="en-US"/>
+              <a:rPr lang="en-US" smtClean="0"/>
               <a:t>Click to edit Master text styles</a:t>
             </a:r>
           </a:p>
           <a:p>
             <a:pPr lvl="1"/>
             <a:r>
-              <a:rPr lang="en-US"/>
+              <a:rPr lang="en-US" smtClean="0"/>
               <a:t>Second level</a:t>
             </a:r>
           </a:p>
           <a:p>
             <a:pPr lvl="2"/>
             <a:r>
-              <a:rPr lang="en-US"/>
+              <a:rPr lang="en-US" smtClean="0"/>
               <a:t>Third level</a:t>
             </a:r>
           </a:p>
           <a:p>
             <a:pPr lvl="3"/>
             <a:r>
-              <a:rPr lang="en-US"/>
+              <a:rPr lang="en-US" smtClean="0"/>
               <a:t>Fourth level</a:t>
             </a:r>
           </a:p>
           <a:p>
             <a:pPr lvl="4"/>
             <a:r>
-              <a:rPr lang="en-US"/>
+              <a:rPr lang="en-US" smtClean="0"/>
               <a:t>Fifth level</a:t>
             </a:r>
+            <a:endParaRPr lang="en-US"/>
           </a:p>
         </p:txBody>
       </p:sp>
@@ -660,7 +649,7 @@
           <a:p>
             <a:fld id="{5BCAD085-E8A6-8845-BD4E-CB4CCA059FC4}" type="datetimeFigureOut">
               <a:rPr lang="en-US" smtClean="0"/>
-              <a:t>6/29/2026</a:t>
+              <a:t>1/27/13</a:t>
             </a:fld>
             <a:endParaRPr lang="en-US"/>
           </a:p>
@@ -754,9 +743,10 @@
           <a:lstStyle/>
           <a:p>
             <a:r>
-              <a:rPr lang="en-US"/>
+              <a:rPr lang="en-US" smtClean="0"/>
               <a:t>Click to edit Master title style</a:t>
             </a:r>
+            <a:endParaRPr lang="en-US"/>
           </a:p>
         </p:txBody>
       </p:sp>
@@ -777,37 +767,38 @@
           <a:p>
             <a:pPr lvl="0"/>
             <a:r>
-              <a:rPr lang="en-US"/>
+              <a:rPr lang="en-US" smtClean="0"/>
               <a:t>Click to edit Master text styles</a:t>
             </a:r>
           </a:p>
           <a:p>
             <a:pPr lvl="1"/>
             <a:r>
-              <a:rPr lang="en-US"/>
+              <a:rPr lang="en-US" smtClean="0"/>
               <a:t>Second level</a:t>
             </a:r>
           </a:p>
           <a:p>
             <a:pPr lvl="2"/>
             <a:r>
-              <a:rPr lang="en-US"/>
+              <a:rPr lang="en-US" smtClean="0"/>
               <a:t>Third level</a:t>
             </a:r>
           </a:p>
           <a:p>
             <a:pPr lvl="3"/>
             <a:r>
-              <a:rPr lang="en-US"/>
+              <a:rPr lang="en-US" smtClean="0"/>
               <a:t>Fourth level</a:t>
             </a:r>
           </a:p>
           <a:p>
             <a:pPr lvl="4"/>
             <a:r>
-              <a:rPr lang="en-US"/>
+              <a:rPr lang="en-US" smtClean="0"/>
               <a:t>Fifth level</a:t>
             </a:r>
+            <a:endParaRPr lang="en-US"/>
           </a:p>
         </p:txBody>
       </p:sp>
@@ -828,7 +819,7 @@
           <a:p>
             <a:fld id="{5BCAD085-E8A6-8845-BD4E-CB4CCA059FC4}" type="datetimeFigureOut">
               <a:rPr lang="en-US" smtClean="0"/>
-              <a:t>6/29/2026</a:t>
+              <a:t>1/27/13</a:t>
             </a:fld>
             <a:endParaRPr lang="en-US"/>
           </a:p>
@@ -931,9 +922,10 @@
           </a:lstStyle>
           <a:p>
             <a:r>
-              <a:rPr lang="en-US"/>
+              <a:rPr lang="en-US" smtClean="0"/>
               <a:t>Click to edit Master title style</a:t>
             </a:r>
+            <a:endParaRPr lang="en-US"/>
           </a:p>
         </p:txBody>
       </p:sp>
@@ -1050,7 +1042,7 @@
           <a:p>
             <a:pPr lvl="0"/>
             <a:r>
-              <a:rPr lang="en-US"/>
+              <a:rPr lang="en-US" smtClean="0"/>
               <a:t>Click to edit Master text styles</a:t>
             </a:r>
           </a:p>
@@ -1073,7 +1065,7 @@
           <a:p>
             <a:fld id="{5BCAD085-E8A6-8845-BD4E-CB4CCA059FC4}" type="datetimeFigureOut">
               <a:rPr lang="en-US" smtClean="0"/>
-              <a:t>6/29/2026</a:t>
+              <a:t>1/27/13</a:t>
             </a:fld>
             <a:endParaRPr lang="en-US"/>
           </a:p>
@@ -1167,9 +1159,10 @@
           <a:lstStyle/>
           <a:p>
             <a:r>
-              <a:rPr lang="en-US"/>
+              <a:rPr lang="en-US" smtClean="0"/>
               <a:t>Click to edit Master title style</a:t>
             </a:r>
+            <a:endParaRPr lang="en-US"/>
           </a:p>
         </p:txBody>
       </p:sp>
@@ -1223,37 +1216,38 @@
           <a:p>
             <a:pPr lvl="0"/>
             <a:r>
-              <a:rPr lang="en-US"/>
+              <a:rPr lang="en-US" smtClean="0"/>
               <a:t>Click to edit Master text styles</a:t>
             </a:r>
           </a:p>
           <a:p>
             <a:pPr lvl="1"/>
             <a:r>
-              <a:rPr lang="en-US"/>
+              <a:rPr lang="en-US" smtClean="0"/>
               <a:t>Second level</a:t>
             </a:r>
           </a:p>
           <a:p>
             <a:pPr lvl="2"/>
             <a:r>
-              <a:rPr lang="en-US"/>
+              <a:rPr lang="en-US" smtClean="0"/>
               <a:t>Third level</a:t>
             </a:r>
           </a:p>
           <a:p>
             <a:pPr lvl="3"/>
             <a:r>
-              <a:rPr lang="en-US"/>
+              <a:rPr lang="en-US" smtClean="0"/>
               <a:t>Fourth level</a:t>
             </a:r>
           </a:p>
           <a:p>
             <a:pPr lvl="4"/>
             <a:r>
-              <a:rPr lang="en-US"/>
+              <a:rPr lang="en-US" smtClean="0"/>
               <a:t>Fifth level</a:t>
             </a:r>
+            <a:endParaRPr lang="en-US"/>
           </a:p>
         </p:txBody>
       </p:sp>
@@ -1307,37 +1301,38 @@
           <a:p>
             <a:pPr lvl="0"/>
             <a:r>
-              <a:rPr lang="en-US"/>
+              <a:rPr lang="en-US" smtClean="0"/>
               <a:t>Click to edit Master text styles</a:t>
             </a:r>
           </a:p>
           <a:p>
             <a:pPr lvl="1"/>
             <a:r>
-              <a:rPr lang="en-US"/>
+              <a:rPr lang="en-US" smtClean="0"/>
               <a:t>Second level</a:t>
             </a:r>
           </a:p>
           <a:p>
             <a:pPr lvl="2"/>
             <a:r>
-              <a:rPr lang="en-US"/>
+              <a:rPr lang="en-US" smtClean="0"/>
               <a:t>Third level</a:t>
             </a:r>
           </a:p>
           <a:p>
             <a:pPr lvl="3"/>
             <a:r>
-              <a:rPr lang="en-US"/>
+              <a:rPr lang="en-US" smtClean="0"/>
               <a:t>Fourth level</a:t>
             </a:r>
           </a:p>
           <a:p>
             <a:pPr lvl="4"/>
             <a:r>
-              <a:rPr lang="en-US"/>
+              <a:rPr lang="en-US" smtClean="0"/>
               <a:t>Fifth level</a:t>
             </a:r>
+            <a:endParaRPr lang="en-US"/>
           </a:p>
         </p:txBody>
       </p:sp>
@@ -1358,7 +1353,7 @@
           <a:p>
             <a:fld id="{5BCAD085-E8A6-8845-BD4E-CB4CCA059FC4}" type="datetimeFigureOut">
               <a:rPr lang="en-US" smtClean="0"/>
-              <a:t>6/29/2026</a:t>
+              <a:t>1/27/13</a:t>
             </a:fld>
             <a:endParaRPr lang="en-US"/>
           </a:p>
@@ -1456,9 +1451,10 @@
           </a:lstStyle>
           <a:p>
             <a:r>
-              <a:rPr lang="en-US"/>
+              <a:rPr lang="en-US" smtClean="0"/>
               <a:t>Click to edit Master title style</a:t>
             </a:r>
+            <a:endParaRPr lang="en-US"/>
           </a:p>
         </p:txBody>
       </p:sp>
@@ -1521,7 +1517,7 @@
           <a:p>
             <a:pPr lvl="0"/>
             <a:r>
-              <a:rPr lang="en-US"/>
+              <a:rPr lang="en-US" smtClean="0"/>
               <a:t>Click to edit Master text styles</a:t>
             </a:r>
           </a:p>
@@ -1577,37 +1573,38 @@
           <a:p>
             <a:pPr lvl="0"/>
             <a:r>
-              <a:rPr lang="en-US"/>
+              <a:rPr lang="en-US" smtClean="0"/>
               <a:t>Click to edit Master text styles</a:t>
             </a:r>
           </a:p>
           <a:p>
             <a:pPr lvl="1"/>
             <a:r>
-              <a:rPr lang="en-US"/>
+              <a:rPr lang="en-US" smtClean="0"/>
               <a:t>Second level</a:t>
             </a:r>
           </a:p>
           <a:p>
             <a:pPr lvl="2"/>
             <a:r>
-              <a:rPr lang="en-US"/>
+              <a:rPr lang="en-US" smtClean="0"/>
               <a:t>Third level</a:t>
             </a:r>
           </a:p>
           <a:p>
             <a:pPr lvl="3"/>
             <a:r>
-              <a:rPr lang="en-US"/>
+              <a:rPr lang="en-US" smtClean="0"/>
               <a:t>Fourth level</a:t>
             </a:r>
           </a:p>
           <a:p>
             <a:pPr lvl="4"/>
             <a:r>
-              <a:rPr lang="en-US"/>
+              <a:rPr lang="en-US" smtClean="0"/>
               <a:t>Fifth level</a:t>
             </a:r>
+            <a:endParaRPr lang="en-US"/>
           </a:p>
         </p:txBody>
       </p:sp>
@@ -1670,7 +1667,7 @@
           <a:p>
             <a:pPr lvl="0"/>
             <a:r>
-              <a:rPr lang="en-US"/>
+              <a:rPr lang="en-US" smtClean="0"/>
               <a:t>Click to edit Master text styles</a:t>
             </a:r>
           </a:p>
@@ -1726,37 +1723,38 @@
           <a:p>
             <a:pPr lvl="0"/>
             <a:r>
-              <a:rPr lang="en-US"/>
+              <a:rPr lang="en-US" smtClean="0"/>
               <a:t>Click to edit Master text styles</a:t>
             </a:r>
           </a:p>
           <a:p>
             <a:pPr lvl="1"/>
             <a:r>
-              <a:rPr lang="en-US"/>
+              <a:rPr lang="en-US" smtClean="0"/>
               <a:t>Second level</a:t>
             </a:r>
           </a:p>
           <a:p>
             <a:pPr lvl="2"/>
             <a:r>
-              <a:rPr lang="en-US"/>
+              <a:rPr lang="en-US" smtClean="0"/>
               <a:t>Third level</a:t>
             </a:r>
           </a:p>
           <a:p>
             <a:pPr lvl="3"/>
             <a:r>
-              <a:rPr lang="en-US"/>
+              <a:rPr lang="en-US" smtClean="0"/>
               <a:t>Fourth level</a:t>
             </a:r>
           </a:p>
           <a:p>
             <a:pPr lvl="4"/>
             <a:r>
-              <a:rPr lang="en-US"/>
+              <a:rPr lang="en-US" smtClean="0"/>
               <a:t>Fifth level</a:t>
             </a:r>
+            <a:endParaRPr lang="en-US"/>
           </a:p>
         </p:txBody>
       </p:sp>
@@ -1777,7 +1775,7 @@
           <a:p>
             <a:fld id="{5BCAD085-E8A6-8845-BD4E-CB4CCA059FC4}" type="datetimeFigureOut">
               <a:rPr lang="en-US" smtClean="0"/>
-              <a:t>6/29/2026</a:t>
+              <a:t>1/27/13</a:t>
             </a:fld>
             <a:endParaRPr lang="en-US"/>
           </a:p>
@@ -1871,9 +1869,10 @@
           <a:lstStyle/>
           <a:p>
             <a:r>
-              <a:rPr lang="en-US"/>
+              <a:rPr lang="en-US" smtClean="0"/>
               <a:t>Click to edit Master title style</a:t>
             </a:r>
+            <a:endParaRPr lang="en-US"/>
           </a:p>
         </p:txBody>
       </p:sp>
@@ -1894,7 +1893,7 @@
           <a:p>
             <a:fld id="{5BCAD085-E8A6-8845-BD4E-CB4CCA059FC4}" type="datetimeFigureOut">
               <a:rPr lang="en-US" smtClean="0"/>
-              <a:t>6/29/2026</a:t>
+              <a:t>1/27/13</a:t>
             </a:fld>
             <a:endParaRPr lang="en-US"/>
           </a:p>
@@ -1989,7 +1988,7 @@
           <a:p>
             <a:fld id="{5BCAD085-E8A6-8845-BD4E-CB4CCA059FC4}" type="datetimeFigureOut">
               <a:rPr lang="en-US" smtClean="0"/>
-              <a:t>6/29/2026</a:t>
+              <a:t>1/27/13</a:t>
             </a:fld>
             <a:endParaRPr lang="en-US"/>
           </a:p>
@@ -2092,9 +2091,10 @@
           </a:lstStyle>
           <a:p>
             <a:r>
-              <a:rPr lang="en-US"/>
+              <a:rPr lang="en-US" smtClean="0"/>
               <a:t>Click to edit Master title style</a:t>
             </a:r>
+            <a:endParaRPr lang="en-US"/>
           </a:p>
         </p:txBody>
       </p:sp>
@@ -2148,37 +2148,38 @@
           <a:p>
             <a:pPr lvl="0"/>
             <a:r>
-              <a:rPr lang="en-US"/>
+              <a:rPr lang="en-US" smtClean="0"/>
               <a:t>Click to edit Master text styles</a:t>
             </a:r>
           </a:p>
           <a:p>
             <a:pPr lvl="1"/>
             <a:r>
-              <a:rPr lang="en-US"/>
+              <a:rPr lang="en-US" smtClean="0"/>
               <a:t>Second level</a:t>
             </a:r>
           </a:p>
           <a:p>
             <a:pPr lvl="2"/>
             <a:r>
-              <a:rPr lang="en-US"/>
+              <a:rPr lang="en-US" smtClean="0"/>
               <a:t>Third level</a:t>
             </a:r>
           </a:p>
           <a:p>
             <a:pPr lvl="3"/>
             <a:r>
-              <a:rPr lang="en-US"/>
+              <a:rPr lang="en-US" smtClean="0"/>
               <a:t>Fourth level</a:t>
             </a:r>
           </a:p>
           <a:p>
             <a:pPr lvl="4"/>
             <a:r>
-              <a:rPr lang="en-US"/>
+              <a:rPr lang="en-US" smtClean="0"/>
               <a:t>Fifth level</a:t>
             </a:r>
+            <a:endParaRPr lang="en-US"/>
           </a:p>
         </p:txBody>
       </p:sp>
@@ -2241,7 +2242,7 @@
           <a:p>
             <a:pPr lvl="0"/>
             <a:r>
-              <a:rPr lang="en-US"/>
+              <a:rPr lang="en-US" smtClean="0"/>
               <a:t>Click to edit Master text styles</a:t>
             </a:r>
           </a:p>
@@ -2264,7 +2265,7 @@
           <a:p>
             <a:fld id="{5BCAD085-E8A6-8845-BD4E-CB4CCA059FC4}" type="datetimeFigureOut">
               <a:rPr lang="en-US" smtClean="0"/>
-              <a:t>6/29/2026</a:t>
+              <a:t>1/27/13</a:t>
             </a:fld>
             <a:endParaRPr lang="en-US"/>
           </a:p>
@@ -2367,9 +2368,10 @@
           </a:lstStyle>
           <a:p>
             <a:r>
-              <a:rPr lang="en-US"/>
+              <a:rPr lang="en-US" smtClean="0"/>
               <a:t>Click to edit Master title style</a:t>
             </a:r>
+            <a:endParaRPr lang="en-US"/>
           </a:p>
         </p:txBody>
       </p:sp>
@@ -2493,7 +2495,7 @@
           <a:p>
             <a:pPr lvl="0"/>
             <a:r>
-              <a:rPr lang="en-US"/>
+              <a:rPr lang="en-US" smtClean="0"/>
               <a:t>Click to edit Master text styles</a:t>
             </a:r>
           </a:p>
@@ -2516,7 +2518,7 @@
           <a:p>
             <a:fld id="{5BCAD085-E8A6-8845-BD4E-CB4CCA059FC4}" type="datetimeFigureOut">
               <a:rPr lang="en-US" smtClean="0"/>
-              <a:t>6/29/2026</a:t>
+              <a:t>1/27/13</a:t>
             </a:fld>
             <a:endParaRPr lang="en-US"/>
           </a:p>
@@ -2625,9 +2627,10 @@
           <a:lstStyle/>
           <a:p>
             <a:r>
-              <a:rPr lang="en-US"/>
+              <a:rPr lang="en-US" smtClean="0"/>
               <a:t>Click to edit Master title style</a:t>
             </a:r>
+            <a:endParaRPr lang="en-US"/>
           </a:p>
         </p:txBody>
       </p:sp>
@@ -2658,37 +2661,38 @@
           <a:p>
             <a:pPr lvl="0"/>
             <a:r>
-              <a:rPr lang="en-US"/>
+              <a:rPr lang="en-US" smtClean="0"/>
               <a:t>Click to edit Master text styles</a:t>
             </a:r>
           </a:p>
           <a:p>
             <a:pPr lvl="1"/>
             <a:r>
-              <a:rPr lang="en-US"/>
+              <a:rPr lang="en-US" smtClean="0"/>
               <a:t>Second level</a:t>
             </a:r>
           </a:p>
           <a:p>
             <a:pPr lvl="2"/>
             <a:r>
-              <a:rPr lang="en-US"/>
+              <a:rPr lang="en-US" smtClean="0"/>
               <a:t>Third level</a:t>
             </a:r>
           </a:p>
           <a:p>
             <a:pPr lvl="3"/>
             <a:r>
-              <a:rPr lang="en-US"/>
+              <a:rPr lang="en-US" smtClean="0"/>
               <a:t>Fourth level</a:t>
             </a:r>
           </a:p>
           <a:p>
             <a:pPr lvl="4"/>
             <a:r>
-              <a:rPr lang="en-US"/>
+              <a:rPr lang="en-US" smtClean="0"/>
               <a:t>Fifth level</a:t>
             </a:r>
+            <a:endParaRPr lang="en-US"/>
           </a:p>
         </p:txBody>
       </p:sp>
@@ -2727,7 +2731,7 @@
           <a:p>
             <a:fld id="{5BCAD085-E8A6-8845-BD4E-CB4CCA059FC4}" type="datetimeFigureOut">
               <a:rPr lang="en-US" smtClean="0"/>
-              <a:t>6/29/2026</a:t>
+              <a:t>1/27/13</a:t>
             </a:fld>
             <a:endParaRPr lang="en-US"/>
           </a:p>
@@ -3086,7 +3090,7 @@
 </file>
 
 <file path=ppt/slides/slide1.xml><?xml version="1.0" encoding="utf-8"?>
-<p:sld xmlns:a="http://schemas.openxmlformats.org/drawingml/2006/main" xmlns:r="http://schemas.openxmlformats.org/officeDocument/2006/relationships" xmlns:p="http://schemas.openxmlformats.org/presentationml/2006/main">
+<p:sld xmlns:a="http://schemas.openxmlformats.org/drawingml/2006/main" xmlns:p="http://schemas.openxmlformats.org/presentationml/2006/main" xmlns:r="http://schemas.openxmlformats.org/officeDocument/2006/relationships">
   <p:cSld>
     <p:spTree>
       <p:nvGrpSpPr>
@@ -3094,14 +3098,7 @@
         <p:cNvGrpSpPr/>
         <p:nvPr/>
       </p:nvGrpSpPr>
-      <p:grpSpPr>
-        <a:xfrm>
-          <a:off x="0" y="0"/>
-          <a:ext cx="0" cy="0"/>
-          <a:chOff x="0" y="0"/>
-          <a:chExt cx="0" cy="0"/>
-        </a:xfrm>
-      </p:grpSpPr>
+      <p:grpSpPr/>
       <p:sp>
         <p:nvSpPr>
           <p:cNvPr id="2" name="TextBox 1"/>
@@ -3140,7 +3137,7 @@
 </file>
 
 <file path=ppt/slides/slide10.xml><?xml version="1.0" encoding="utf-8"?>
-<p:sld xmlns:a="http://schemas.openxmlformats.org/drawingml/2006/main" xmlns:r="http://schemas.openxmlformats.org/officeDocument/2006/relationships" xmlns:p="http://schemas.openxmlformats.org/presentationml/2006/main">
+<p:sld xmlns:a="http://schemas.openxmlformats.org/drawingml/2006/main" xmlns:p="http://schemas.openxmlformats.org/presentationml/2006/main" xmlns:r="http://schemas.openxmlformats.org/officeDocument/2006/relationships">
   <p:cSld>
     <p:spTree>
       <p:nvGrpSpPr>
@@ -3148,24 +3145,17 @@
         <p:cNvGrpSpPr/>
         <p:nvPr/>
       </p:nvGrpSpPr>
-      <p:grpSpPr>
-        <a:xfrm>
-          <a:off x="0" y="0"/>
-          <a:ext cx="0" cy="0"/>
-          <a:chOff x="0" y="0"/>
-          <a:chExt cx="0" cy="0"/>
-        </a:xfrm>
-      </p:grpSpPr>
-      <p:sp>
-        <p:nvSpPr>
-          <p:cNvPr id="2" name="TextBox 1"/>
+      <p:grpSpPr/>
+      <p:sp>
+        <p:nvSpPr>
+          <p:cNvPr id="2" name="NAME"/>
           <p:cNvSpPr txBox="1"/>
           <p:nvPr/>
         </p:nvSpPr>
         <p:spPr>
           <a:xfrm>
-            <a:off x="914400" y="2286000"/>
-            <a:ext cx="7315200" cy="1371600"/>
+            <a:off x="914400" y="1828800"/>
+            <a:ext cx="7315200" cy="914400"/>
           </a:xfrm>
           <a:prstGeom prst="rect">
             <a:avLst/>
@@ -3179,8 +3169,66 @@
           <a:lstStyle/>
           <a:p>
             <a:r>
-              <a:rPr sz="4000"/>
-              <a:t>F grade attendees</a:t>
+              <a:rPr sz="3200"/>
+              <a:t>{{name}}</a:t>
+            </a:r>
+          </a:p>
+        </p:txBody>
+      </p:sp>
+      <p:sp>
+        <p:nvSpPr>
+          <p:cNvPr id="3" name="TITLE"/>
+          <p:cNvSpPr txBox="1"/>
+          <p:nvPr/>
+        </p:nvSpPr>
+        <p:spPr>
+          <a:xfrm>
+            <a:off x="914400" y="2926080"/>
+            <a:ext cx="7315200" cy="914400"/>
+          </a:xfrm>
+          <a:prstGeom prst="rect">
+            <a:avLst/>
+          </a:prstGeom>
+          <a:noFill/>
+        </p:spPr>
+        <p:txBody>
+          <a:bodyPr wrap="none">
+            <a:spAutoFit/>
+          </a:bodyPr>
+          <a:lstStyle/>
+          <a:p>
+            <a:r>
+              <a:rPr sz="2400"/>
+              <a:t>{{title}}</a:t>
+            </a:r>
+          </a:p>
+        </p:txBody>
+      </p:sp>
+      <p:sp>
+        <p:nvSpPr>
+          <p:cNvPr id="4" name="BU"/>
+          <p:cNvSpPr txBox="1"/>
+          <p:nvPr/>
+        </p:nvSpPr>
+        <p:spPr>
+          <a:xfrm>
+            <a:off x="914400" y="3840480"/>
+            <a:ext cx="7315200" cy="914400"/>
+          </a:xfrm>
+          <a:prstGeom prst="rect">
+            <a:avLst/>
+          </a:prstGeom>
+          <a:noFill/>
+        </p:spPr>
+        <p:txBody>
+          <a:bodyPr wrap="none">
+            <a:spAutoFit/>
+          </a:bodyPr>
+          <a:lstStyle/>
+          <a:p>
+            <a:r>
+              <a:rPr sz="2000"/>
+              <a:t>{{bu}}</a:t>
             </a:r>
           </a:p>
         </p:txBody>
@@ -3194,7 +3242,7 @@
 </file>
 
 <file path=ppt/slides/slide11.xml><?xml version="1.0" encoding="utf-8"?>
-<p:sld xmlns:a="http://schemas.openxmlformats.org/drawingml/2006/main" xmlns:r="http://schemas.openxmlformats.org/officeDocument/2006/relationships" xmlns:p="http://schemas.openxmlformats.org/presentationml/2006/main">
+<p:sld xmlns:a="http://schemas.openxmlformats.org/drawingml/2006/main" xmlns:p="http://schemas.openxmlformats.org/presentationml/2006/main" xmlns:r="http://schemas.openxmlformats.org/officeDocument/2006/relationships">
   <p:cSld>
     <p:spTree>
       <p:nvGrpSpPr>
@@ -3202,24 +3250,17 @@
         <p:cNvGrpSpPr/>
         <p:nvPr/>
       </p:nvGrpSpPr>
-      <p:grpSpPr>
-        <a:xfrm>
-          <a:off x="0" y="0"/>
-          <a:ext cx="0" cy="0"/>
-          <a:chOff x="0" y="0"/>
-          <a:chExt cx="0" cy="0"/>
-        </a:xfrm>
-      </p:grpSpPr>
-      <p:sp>
-        <p:nvSpPr>
-          <p:cNvPr id="2" name="NAME"/>
+      <p:grpSpPr/>
+      <p:sp>
+        <p:nvSpPr>
+          <p:cNvPr id="2" name="TextBox 1"/>
           <p:cNvSpPr txBox="1"/>
           <p:nvPr/>
         </p:nvSpPr>
         <p:spPr>
           <a:xfrm>
-            <a:off x="914400" y="1828800"/>
-            <a:ext cx="7315200" cy="914400"/>
+            <a:off x="914400" y="2286000"/>
+            <a:ext cx="7315200" cy="1371600"/>
           </a:xfrm>
           <a:prstGeom prst="rect">
             <a:avLst/>
@@ -3233,37 +3274,8 @@
           <a:lstStyle/>
           <a:p>
             <a:r>
-              <a:rPr sz="3200"/>
-              <a:t>{{name}}</a:t>
-            </a:r>
-          </a:p>
-        </p:txBody>
-      </p:sp>
-      <p:sp>
-        <p:nvSpPr>
-          <p:cNvPr id="3" name="TITLE"/>
-          <p:cNvSpPr txBox="1"/>
-          <p:nvPr/>
-        </p:nvSpPr>
-        <p:spPr>
-          <a:xfrm>
-            <a:off x="914400" y="2926080"/>
-            <a:ext cx="7315200" cy="914400"/>
-          </a:xfrm>
-          <a:prstGeom prst="rect">
-            <a:avLst/>
-          </a:prstGeom>
-          <a:noFill/>
-        </p:spPr>
-        <p:txBody>
-          <a:bodyPr wrap="none">
-            <a:spAutoFit/>
-          </a:bodyPr>
-          <a:lstStyle/>
-          <a:p>
-            <a:r>
-              <a:rPr sz="2400"/>
-              <a:t>{{title}}</a:t>
+              <a:rPr sz="4000"/>
+              <a:t>F grade absentees</a:t>
             </a:r>
           </a:p>
         </p:txBody>
@@ -3277,7 +3289,7 @@
 </file>
 
 <file path=ppt/slides/slide12.xml><?xml version="1.0" encoding="utf-8"?>
-<p:sld xmlns:a="http://schemas.openxmlformats.org/drawingml/2006/main" xmlns:r="http://schemas.openxmlformats.org/officeDocument/2006/relationships" xmlns:p="http://schemas.openxmlformats.org/presentationml/2006/main">
+<p:sld xmlns:a="http://schemas.openxmlformats.org/drawingml/2006/main" xmlns:p="http://schemas.openxmlformats.org/presentationml/2006/main" xmlns:r="http://schemas.openxmlformats.org/officeDocument/2006/relationships">
   <p:cSld>
     <p:spTree>
       <p:nvGrpSpPr>
@@ -3285,24 +3297,17 @@
         <p:cNvGrpSpPr/>
         <p:nvPr/>
       </p:nvGrpSpPr>
-      <p:grpSpPr>
-        <a:xfrm>
-          <a:off x="0" y="0"/>
-          <a:ext cx="0" cy="0"/>
-          <a:chOff x="0" y="0"/>
-          <a:chExt cx="0" cy="0"/>
-        </a:xfrm>
-      </p:grpSpPr>
-      <p:sp>
-        <p:nvSpPr>
-          <p:cNvPr id="2" name="TextBox 1"/>
+      <p:grpSpPr/>
+      <p:sp>
+        <p:nvSpPr>
+          <p:cNvPr id="2" name="NAME"/>
           <p:cNvSpPr txBox="1"/>
           <p:nvPr/>
         </p:nvSpPr>
         <p:spPr>
           <a:xfrm>
-            <a:off x="914400" y="2286000"/>
-            <a:ext cx="7315200" cy="1371600"/>
+            <a:off x="914400" y="1828800"/>
+            <a:ext cx="7315200" cy="914400"/>
           </a:xfrm>
           <a:prstGeom prst="rect">
             <a:avLst/>
@@ -3316,46 +3321,21 @@
           <a:lstStyle/>
           <a:p>
             <a:r>
-              <a:rPr sz="4000"/>
-              <a:t>F grade absentees</a:t>
-            </a:r>
-          </a:p>
-        </p:txBody>
-      </p:sp>
-    </p:spTree>
-  </p:cSld>
-  <p:clrMapOvr>
-    <a:masterClrMapping/>
-  </p:clrMapOvr>
-</p:sld>
-</file>
-
-<file path=ppt/slides/slide13.xml><?xml version="1.0" encoding="utf-8"?>
-<p:sld xmlns:a="http://schemas.openxmlformats.org/drawingml/2006/main" xmlns:r="http://schemas.openxmlformats.org/officeDocument/2006/relationships" xmlns:p="http://schemas.openxmlformats.org/presentationml/2006/main">
-  <p:cSld>
-    <p:spTree>
-      <p:nvGrpSpPr>
-        <p:cNvPr id="1" name=""/>
-        <p:cNvGrpSpPr/>
-        <p:nvPr/>
-      </p:nvGrpSpPr>
-      <p:grpSpPr>
-        <a:xfrm>
-          <a:off x="0" y="0"/>
-          <a:ext cx="0" cy="0"/>
-          <a:chOff x="0" y="0"/>
-          <a:chExt cx="0" cy="0"/>
-        </a:xfrm>
-      </p:grpSpPr>
-      <p:sp>
-        <p:nvSpPr>
-          <p:cNvPr id="2" name="NAME"/>
+              <a:rPr sz="3200"/>
+              <a:t>{{name}}</a:t>
+            </a:r>
+          </a:p>
+        </p:txBody>
+      </p:sp>
+      <p:sp>
+        <p:nvSpPr>
+          <p:cNvPr id="3" name="TITLE"/>
           <p:cNvSpPr txBox="1"/>
           <p:nvPr/>
         </p:nvSpPr>
         <p:spPr>
           <a:xfrm>
-            <a:off x="914400" y="1828800"/>
+            <a:off x="914400" y="2926080"/>
             <a:ext cx="7315200" cy="914400"/>
           </a:xfrm>
           <a:prstGeom prst="rect">
@@ -3370,21 +3350,21 @@
           <a:lstStyle/>
           <a:p>
             <a:r>
-              <a:rPr sz="3200"/>
-              <a:t>{{name}}</a:t>
-            </a:r>
-          </a:p>
-        </p:txBody>
-      </p:sp>
-      <p:sp>
-        <p:nvSpPr>
-          <p:cNvPr id="3" name="TITLE"/>
+              <a:rPr sz="2400"/>
+              <a:t>{{title}}</a:t>
+            </a:r>
+          </a:p>
+        </p:txBody>
+      </p:sp>
+      <p:sp>
+        <p:nvSpPr>
+          <p:cNvPr id="4" name="BU"/>
           <p:cNvSpPr txBox="1"/>
           <p:nvPr/>
         </p:nvSpPr>
         <p:spPr>
           <a:xfrm>
-            <a:off x="914400" y="2926080"/>
+            <a:off x="914400" y="3840480"/>
             <a:ext cx="7315200" cy="914400"/>
           </a:xfrm>
           <a:prstGeom prst="rect">
@@ -3399,8 +3379,8 @@
           <a:lstStyle/>
           <a:p>
             <a:r>
-              <a:rPr sz="2400"/>
-              <a:t>{{title}}</a:t>
+              <a:rPr sz="2000"/>
+              <a:t>{{bu}}</a:t>
             </a:r>
           </a:p>
         </p:txBody>
@@ -3414,7 +3394,7 @@
 </file>
 
 <file path=ppt/slides/slide2.xml><?xml version="1.0" encoding="utf-8"?>
-<p:sld xmlns:a="http://schemas.openxmlformats.org/drawingml/2006/main" xmlns:r="http://schemas.openxmlformats.org/officeDocument/2006/relationships" xmlns:p="http://schemas.openxmlformats.org/presentationml/2006/main">
+<p:sld xmlns:a="http://schemas.openxmlformats.org/drawingml/2006/main" xmlns:p="http://schemas.openxmlformats.org/presentationml/2006/main" xmlns:r="http://schemas.openxmlformats.org/officeDocument/2006/relationships">
   <p:cSld>
     <p:spTree>
       <p:nvGrpSpPr>
@@ -3422,161 +3402,95 @@
         <p:cNvGrpSpPr/>
         <p:nvPr/>
       </p:nvGrpSpPr>
-      <p:grpSpPr>
-        <a:xfrm>
-          <a:off x="0" y="0"/>
-          <a:ext cx="0" cy="0"/>
-          <a:chOff x="0" y="0"/>
-          <a:chExt cx="0" cy="0"/>
-        </a:xfrm>
-      </p:grpSpPr>
-      <p:sp>
-        <p:nvSpPr>
-          <p:cNvPr id="2" name="Rectangle 1">
-            <a:extLst>
-              <a:ext uri="{FF2B5EF4-FFF2-40B4-BE49-F238E27FC236}">
-                <a16:creationId xmlns:a16="http://schemas.microsoft.com/office/drawing/2014/main" id="{0F57B1E0-5715-ED26-9457-362E8AD0634D}"/>
-              </a:ext>
-            </a:extLst>
-          </p:cNvPr>
-          <p:cNvSpPr/>
+      <p:grpSpPr/>
+      <p:sp>
+        <p:nvSpPr>
+          <p:cNvPr id="2" name="NAME"/>
+          <p:cNvSpPr txBox="1"/>
           <p:nvPr/>
         </p:nvSpPr>
         <p:spPr>
           <a:xfrm>
-            <a:off x="1081548" y="648929"/>
-            <a:ext cx="3982065" cy="1258529"/>
+            <a:off x="914400" y="1828800"/>
+            <a:ext cx="7315200" cy="914400"/>
           </a:xfrm>
           <a:prstGeom prst="rect">
             <a:avLst/>
           </a:prstGeom>
-        </p:spPr>
-        <p:style>
-          <a:lnRef idx="1">
-            <a:schemeClr val="accent1"/>
-          </a:lnRef>
-          <a:fillRef idx="3">
-            <a:schemeClr val="accent1"/>
-          </a:fillRef>
-          <a:effectRef idx="2">
-            <a:schemeClr val="accent1"/>
-          </a:effectRef>
-          <a:fontRef idx="minor">
-            <a:schemeClr val="lt1"/>
-          </a:fontRef>
-        </p:style>
-        <p:txBody>
-          <a:bodyPr rtlCol="0" anchor="ctr"/>
-          <a:lstStyle/>
-          <a:p>
-            <a:pPr algn="ctr"/>
-            <a:r>
-              <a:rPr lang="en-SG" dirty="0"/>
-              <a:t>name</a:t>
-            </a:r>
-          </a:p>
-        </p:txBody>
-      </p:sp>
-      <p:sp>
-        <p:nvSpPr>
-          <p:cNvPr id="3" name="Rectangle 2">
-            <a:extLst>
-              <a:ext uri="{FF2B5EF4-FFF2-40B4-BE49-F238E27FC236}">
-                <a16:creationId xmlns:a16="http://schemas.microsoft.com/office/drawing/2014/main" id="{3E9FC97A-DECC-C6B1-6317-4CEF2879EB96}"/>
-              </a:ext>
-            </a:extLst>
-          </p:cNvPr>
-          <p:cNvSpPr/>
+          <a:noFill/>
+        </p:spPr>
+        <p:txBody>
+          <a:bodyPr wrap="none">
+            <a:spAutoFit/>
+          </a:bodyPr>
+          <a:lstStyle/>
+          <a:p>
+            <a:r>
+              <a:rPr sz="3200"/>
+              <a:t>{{name}}</a:t>
+            </a:r>
+          </a:p>
+        </p:txBody>
+      </p:sp>
+      <p:sp>
+        <p:nvSpPr>
+          <p:cNvPr id="3" name="TITLE"/>
+          <p:cNvSpPr txBox="1"/>
           <p:nvPr/>
         </p:nvSpPr>
         <p:spPr>
           <a:xfrm>
-            <a:off x="1160206" y="2546555"/>
-            <a:ext cx="3982065" cy="1258529"/>
+            <a:off x="914400" y="2926080"/>
+            <a:ext cx="7315200" cy="914400"/>
           </a:xfrm>
           <a:prstGeom prst="rect">
             <a:avLst/>
           </a:prstGeom>
-        </p:spPr>
-        <p:style>
-          <a:lnRef idx="1">
-            <a:schemeClr val="accent1"/>
-          </a:lnRef>
-          <a:fillRef idx="3">
-            <a:schemeClr val="accent1"/>
-          </a:fillRef>
-          <a:effectRef idx="2">
-            <a:schemeClr val="accent1"/>
-          </a:effectRef>
-          <a:fontRef idx="minor">
-            <a:schemeClr val="lt1"/>
-          </a:fontRef>
-        </p:style>
-        <p:txBody>
-          <a:bodyPr rtlCol="0" anchor="ctr"/>
-          <a:lstStyle/>
-          <a:p>
-            <a:pPr algn="ctr"/>
-            <a:r>
-              <a:rPr lang="en-SG" dirty="0"/>
-              <a:t>title</a:t>
-            </a:r>
-          </a:p>
-        </p:txBody>
-      </p:sp>
-      <p:sp>
-        <p:nvSpPr>
-          <p:cNvPr id="4" name="Rectangle 3">
-            <a:extLst>
-              <a:ext uri="{FF2B5EF4-FFF2-40B4-BE49-F238E27FC236}">
-                <a16:creationId xmlns:a16="http://schemas.microsoft.com/office/drawing/2014/main" id="{D60E88F6-7BF8-B5F7-F5D3-C647337C49C4}"/>
-              </a:ext>
-            </a:extLst>
-          </p:cNvPr>
-          <p:cNvSpPr/>
+          <a:noFill/>
+        </p:spPr>
+        <p:txBody>
+          <a:bodyPr wrap="none">
+            <a:spAutoFit/>
+          </a:bodyPr>
+          <a:lstStyle/>
+          <a:p>
+            <a:r>
+              <a:rPr sz="2400"/>
+              <a:t>{{title}}</a:t>
+            </a:r>
+          </a:p>
+        </p:txBody>
+      </p:sp>
+      <p:sp>
+        <p:nvSpPr>
+          <p:cNvPr id="4" name="BU"/>
+          <p:cNvSpPr txBox="1"/>
           <p:nvPr/>
         </p:nvSpPr>
         <p:spPr>
           <a:xfrm>
-            <a:off x="1268360" y="4562168"/>
-            <a:ext cx="3982065" cy="1258529"/>
+            <a:off x="914400" y="3840480"/>
+            <a:ext cx="7315200" cy="914400"/>
           </a:xfrm>
           <a:prstGeom prst="rect">
             <a:avLst/>
           </a:prstGeom>
-        </p:spPr>
-        <p:style>
-          <a:lnRef idx="1">
-            <a:schemeClr val="accent1"/>
-          </a:lnRef>
-          <a:fillRef idx="3">
-            <a:schemeClr val="accent1"/>
-          </a:fillRef>
-          <a:effectRef idx="2">
-            <a:schemeClr val="accent1"/>
-          </a:effectRef>
-          <a:fontRef idx="minor">
-            <a:schemeClr val="lt1"/>
-          </a:fontRef>
-        </p:style>
-        <p:txBody>
-          <a:bodyPr rtlCol="0" anchor="ctr"/>
-          <a:lstStyle/>
-          <a:p>
-            <a:pPr algn="ctr"/>
-            <a:r>
-              <a:rPr lang="en-SG"/>
-              <a:t>BU</a:t>
+          <a:noFill/>
+        </p:spPr>
+        <p:txBody>
+          <a:bodyPr wrap="none">
+            <a:spAutoFit/>
+          </a:bodyPr>
+          <a:lstStyle/>
+          <a:p>
+            <a:r>
+              <a:rPr sz="2000"/>
+              <a:t>{{bu}}</a:t>
             </a:r>
           </a:p>
         </p:txBody>
       </p:sp>
     </p:spTree>
-    <p:extLst>
-      <p:ext uri="{BB962C8B-B14F-4D97-AF65-F5344CB8AC3E}">
-        <p14:creationId xmlns:p14="http://schemas.microsoft.com/office/powerpoint/2010/main" val="2163112749"/>
-      </p:ext>
-    </p:extLst>
   </p:cSld>
   <p:clrMapOvr>
     <a:masterClrMapping/>
@@ -3585,7 +3499,7 @@
 </file>
 
 <file path=ppt/slides/slide3.xml><?xml version="1.0" encoding="utf-8"?>
-<p:sld xmlns:a="http://schemas.openxmlformats.org/drawingml/2006/main" xmlns:r="http://schemas.openxmlformats.org/officeDocument/2006/relationships" xmlns:p="http://schemas.openxmlformats.org/presentationml/2006/main">
+<p:sld xmlns:a="http://schemas.openxmlformats.org/drawingml/2006/main" xmlns:p="http://schemas.openxmlformats.org/presentationml/2006/main" xmlns:r="http://schemas.openxmlformats.org/officeDocument/2006/relationships">
   <p:cSld>
     <p:spTree>
       <p:nvGrpSpPr>
@@ -3593,24 +3507,17 @@
         <p:cNvGrpSpPr/>
         <p:nvPr/>
       </p:nvGrpSpPr>
-      <p:grpSpPr>
-        <a:xfrm>
-          <a:off x="0" y="0"/>
-          <a:ext cx="0" cy="0"/>
-          <a:chOff x="0" y="0"/>
-          <a:chExt cx="0" cy="0"/>
-        </a:xfrm>
-      </p:grpSpPr>
-      <p:sp>
-        <p:nvSpPr>
-          <p:cNvPr id="2" name="NAME"/>
+      <p:grpSpPr/>
+      <p:sp>
+        <p:nvSpPr>
+          <p:cNvPr id="2" name="TextBox 1"/>
           <p:cNvSpPr txBox="1"/>
           <p:nvPr/>
         </p:nvSpPr>
         <p:spPr>
           <a:xfrm>
-            <a:off x="914400" y="1828800"/>
-            <a:ext cx="7315200" cy="914400"/>
+            <a:off x="914400" y="2286000"/>
+            <a:ext cx="7315200" cy="1371600"/>
           </a:xfrm>
           <a:prstGeom prst="rect">
             <a:avLst/>
@@ -3624,37 +3531,8 @@
           <a:lstStyle/>
           <a:p>
             <a:r>
-              <a:rPr sz="3200"/>
-              <a:t>{{name}}</a:t>
-            </a:r>
-          </a:p>
-        </p:txBody>
-      </p:sp>
-      <p:sp>
-        <p:nvSpPr>
-          <p:cNvPr id="3" name="TITLE"/>
-          <p:cNvSpPr txBox="1"/>
-          <p:nvPr/>
-        </p:nvSpPr>
-        <p:spPr>
-          <a:xfrm>
-            <a:off x="914400" y="2926080"/>
-            <a:ext cx="7315200" cy="914400"/>
-          </a:xfrm>
-          <a:prstGeom prst="rect">
-            <a:avLst/>
-          </a:prstGeom>
-          <a:noFill/>
-        </p:spPr>
-        <p:txBody>
-          <a:bodyPr wrap="none">
-            <a:spAutoFit/>
-          </a:bodyPr>
-          <a:lstStyle/>
-          <a:p>
-            <a:r>
-              <a:rPr sz="2400"/>
-              <a:t>{{title}}</a:t>
+              <a:rPr sz="4000"/>
+              <a:t>E grade absentees</a:t>
             </a:r>
           </a:p>
         </p:txBody>
@@ -3668,7 +3546,7 @@
 </file>
 
 <file path=ppt/slides/slide4.xml><?xml version="1.0" encoding="utf-8"?>
-<p:sld xmlns:a="http://schemas.openxmlformats.org/drawingml/2006/main" xmlns:r="http://schemas.openxmlformats.org/officeDocument/2006/relationships" xmlns:p="http://schemas.openxmlformats.org/presentationml/2006/main">
+<p:sld xmlns:a="http://schemas.openxmlformats.org/drawingml/2006/main" xmlns:p="http://schemas.openxmlformats.org/presentationml/2006/main" xmlns:r="http://schemas.openxmlformats.org/officeDocument/2006/relationships">
   <p:cSld>
     <p:spTree>
       <p:nvGrpSpPr>
@@ -3676,24 +3554,17 @@
         <p:cNvGrpSpPr/>
         <p:nvPr/>
       </p:nvGrpSpPr>
-      <p:grpSpPr>
-        <a:xfrm>
-          <a:off x="0" y="0"/>
-          <a:ext cx="0" cy="0"/>
-          <a:chOff x="0" y="0"/>
-          <a:chExt cx="0" cy="0"/>
-        </a:xfrm>
-      </p:grpSpPr>
-      <p:sp>
-        <p:nvSpPr>
-          <p:cNvPr id="2" name="TextBox 1"/>
+      <p:grpSpPr/>
+      <p:sp>
+        <p:nvSpPr>
+          <p:cNvPr id="2" name="NAME"/>
           <p:cNvSpPr txBox="1"/>
           <p:nvPr/>
         </p:nvSpPr>
         <p:spPr>
           <a:xfrm>
-            <a:off x="914400" y="2286000"/>
-            <a:ext cx="7315200" cy="1371600"/>
+            <a:off x="914400" y="1828800"/>
+            <a:ext cx="7315200" cy="914400"/>
           </a:xfrm>
           <a:prstGeom prst="rect">
             <a:avLst/>
@@ -3707,8 +3578,66 @@
           <a:lstStyle/>
           <a:p>
             <a:r>
-              <a:rPr sz="4000"/>
-              <a:t>E grade absentees</a:t>
+              <a:rPr sz="3200"/>
+              <a:t>{{name}}</a:t>
+            </a:r>
+          </a:p>
+        </p:txBody>
+      </p:sp>
+      <p:sp>
+        <p:nvSpPr>
+          <p:cNvPr id="3" name="TITLE"/>
+          <p:cNvSpPr txBox="1"/>
+          <p:nvPr/>
+        </p:nvSpPr>
+        <p:spPr>
+          <a:xfrm>
+            <a:off x="914400" y="2926080"/>
+            <a:ext cx="7315200" cy="914400"/>
+          </a:xfrm>
+          <a:prstGeom prst="rect">
+            <a:avLst/>
+          </a:prstGeom>
+          <a:noFill/>
+        </p:spPr>
+        <p:txBody>
+          <a:bodyPr wrap="none">
+            <a:spAutoFit/>
+          </a:bodyPr>
+          <a:lstStyle/>
+          <a:p>
+            <a:r>
+              <a:rPr sz="2400"/>
+              <a:t>{{title}}</a:t>
+            </a:r>
+          </a:p>
+        </p:txBody>
+      </p:sp>
+      <p:sp>
+        <p:nvSpPr>
+          <p:cNvPr id="4" name="BU"/>
+          <p:cNvSpPr txBox="1"/>
+          <p:nvPr/>
+        </p:nvSpPr>
+        <p:spPr>
+          <a:xfrm>
+            <a:off x="914400" y="3840480"/>
+            <a:ext cx="7315200" cy="914400"/>
+          </a:xfrm>
+          <a:prstGeom prst="rect">
+            <a:avLst/>
+          </a:prstGeom>
+          <a:noFill/>
+        </p:spPr>
+        <p:txBody>
+          <a:bodyPr wrap="none">
+            <a:spAutoFit/>
+          </a:bodyPr>
+          <a:lstStyle/>
+          <a:p>
+            <a:r>
+              <a:rPr sz="2000"/>
+              <a:t>{{bu}}</a:t>
             </a:r>
           </a:p>
         </p:txBody>
@@ -3722,7 +3651,7 @@
 </file>
 
 <file path=ppt/slides/slide5.xml><?xml version="1.0" encoding="utf-8"?>
-<p:sld xmlns:a="http://schemas.openxmlformats.org/drawingml/2006/main" xmlns:r="http://schemas.openxmlformats.org/officeDocument/2006/relationships" xmlns:p="http://schemas.openxmlformats.org/presentationml/2006/main">
+<p:sld xmlns:a="http://schemas.openxmlformats.org/drawingml/2006/main" xmlns:p="http://schemas.openxmlformats.org/presentationml/2006/main" xmlns:r="http://schemas.openxmlformats.org/officeDocument/2006/relationships">
   <p:cSld>
     <p:spTree>
       <p:nvGrpSpPr>
@@ -3730,24 +3659,17 @@
         <p:cNvGrpSpPr/>
         <p:nvPr/>
       </p:nvGrpSpPr>
-      <p:grpSpPr>
-        <a:xfrm>
-          <a:off x="0" y="0"/>
-          <a:ext cx="0" cy="0"/>
-          <a:chOff x="0" y="0"/>
-          <a:chExt cx="0" cy="0"/>
-        </a:xfrm>
-      </p:grpSpPr>
-      <p:sp>
-        <p:nvSpPr>
-          <p:cNvPr id="2" name="NAME"/>
+      <p:grpSpPr/>
+      <p:sp>
+        <p:nvSpPr>
+          <p:cNvPr id="2" name="TextBox 1"/>
           <p:cNvSpPr txBox="1"/>
           <p:nvPr/>
         </p:nvSpPr>
         <p:spPr>
           <a:xfrm>
-            <a:off x="914400" y="1828800"/>
-            <a:ext cx="7315200" cy="914400"/>
+            <a:off x="914400" y="2286000"/>
+            <a:ext cx="7315200" cy="1371600"/>
           </a:xfrm>
           <a:prstGeom prst="rect">
             <a:avLst/>
@@ -3761,37 +3683,8 @@
           <a:lstStyle/>
           <a:p>
             <a:r>
-              <a:rPr sz="3200"/>
-              <a:t>{{name}}</a:t>
-            </a:r>
-          </a:p>
-        </p:txBody>
-      </p:sp>
-      <p:sp>
-        <p:nvSpPr>
-          <p:cNvPr id="3" name="TITLE"/>
-          <p:cNvSpPr txBox="1"/>
-          <p:nvPr/>
-        </p:nvSpPr>
-        <p:spPr>
-          <a:xfrm>
-            <a:off x="914400" y="2926080"/>
-            <a:ext cx="7315200" cy="914400"/>
-          </a:xfrm>
-          <a:prstGeom prst="rect">
-            <a:avLst/>
-          </a:prstGeom>
-          <a:noFill/>
-        </p:spPr>
-        <p:txBody>
-          <a:bodyPr wrap="none">
-            <a:spAutoFit/>
-          </a:bodyPr>
-          <a:lstStyle/>
-          <a:p>
-            <a:r>
-              <a:rPr sz="2400"/>
-              <a:t>{{title}}</a:t>
+              <a:rPr sz="4000"/>
+              <a:t>M grade attendees</a:t>
             </a:r>
           </a:p>
         </p:txBody>
@@ -3805,7 +3698,7 @@
 </file>
 
 <file path=ppt/slides/slide6.xml><?xml version="1.0" encoding="utf-8"?>
-<p:sld xmlns:a="http://schemas.openxmlformats.org/drawingml/2006/main" xmlns:r="http://schemas.openxmlformats.org/officeDocument/2006/relationships" xmlns:p="http://schemas.openxmlformats.org/presentationml/2006/main">
+<p:sld xmlns:a="http://schemas.openxmlformats.org/drawingml/2006/main" xmlns:p="http://schemas.openxmlformats.org/presentationml/2006/main" xmlns:r="http://schemas.openxmlformats.org/officeDocument/2006/relationships">
   <p:cSld>
     <p:spTree>
       <p:nvGrpSpPr>
@@ -3813,24 +3706,17 @@
         <p:cNvGrpSpPr/>
         <p:nvPr/>
       </p:nvGrpSpPr>
-      <p:grpSpPr>
-        <a:xfrm>
-          <a:off x="0" y="0"/>
-          <a:ext cx="0" cy="0"/>
-          <a:chOff x="0" y="0"/>
-          <a:chExt cx="0" cy="0"/>
-        </a:xfrm>
-      </p:grpSpPr>
-      <p:sp>
-        <p:nvSpPr>
-          <p:cNvPr id="2" name="TextBox 1"/>
+      <p:grpSpPr/>
+      <p:sp>
+        <p:nvSpPr>
+          <p:cNvPr id="2" name="NAME"/>
           <p:cNvSpPr txBox="1"/>
           <p:nvPr/>
         </p:nvSpPr>
         <p:spPr>
           <a:xfrm>
-            <a:off x="914400" y="2286000"/>
-            <a:ext cx="7315200" cy="1371600"/>
+            <a:off x="914400" y="1828800"/>
+            <a:ext cx="7315200" cy="914400"/>
           </a:xfrm>
           <a:prstGeom prst="rect">
             <a:avLst/>
@@ -3844,8 +3730,66 @@
           <a:lstStyle/>
           <a:p>
             <a:r>
-              <a:rPr sz="4000"/>
-              <a:t>M grade attendees</a:t>
+              <a:rPr sz="3200"/>
+              <a:t>{{name}}</a:t>
+            </a:r>
+          </a:p>
+        </p:txBody>
+      </p:sp>
+      <p:sp>
+        <p:nvSpPr>
+          <p:cNvPr id="3" name="TITLE"/>
+          <p:cNvSpPr txBox="1"/>
+          <p:nvPr/>
+        </p:nvSpPr>
+        <p:spPr>
+          <a:xfrm>
+            <a:off x="914400" y="2926080"/>
+            <a:ext cx="7315200" cy="914400"/>
+          </a:xfrm>
+          <a:prstGeom prst="rect">
+            <a:avLst/>
+          </a:prstGeom>
+          <a:noFill/>
+        </p:spPr>
+        <p:txBody>
+          <a:bodyPr wrap="none">
+            <a:spAutoFit/>
+          </a:bodyPr>
+          <a:lstStyle/>
+          <a:p>
+            <a:r>
+              <a:rPr sz="2400"/>
+              <a:t>{{title}}</a:t>
+            </a:r>
+          </a:p>
+        </p:txBody>
+      </p:sp>
+      <p:sp>
+        <p:nvSpPr>
+          <p:cNvPr id="4" name="BU"/>
+          <p:cNvSpPr txBox="1"/>
+          <p:nvPr/>
+        </p:nvSpPr>
+        <p:spPr>
+          <a:xfrm>
+            <a:off x="914400" y="3840480"/>
+            <a:ext cx="7315200" cy="914400"/>
+          </a:xfrm>
+          <a:prstGeom prst="rect">
+            <a:avLst/>
+          </a:prstGeom>
+          <a:noFill/>
+        </p:spPr>
+        <p:txBody>
+          <a:bodyPr wrap="none">
+            <a:spAutoFit/>
+          </a:bodyPr>
+          <a:lstStyle/>
+          <a:p>
+            <a:r>
+              <a:rPr sz="2000"/>
+              <a:t>{{bu}}</a:t>
             </a:r>
           </a:p>
         </p:txBody>
@@ -3859,7 +3803,7 @@
 </file>
 
 <file path=ppt/slides/slide7.xml><?xml version="1.0" encoding="utf-8"?>
-<p:sld xmlns:a="http://schemas.openxmlformats.org/drawingml/2006/main" xmlns:r="http://schemas.openxmlformats.org/officeDocument/2006/relationships" xmlns:p="http://schemas.openxmlformats.org/presentationml/2006/main">
+<p:sld xmlns:a="http://schemas.openxmlformats.org/drawingml/2006/main" xmlns:p="http://schemas.openxmlformats.org/presentationml/2006/main" xmlns:r="http://schemas.openxmlformats.org/officeDocument/2006/relationships">
   <p:cSld>
     <p:spTree>
       <p:nvGrpSpPr>
@@ -3867,24 +3811,17 @@
         <p:cNvGrpSpPr/>
         <p:nvPr/>
       </p:nvGrpSpPr>
-      <p:grpSpPr>
-        <a:xfrm>
-          <a:off x="0" y="0"/>
-          <a:ext cx="0" cy="0"/>
-          <a:chOff x="0" y="0"/>
-          <a:chExt cx="0" cy="0"/>
-        </a:xfrm>
-      </p:grpSpPr>
-      <p:sp>
-        <p:nvSpPr>
-          <p:cNvPr id="2" name="NAME"/>
+      <p:grpSpPr/>
+      <p:sp>
+        <p:nvSpPr>
+          <p:cNvPr id="2" name="TextBox 1"/>
           <p:cNvSpPr txBox="1"/>
           <p:nvPr/>
         </p:nvSpPr>
         <p:spPr>
           <a:xfrm>
-            <a:off x="914400" y="1828800"/>
-            <a:ext cx="7315200" cy="914400"/>
+            <a:off x="914400" y="2286000"/>
+            <a:ext cx="7315200" cy="1371600"/>
           </a:xfrm>
           <a:prstGeom prst="rect">
             <a:avLst/>
@@ -3898,37 +3835,8 @@
           <a:lstStyle/>
           <a:p>
             <a:r>
-              <a:rPr sz="3200"/>
-              <a:t>{{name}}</a:t>
-            </a:r>
-          </a:p>
-        </p:txBody>
-      </p:sp>
-      <p:sp>
-        <p:nvSpPr>
-          <p:cNvPr id="3" name="TITLE"/>
-          <p:cNvSpPr txBox="1"/>
-          <p:nvPr/>
-        </p:nvSpPr>
-        <p:spPr>
-          <a:xfrm>
-            <a:off x="914400" y="2926080"/>
-            <a:ext cx="7315200" cy="914400"/>
-          </a:xfrm>
-          <a:prstGeom prst="rect">
-            <a:avLst/>
-          </a:prstGeom>
-          <a:noFill/>
-        </p:spPr>
-        <p:txBody>
-          <a:bodyPr wrap="none">
-            <a:spAutoFit/>
-          </a:bodyPr>
-          <a:lstStyle/>
-          <a:p>
-            <a:r>
-              <a:rPr sz="2400"/>
-              <a:t>{{title}}</a:t>
+              <a:rPr sz="4000"/>
+              <a:t>M grade absentees</a:t>
             </a:r>
           </a:p>
         </p:txBody>
@@ -3942,7 +3850,7 @@
 </file>
 
 <file path=ppt/slides/slide8.xml><?xml version="1.0" encoding="utf-8"?>
-<p:sld xmlns:a="http://schemas.openxmlformats.org/drawingml/2006/main" xmlns:r="http://schemas.openxmlformats.org/officeDocument/2006/relationships" xmlns:p="http://schemas.openxmlformats.org/presentationml/2006/main">
+<p:sld xmlns:a="http://schemas.openxmlformats.org/drawingml/2006/main" xmlns:p="http://schemas.openxmlformats.org/presentationml/2006/main" xmlns:r="http://schemas.openxmlformats.org/officeDocument/2006/relationships">
   <p:cSld>
     <p:spTree>
       <p:nvGrpSpPr>
@@ -3950,24 +3858,17 @@
         <p:cNvGrpSpPr/>
         <p:nvPr/>
       </p:nvGrpSpPr>
-      <p:grpSpPr>
-        <a:xfrm>
-          <a:off x="0" y="0"/>
-          <a:ext cx="0" cy="0"/>
-          <a:chOff x="0" y="0"/>
-          <a:chExt cx="0" cy="0"/>
-        </a:xfrm>
-      </p:grpSpPr>
-      <p:sp>
-        <p:nvSpPr>
-          <p:cNvPr id="2" name="TextBox 1"/>
+      <p:grpSpPr/>
+      <p:sp>
+        <p:nvSpPr>
+          <p:cNvPr id="2" name="NAME"/>
           <p:cNvSpPr txBox="1"/>
           <p:nvPr/>
         </p:nvSpPr>
         <p:spPr>
           <a:xfrm>
-            <a:off x="914400" y="2286000"/>
-            <a:ext cx="7315200" cy="1371600"/>
+            <a:off x="914400" y="1828800"/>
+            <a:ext cx="7315200" cy="914400"/>
           </a:xfrm>
           <a:prstGeom prst="rect">
             <a:avLst/>
@@ -3981,8 +3882,66 @@
           <a:lstStyle/>
           <a:p>
             <a:r>
-              <a:rPr sz="4000"/>
-              <a:t>M grade absentees</a:t>
+              <a:rPr sz="3200"/>
+              <a:t>{{name}}</a:t>
+            </a:r>
+          </a:p>
+        </p:txBody>
+      </p:sp>
+      <p:sp>
+        <p:nvSpPr>
+          <p:cNvPr id="3" name="TITLE"/>
+          <p:cNvSpPr txBox="1"/>
+          <p:nvPr/>
+        </p:nvSpPr>
+        <p:spPr>
+          <a:xfrm>
+            <a:off x="914400" y="2926080"/>
+            <a:ext cx="7315200" cy="914400"/>
+          </a:xfrm>
+          <a:prstGeom prst="rect">
+            <a:avLst/>
+          </a:prstGeom>
+          <a:noFill/>
+        </p:spPr>
+        <p:txBody>
+          <a:bodyPr wrap="none">
+            <a:spAutoFit/>
+          </a:bodyPr>
+          <a:lstStyle/>
+          <a:p>
+            <a:r>
+              <a:rPr sz="2400"/>
+              <a:t>{{title}}</a:t>
+            </a:r>
+          </a:p>
+        </p:txBody>
+      </p:sp>
+      <p:sp>
+        <p:nvSpPr>
+          <p:cNvPr id="4" name="BU"/>
+          <p:cNvSpPr txBox="1"/>
+          <p:nvPr/>
+        </p:nvSpPr>
+        <p:spPr>
+          <a:xfrm>
+            <a:off x="914400" y="3840480"/>
+            <a:ext cx="7315200" cy="914400"/>
+          </a:xfrm>
+          <a:prstGeom prst="rect">
+            <a:avLst/>
+          </a:prstGeom>
+          <a:noFill/>
+        </p:spPr>
+        <p:txBody>
+          <a:bodyPr wrap="none">
+            <a:spAutoFit/>
+          </a:bodyPr>
+          <a:lstStyle/>
+          <a:p>
+            <a:r>
+              <a:rPr sz="2000"/>
+              <a:t>{{bu}}</a:t>
             </a:r>
           </a:p>
         </p:txBody>
@@ -3996,7 +3955,7 @@
 </file>
 
 <file path=ppt/slides/slide9.xml><?xml version="1.0" encoding="utf-8"?>
-<p:sld xmlns:a="http://schemas.openxmlformats.org/drawingml/2006/main" xmlns:r="http://schemas.openxmlformats.org/officeDocument/2006/relationships" xmlns:p="http://schemas.openxmlformats.org/presentationml/2006/main">
+<p:sld xmlns:a="http://schemas.openxmlformats.org/drawingml/2006/main" xmlns:p="http://schemas.openxmlformats.org/presentationml/2006/main" xmlns:r="http://schemas.openxmlformats.org/officeDocument/2006/relationships">
   <p:cSld>
     <p:spTree>
       <p:nvGrpSpPr>
@@ -4004,24 +3963,17 @@
         <p:cNvGrpSpPr/>
         <p:nvPr/>
       </p:nvGrpSpPr>
-      <p:grpSpPr>
-        <a:xfrm>
-          <a:off x="0" y="0"/>
-          <a:ext cx="0" cy="0"/>
-          <a:chOff x="0" y="0"/>
-          <a:chExt cx="0" cy="0"/>
-        </a:xfrm>
-      </p:grpSpPr>
-      <p:sp>
-        <p:nvSpPr>
-          <p:cNvPr id="2" name="NAME"/>
+      <p:grpSpPr/>
+      <p:sp>
+        <p:nvSpPr>
+          <p:cNvPr id="2" name="TextBox 1"/>
           <p:cNvSpPr txBox="1"/>
           <p:nvPr/>
         </p:nvSpPr>
         <p:spPr>
           <a:xfrm>
-            <a:off x="914400" y="1828800"/>
-            <a:ext cx="7315200" cy="914400"/>
+            <a:off x="914400" y="2286000"/>
+            <a:ext cx="7315200" cy="1371600"/>
           </a:xfrm>
           <a:prstGeom prst="rect">
             <a:avLst/>
@@ -4035,37 +3987,8 @@
           <a:lstStyle/>
           <a:p>
             <a:r>
-              <a:rPr sz="3200"/>
-              <a:t>{{name}}</a:t>
-            </a:r>
-          </a:p>
-        </p:txBody>
-      </p:sp>
-      <p:sp>
-        <p:nvSpPr>
-          <p:cNvPr id="3" name="TITLE"/>
-          <p:cNvSpPr txBox="1"/>
-          <p:nvPr/>
-        </p:nvSpPr>
-        <p:spPr>
-          <a:xfrm>
-            <a:off x="914400" y="2926080"/>
-            <a:ext cx="7315200" cy="914400"/>
-          </a:xfrm>
-          <a:prstGeom prst="rect">
-            <a:avLst/>
-          </a:prstGeom>
-          <a:noFill/>
-        </p:spPr>
-        <p:txBody>
-          <a:bodyPr wrap="none">
-            <a:spAutoFit/>
-          </a:bodyPr>
-          <a:lstStyle/>
-          <a:p>
-            <a:r>
-              <a:rPr sz="2400"/>
-              <a:t>{{title}}</a:t>
+              <a:rPr sz="4000"/>
+              <a:t>F grade attendees</a:t>
             </a:r>
           </a:p>
         </p:txBody>

</xml_diff>